<commit_message>
working on the presentation
</commit_message>
<xml_diff>
--- a/Documents/Presentation/Capstone Project Presentation.pptx
+++ b/Documents/Presentation/Capstone Project Presentation.pptx
@@ -11893,7 +11893,27 @@
                 <a:latin typeface="Candara" panose="020E0502030303020204" pitchFamily="34" charset="0"/>
                 <a:ea typeface="Cambria Math" panose="02040503050406030204" pitchFamily="18" charset="0"/>
               </a:rPr>
-              <a:t>C#, ASP.net core, Restful </a:t>
+              <a:t>C#, ASP.NET Core, </a:t>
+            </a:r>
+            <a:r>
+              <a:rPr lang="en-US" sz="1400" b="1" dirty="0" err="1">
+                <a:solidFill>
+                  <a:srgbClr val="009A72"/>
+                </a:solidFill>
+                <a:latin typeface="Candara" panose="020E0502030303020204" pitchFamily="34" charset="0"/>
+                <a:ea typeface="Cambria Math" panose="02040503050406030204" pitchFamily="18" charset="0"/>
+              </a:rPr>
+              <a:t>RESt</a:t>
+            </a:r>
+            <a:r>
+              <a:rPr lang="en-US" sz="1400" b="1" dirty="0">
+                <a:solidFill>
+                  <a:srgbClr val="009A72"/>
+                </a:solidFill>
+                <a:latin typeface="Candara" panose="020E0502030303020204" pitchFamily="34" charset="0"/>
+                <a:ea typeface="Cambria Math" panose="02040503050406030204" pitchFamily="18" charset="0"/>
+              </a:rPr>
+              <a:t> </a:t>
             </a:r>
             <a:r>
               <a:rPr lang="en-US" sz="1400" dirty="0">
@@ -14085,52 +14105,9 @@
                 <a:ea typeface="Calibri" pitchFamily="34" charset="-122"/>
                 <a:cs typeface="Calibri" pitchFamily="34" charset="-120"/>
               </a:rPr>
-              <a:t>Engineering Decision Made To Handle specific Technical problems.</a:t>
+              <a:t>Engineering decisions that address specific technical challenges.</a:t>
             </a:r>
             <a:endParaRPr lang="en-US" sz="1600" dirty="0">
-              <a:solidFill>
-                <a:prstClr val="black"/>
-              </a:solidFill>
-              <a:latin typeface="Candara" panose="020E0502030303020204" pitchFamily="34" charset="0"/>
-            </a:endParaRPr>
-          </a:p>
-        </p:txBody>
-      </p:sp>
-      <p:sp>
-        <p:nvSpPr>
-          <p:cNvPr id="4" name="Shape 2"/>
-          <p:cNvSpPr/>
-          <p:nvPr/>
-        </p:nvSpPr>
-        <p:spPr>
-          <a:xfrm>
-            <a:off x="609441" y="1585440"/>
-            <a:ext cx="5399649" cy="2303688"/>
-          </a:xfrm>
-          <a:prstGeom prst="rect">
-            <a:avLst/>
-          </a:prstGeom>
-          <a:solidFill>
-            <a:srgbClr val="0D2318"/>
-          </a:solidFill>
-          <a:ln w="9525">
-            <a:noFill/>
-            <a:prstDash val="solid"/>
-          </a:ln>
-          <a:effectLst>
-            <a:outerShdw blurRad="76200" dist="25400" dir="8100000" algn="bl" rotWithShape="0">
-              <a:srgbClr val="000000">
-                <a:alpha val="25000"/>
-              </a:srgbClr>
-            </a:outerShdw>
-          </a:effectLst>
-        </p:spPr>
-        <p:txBody>
-          <a:bodyPr/>
-          <a:lstStyle/>
-          <a:p>
-            <a:pPr defTabSz="1218895"/>
-            <a:endParaRPr lang="en-US" sz="1600">
               <a:solidFill>
                 <a:prstClr val="black"/>
               </a:solidFill>
@@ -14175,54 +14152,6 @@
           </a:p>
         </p:txBody>
       </p:sp>
-      <p:sp>
-        <p:nvSpPr>
-          <p:cNvPr id="6" name="Text 4"/>
-          <p:cNvSpPr/>
-          <p:nvPr/>
-        </p:nvSpPr>
-        <p:spPr>
-          <a:xfrm>
-            <a:off x="5399649" y="1707329"/>
-            <a:ext cx="609441" cy="390042"/>
-          </a:xfrm>
-          <a:prstGeom prst="rect">
-            <a:avLst/>
-          </a:prstGeom>
-          <a:solidFill>
-            <a:srgbClr val="0D2318"/>
-          </a:solidFill>
-          <a:ln>
-            <a:noFill/>
-          </a:ln>
-        </p:spPr>
-        <p:txBody>
-          <a:bodyPr wrap="square" lIns="0" tIns="0" rIns="0" bIns="0" rtlCol="0" anchor="ctr"/>
-          <a:lstStyle/>
-          <a:p>
-            <a:pPr algn="r" defTabSz="1218895"/>
-            <a:r>
-              <a:rPr lang="en-US" sz="1600" b="1" dirty="0">
-                <a:solidFill>
-                  <a:srgbClr val="3DDB61">
-                    <a:alpha val="40000"/>
-                  </a:srgbClr>
-                </a:solidFill>
-                <a:latin typeface="Candara" panose="020E0502030303020204" pitchFamily="34" charset="0"/>
-                <a:ea typeface="Calibri" pitchFamily="34" charset="-122"/>
-                <a:cs typeface="Calibri" pitchFamily="34" charset="-120"/>
-              </a:rPr>
-              <a:t>01</a:t>
-            </a:r>
-            <a:endParaRPr lang="en-US" sz="1600" dirty="0">
-              <a:solidFill>
-                <a:prstClr val="black"/>
-              </a:solidFill>
-              <a:latin typeface="Candara" panose="020E0502030303020204" pitchFamily="34" charset="0"/>
-            </a:endParaRPr>
-          </a:p>
-        </p:txBody>
-      </p:sp>
       <p:pic>
         <p:nvPicPr>
           <p:cNvPr id="7" name="Image 0" descr="preencoded.png"/>
@@ -14342,7 +14271,7 @@
         <p:spPr>
           <a:xfrm>
             <a:off x="828839" y="2353336"/>
-            <a:ext cx="5107118" cy="792274"/>
+            <a:ext cx="4974802" cy="428349"/>
           </a:xfrm>
           <a:prstGeom prst="rect">
             <a:avLst/>
@@ -14371,7 +14300,7 @@
               <a:t>Challenge  </a:t>
             </a:r>
             <a:r>
-              <a:rPr lang="en-US" sz="1600" dirty="0">
+              <a:rPr lang="en-US" sz="1600" b="1" dirty="0">
                 <a:solidFill>
                   <a:srgbClr val="A8C4B0"/>
                 </a:solidFill>
@@ -14379,7 +14308,18 @@
                 <a:ea typeface="Calibri" pitchFamily="34" charset="-122"/>
                 <a:cs typeface="Calibri" pitchFamily="34" charset="-120"/>
               </a:rPr>
-              <a:t>Keeping multiple browser clients in sync with live sensor data without polling or page refreshes.</a:t>
+              <a:t>Multi-client live sync without polling</a:t>
+            </a:r>
+            <a:r>
+              <a:rPr lang="en-US" sz="1600" dirty="0">
+                <a:solidFill>
+                  <a:srgbClr val="A8C4B0"/>
+                </a:solidFill>
+                <a:latin typeface="Candara" panose="020E0502030303020204" pitchFamily="34" charset="0"/>
+                <a:ea typeface="Calibri" pitchFamily="34" charset="-122"/>
+                <a:cs typeface="Calibri" pitchFamily="34" charset="-120"/>
+              </a:rPr>
+              <a:t>.</a:t>
             </a:r>
             <a:endParaRPr lang="en-US" sz="1600" dirty="0">
               <a:solidFill>
@@ -14398,8 +14338,8 @@
         </p:nvSpPr>
         <p:spPr>
           <a:xfrm>
-            <a:off x="828839" y="3218743"/>
-            <a:ext cx="5107118" cy="914162"/>
+            <a:off x="828838" y="2752058"/>
+            <a:ext cx="5326517" cy="463175"/>
           </a:xfrm>
           <a:prstGeom prst="rect">
             <a:avLst/>
@@ -14428,7 +14368,7 @@
               <a:t>Solution  </a:t>
             </a:r>
             <a:r>
-              <a:rPr lang="en-US" sz="1600" dirty="0">
+              <a:rPr lang="en-US" sz="1600" dirty="0" err="1">
                 <a:solidFill>
                   <a:srgbClr val="C8DDD0"/>
                 </a:solidFill>
@@ -14436,52 +14376,20 @@
                 <a:ea typeface="Calibri" pitchFamily="34" charset="-122"/>
                 <a:cs typeface="Calibri" pitchFamily="34" charset="-120"/>
               </a:rPr>
-              <a:t>SignalR WebSocket hub with device-group subscriptions. Server pushes to groups on data receipt.</a:t>
+              <a:t>SignalR</a:t>
+            </a:r>
+            <a:r>
+              <a:rPr lang="en-US" sz="1600" dirty="0">
+                <a:solidFill>
+                  <a:srgbClr val="C8DDD0"/>
+                </a:solidFill>
+                <a:latin typeface="Candara" panose="020E0502030303020204" pitchFamily="34" charset="0"/>
+                <a:ea typeface="Calibri" pitchFamily="34" charset="-122"/>
+                <a:cs typeface="Calibri" pitchFamily="34" charset="-120"/>
+              </a:rPr>
+              <a:t> groups; push after save.</a:t>
             </a:r>
             <a:endParaRPr lang="en-US" sz="1600" dirty="0">
-              <a:solidFill>
-                <a:prstClr val="black"/>
-              </a:solidFill>
-              <a:latin typeface="Candara" panose="020E0502030303020204" pitchFamily="34" charset="0"/>
-            </a:endParaRPr>
-          </a:p>
-        </p:txBody>
-      </p:sp>
-      <p:sp>
-        <p:nvSpPr>
-          <p:cNvPr id="12" name="Shape 9"/>
-          <p:cNvSpPr/>
-          <p:nvPr/>
-        </p:nvSpPr>
-        <p:spPr>
-          <a:xfrm>
-            <a:off x="6399133" y="1585440"/>
-            <a:ext cx="5424027" cy="2303688"/>
-          </a:xfrm>
-          <a:prstGeom prst="rect">
-            <a:avLst/>
-          </a:prstGeom>
-          <a:solidFill>
-            <a:srgbClr val="0D2318"/>
-          </a:solidFill>
-          <a:ln w="9525">
-            <a:noFill/>
-            <a:prstDash val="solid"/>
-          </a:ln>
-          <a:effectLst>
-            <a:outerShdw blurRad="76200" dist="25400" dir="8100000" algn="bl" rotWithShape="0">
-              <a:srgbClr val="000000">
-                <a:alpha val="25000"/>
-              </a:srgbClr>
-            </a:outerShdw>
-          </a:effectLst>
-        </p:spPr>
-        <p:txBody>
-          <a:bodyPr/>
-          <a:lstStyle/>
-          <a:p>
-            <a:pPr defTabSz="1218895"/>
-            <a:endParaRPr lang="en-US" sz="1600">
               <a:solidFill>
                 <a:prstClr val="black"/>
               </a:solidFill>
@@ -14526,54 +14434,6 @@
           </a:p>
         </p:txBody>
       </p:sp>
-      <p:sp>
-        <p:nvSpPr>
-          <p:cNvPr id="14" name="Text 11"/>
-          <p:cNvSpPr/>
-          <p:nvPr/>
-        </p:nvSpPr>
-        <p:spPr>
-          <a:xfrm>
-            <a:off x="11189341" y="1707329"/>
-            <a:ext cx="609441" cy="390042"/>
-          </a:xfrm>
-          <a:prstGeom prst="rect">
-            <a:avLst/>
-          </a:prstGeom>
-          <a:solidFill>
-            <a:srgbClr val="0D2318"/>
-          </a:solidFill>
-          <a:ln>
-            <a:noFill/>
-          </a:ln>
-        </p:spPr>
-        <p:txBody>
-          <a:bodyPr wrap="square" lIns="0" tIns="0" rIns="0" bIns="0" rtlCol="0" anchor="ctr"/>
-          <a:lstStyle/>
-          <a:p>
-            <a:pPr algn="r" defTabSz="1218895"/>
-            <a:r>
-              <a:rPr lang="en-US" sz="1600" b="1" dirty="0">
-                <a:solidFill>
-                  <a:srgbClr val="00BCD4">
-                    <a:alpha val="40000"/>
-                  </a:srgbClr>
-                </a:solidFill>
-                <a:latin typeface="Candara" panose="020E0502030303020204" pitchFamily="34" charset="0"/>
-                <a:ea typeface="Calibri" pitchFamily="34" charset="-122"/>
-                <a:cs typeface="Calibri" pitchFamily="34" charset="-120"/>
-              </a:rPr>
-              <a:t>02</a:t>
-            </a:r>
-            <a:endParaRPr lang="en-US" sz="1600" dirty="0">
-              <a:solidFill>
-                <a:prstClr val="black"/>
-              </a:solidFill>
-              <a:latin typeface="Candara" panose="020E0502030303020204" pitchFamily="34" charset="0"/>
-            </a:endParaRPr>
-          </a:p>
-        </p:txBody>
-      </p:sp>
       <p:pic>
         <p:nvPicPr>
           <p:cNvPr id="15" name="Image 1" descr="preencoded.png"/>
@@ -14693,7 +14553,7 @@
         <p:spPr>
           <a:xfrm>
             <a:off x="6618531" y="2353336"/>
-            <a:ext cx="5107118" cy="792274"/>
+            <a:ext cx="5107118" cy="479718"/>
           </a:xfrm>
           <a:prstGeom prst="rect">
             <a:avLst/>
@@ -14722,7 +14582,7 @@
               <a:t>Challenge  </a:t>
             </a:r>
             <a:r>
-              <a:rPr lang="en-US" sz="1600" dirty="0">
+              <a:rPr lang="en-US" sz="1600" b="1" dirty="0">
                 <a:solidFill>
                   <a:srgbClr val="A8C4B0"/>
                 </a:solidFill>
@@ -14730,7 +14590,18 @@
                 <a:ea typeface="Calibri" pitchFamily="34" charset="-122"/>
                 <a:cs typeface="Calibri" pitchFamily="34" charset="-120"/>
               </a:rPr>
-              <a:t>SensorReadings grows to thousands of rows per device per day. Queries must stay fast.</a:t>
+              <a:t>Fast queries on growing reading table</a:t>
+            </a:r>
+            <a:r>
+              <a:rPr lang="en-US" sz="1600" dirty="0">
+                <a:solidFill>
+                  <a:srgbClr val="A8C4B0"/>
+                </a:solidFill>
+                <a:latin typeface="Candara" panose="020E0502030303020204" pitchFamily="34" charset="0"/>
+                <a:ea typeface="Calibri" pitchFamily="34" charset="-122"/>
+                <a:cs typeface="Calibri" pitchFamily="34" charset="-120"/>
+              </a:rPr>
+              <a:t>.</a:t>
             </a:r>
             <a:endParaRPr lang="en-US" sz="1600" dirty="0">
               <a:solidFill>
@@ -14749,8 +14620,8 @@
         </p:nvSpPr>
         <p:spPr>
           <a:xfrm>
-            <a:off x="6618531" y="3218743"/>
-            <a:ext cx="5107118" cy="914162"/>
+            <a:off x="6618531" y="2734588"/>
+            <a:ext cx="5107118" cy="463175"/>
           </a:xfrm>
           <a:prstGeom prst="rect">
             <a:avLst/>
@@ -14787,7 +14658,7 @@
                 <a:ea typeface="Calibri" pitchFamily="34" charset="-122"/>
                 <a:cs typeface="Calibri" pitchFamily="34" charset="-120"/>
               </a:rPr>
-              <a:t>BIGINT key, composite indexes on (Timestamp, DeviceId), 30-day detail + aggregated archive policy. Consider to work on MongoDB instead of MSSQL</a:t>
+              <a:t>BIGINT key, indexes, paged date filters</a:t>
             </a:r>
             <a:endParaRPr lang="en-US" sz="1600" dirty="0">
               <a:solidFill>
@@ -14798,16 +14669,24 @@
           </a:p>
         </p:txBody>
       </p:sp>
-      <p:sp>
-        <p:nvSpPr>
-          <p:cNvPr id="20" name="Shape 16"/>
-          <p:cNvSpPr/>
-          <p:nvPr/>
-        </p:nvSpPr>
-        <p:spPr>
-          <a:xfrm>
-            <a:off x="609441" y="4037135"/>
-            <a:ext cx="5545915" cy="2657164"/>
+      <p:pic>
+        <p:nvPicPr>
+          <p:cNvPr id="23" name="Image 2" descr="preencoded.png"/>
+          <p:cNvPicPr>
+            <a:picLocks noChangeAspect="1"/>
+          </p:cNvPicPr>
+          <p:nvPr/>
+        </p:nvPicPr>
+        <p:blipFill>
+          <a:blip r:embed="rId5"/>
+          <a:stretch>
+            <a:fillRect/>
+          </a:stretch>
+        </p:blipFill>
+        <p:spPr>
+          <a:xfrm>
+            <a:off x="828839" y="4301088"/>
+            <a:ext cx="438798" cy="438798"/>
           </a:xfrm>
           <a:prstGeom prst="rect">
             <a:avLst/>
@@ -14815,17 +14694,76 @@
           <a:solidFill>
             <a:srgbClr val="0D2318"/>
           </a:solidFill>
+          <a:ln>
+            <a:noFill/>
+          </a:ln>
+        </p:spPr>
+      </p:pic>
+      <p:sp>
+        <p:nvSpPr>
+          <p:cNvPr id="24" name="Text 19"/>
+          <p:cNvSpPr/>
+          <p:nvPr/>
+        </p:nvSpPr>
+        <p:spPr>
+          <a:xfrm>
+            <a:off x="1389525" y="4276711"/>
+            <a:ext cx="4546432" cy="463175"/>
+          </a:xfrm>
+          <a:prstGeom prst="rect">
+            <a:avLst/>
+          </a:prstGeom>
+          <a:solidFill>
+            <a:srgbClr val="0D2318"/>
+          </a:solidFill>
+          <a:ln>
+            <a:noFill/>
+          </a:ln>
+        </p:spPr>
+        <p:txBody>
+          <a:bodyPr wrap="square" lIns="0" tIns="0" rIns="0" bIns="0" rtlCol="0" anchor="ctr"/>
+          <a:lstStyle/>
+          <a:p>
+            <a:pPr defTabSz="1218895"/>
+            <a:r>
+              <a:rPr lang="en-US" sz="1600" b="1" dirty="0">
+                <a:solidFill>
+                  <a:srgbClr val="FFFFFF"/>
+                </a:solidFill>
+                <a:latin typeface="Candara" panose="020E0502030303020204" pitchFamily="34" charset="0"/>
+                <a:ea typeface="Calibri" pitchFamily="34" charset="-122"/>
+                <a:cs typeface="Calibri" pitchFamily="34" charset="-120"/>
+              </a:rPr>
+              <a:t>Cross-Layer Data Flow Design</a:t>
+            </a:r>
+            <a:endParaRPr lang="en-US" sz="1600" dirty="0">
+              <a:solidFill>
+                <a:prstClr val="black"/>
+              </a:solidFill>
+              <a:latin typeface="Candara" panose="020E0502030303020204" pitchFamily="34" charset="0"/>
+            </a:endParaRPr>
+          </a:p>
+        </p:txBody>
+      </p:sp>
+      <p:sp>
+        <p:nvSpPr>
+          <p:cNvPr id="25" name="Shape 20"/>
+          <p:cNvSpPr/>
+          <p:nvPr/>
+        </p:nvSpPr>
+        <p:spPr>
+          <a:xfrm>
+            <a:off x="828839" y="4813019"/>
+            <a:ext cx="5107118" cy="0"/>
+          </a:xfrm>
+          <a:prstGeom prst="line">
+            <a:avLst/>
+          </a:prstGeom>
+          <a:noFill/>
           <a:ln w="9525">
             <a:noFill/>
             <a:prstDash val="solid"/>
           </a:ln>
-          <a:effectLst>
-            <a:outerShdw blurRad="76200" dist="25400" dir="8100000" algn="bl" rotWithShape="0">
-              <a:srgbClr val="000000">
-                <a:alpha val="25000"/>
-              </a:srgbClr>
-            </a:outerShdw>
-          </a:effectLst>
         </p:spPr>
         <p:txBody>
           <a:bodyPr/>
@@ -14843,13 +14781,149 @@
       </p:sp>
       <p:sp>
         <p:nvSpPr>
-          <p:cNvPr id="21" name="Shape 17"/>
-          <p:cNvSpPr/>
-          <p:nvPr/>
-        </p:nvSpPr>
-        <p:spPr>
-          <a:xfrm>
-            <a:off x="609441" y="4037135"/>
+          <p:cNvPr id="26" name="Text 21"/>
+          <p:cNvSpPr/>
+          <p:nvPr/>
+        </p:nvSpPr>
+        <p:spPr>
+          <a:xfrm>
+            <a:off x="828839" y="4898341"/>
+            <a:ext cx="5107118" cy="345640"/>
+          </a:xfrm>
+          <a:prstGeom prst="rect">
+            <a:avLst/>
+          </a:prstGeom>
+          <a:solidFill>
+            <a:srgbClr val="0D2318"/>
+          </a:solidFill>
+          <a:ln>
+            <a:noFill/>
+          </a:ln>
+        </p:spPr>
+        <p:txBody>
+          <a:bodyPr wrap="square" lIns="0" tIns="0" rIns="0" bIns="0" rtlCol="0" anchor="t"/>
+          <a:lstStyle/>
+          <a:p>
+            <a:pPr defTabSz="1218895"/>
+            <a:r>
+              <a:rPr lang="en-US" sz="1600" b="1" dirty="0">
+                <a:solidFill>
+                  <a:srgbClr val="FF8A65"/>
+                </a:solidFill>
+                <a:latin typeface="Candara" panose="020E0502030303020204" pitchFamily="34" charset="0"/>
+                <a:ea typeface="Calibri" pitchFamily="34" charset="-122"/>
+                <a:cs typeface="Calibri" pitchFamily="34" charset="-120"/>
+              </a:rPr>
+              <a:t>Challenge  </a:t>
+            </a:r>
+            <a:r>
+              <a:rPr lang="en-US" sz="1600" b="1" dirty="0">
+                <a:solidFill>
+                  <a:srgbClr val="A8C4B0"/>
+                </a:solidFill>
+                <a:latin typeface="Candara" panose="020E0502030303020204" pitchFamily="34" charset="0"/>
+                <a:ea typeface="Calibri" pitchFamily="34" charset="-122"/>
+                <a:cs typeface="Calibri" pitchFamily="34" charset="-120"/>
+              </a:rPr>
+              <a:t>Clean path from device to chart</a:t>
+            </a:r>
+            <a:endParaRPr lang="en-US" sz="1600" dirty="0">
+              <a:solidFill>
+                <a:prstClr val="black"/>
+              </a:solidFill>
+              <a:latin typeface="Candara" panose="020E0502030303020204" pitchFamily="34" charset="0"/>
+            </a:endParaRPr>
+          </a:p>
+        </p:txBody>
+      </p:sp>
+      <p:sp>
+        <p:nvSpPr>
+          <p:cNvPr id="27" name="Text 22"/>
+          <p:cNvSpPr/>
+          <p:nvPr/>
+        </p:nvSpPr>
+        <p:spPr>
+          <a:xfrm>
+            <a:off x="828839" y="5271339"/>
+            <a:ext cx="4498941" cy="413122"/>
+          </a:xfrm>
+          <a:prstGeom prst="rect">
+            <a:avLst/>
+          </a:prstGeom>
+          <a:solidFill>
+            <a:srgbClr val="0D2318"/>
+          </a:solidFill>
+          <a:ln>
+            <a:noFill/>
+          </a:ln>
+        </p:spPr>
+        <p:txBody>
+          <a:bodyPr wrap="square" lIns="0" tIns="0" rIns="0" bIns="0" rtlCol="0" anchor="t"/>
+          <a:lstStyle/>
+          <a:p>
+            <a:pPr defTabSz="1218895"/>
+            <a:r>
+              <a:rPr lang="en-US" sz="1600" b="1" dirty="0">
+                <a:solidFill>
+                  <a:srgbClr val="F59E0B"/>
+                </a:solidFill>
+                <a:latin typeface="Candara" panose="020E0502030303020204" pitchFamily="34" charset="0"/>
+                <a:ea typeface="Calibri" pitchFamily="34" charset="-122"/>
+                <a:cs typeface="Calibri" pitchFamily="34" charset="-120"/>
+              </a:rPr>
+              <a:t>Solution  </a:t>
+            </a:r>
+            <a:r>
+              <a:rPr lang="en-US" sz="1600" b="1" dirty="0">
+                <a:solidFill>
+                  <a:srgbClr val="C8DDD0"/>
+                </a:solidFill>
+                <a:latin typeface="Candara" panose="020E0502030303020204" pitchFamily="34" charset="0"/>
+                <a:ea typeface="Calibri" pitchFamily="34" charset="-122"/>
+                <a:cs typeface="Calibri" pitchFamily="34" charset="-120"/>
+              </a:rPr>
+              <a:t>MQTT → API → DB → </a:t>
+            </a:r>
+            <a:r>
+              <a:rPr lang="en-US" sz="1600" b="1" dirty="0" err="1">
+                <a:solidFill>
+                  <a:srgbClr val="C8DDD0"/>
+                </a:solidFill>
+                <a:latin typeface="Candara" panose="020E0502030303020204" pitchFamily="34" charset="0"/>
+                <a:ea typeface="Calibri" pitchFamily="34" charset="-122"/>
+                <a:cs typeface="Calibri" pitchFamily="34" charset="-120"/>
+              </a:rPr>
+              <a:t>SignalR</a:t>
+            </a:r>
+            <a:r>
+              <a:rPr lang="en-US" sz="1600" b="1" dirty="0">
+                <a:solidFill>
+                  <a:srgbClr val="C8DDD0"/>
+                </a:solidFill>
+                <a:latin typeface="Candara" panose="020E0502030303020204" pitchFamily="34" charset="0"/>
+                <a:ea typeface="Calibri" pitchFamily="34" charset="-122"/>
+                <a:cs typeface="Calibri" pitchFamily="34" charset="-120"/>
+              </a:rPr>
+              <a:t> → React</a:t>
+            </a:r>
+            <a:endParaRPr lang="en-US" sz="1600" dirty="0">
+              <a:solidFill>
+                <a:prstClr val="black"/>
+              </a:solidFill>
+              <a:latin typeface="Candara" panose="020E0502030303020204" pitchFamily="34" charset="0"/>
+            </a:endParaRPr>
+          </a:p>
+        </p:txBody>
+      </p:sp>
+      <p:sp>
+        <p:nvSpPr>
+          <p:cNvPr id="29" name="Shape 24"/>
+          <p:cNvSpPr/>
+          <p:nvPr/>
+        </p:nvSpPr>
+        <p:spPr>
+          <a:xfrm>
+            <a:off x="6399133" y="4005792"/>
             <a:ext cx="5545915" cy="60944"/>
           </a:xfrm>
           <a:prstGeom prst="rect">
@@ -14877,405 +14951,6 @@
           </a:p>
         </p:txBody>
       </p:sp>
-      <p:sp>
-        <p:nvSpPr>
-          <p:cNvPr id="22" name="Text 18"/>
-          <p:cNvSpPr/>
-          <p:nvPr/>
-        </p:nvSpPr>
-        <p:spPr>
-          <a:xfrm>
-            <a:off x="5399649" y="4159023"/>
-            <a:ext cx="609441" cy="390042"/>
-          </a:xfrm>
-          <a:prstGeom prst="rect">
-            <a:avLst/>
-          </a:prstGeom>
-          <a:solidFill>
-            <a:srgbClr val="0D2318"/>
-          </a:solidFill>
-          <a:ln>
-            <a:noFill/>
-          </a:ln>
-        </p:spPr>
-        <p:txBody>
-          <a:bodyPr wrap="square" lIns="0" tIns="0" rIns="0" bIns="0" rtlCol="0" anchor="ctr"/>
-          <a:lstStyle/>
-          <a:p>
-            <a:pPr algn="r" defTabSz="1218895"/>
-            <a:r>
-              <a:rPr lang="en-US" sz="1600" b="1" dirty="0">
-                <a:solidFill>
-                  <a:srgbClr val="F59E0B">
-                    <a:alpha val="40000"/>
-                  </a:srgbClr>
-                </a:solidFill>
-                <a:latin typeface="Candara" panose="020E0502030303020204" pitchFamily="34" charset="0"/>
-                <a:ea typeface="Calibri" pitchFamily="34" charset="-122"/>
-                <a:cs typeface="Calibri" pitchFamily="34" charset="-120"/>
-              </a:rPr>
-              <a:t>03</a:t>
-            </a:r>
-            <a:endParaRPr lang="en-US" sz="1600" dirty="0">
-              <a:solidFill>
-                <a:prstClr val="black"/>
-              </a:solidFill>
-              <a:latin typeface="Candara" panose="020E0502030303020204" pitchFamily="34" charset="0"/>
-            </a:endParaRPr>
-          </a:p>
-        </p:txBody>
-      </p:sp>
-      <p:pic>
-        <p:nvPicPr>
-          <p:cNvPr id="23" name="Image 2" descr="preencoded.png"/>
-          <p:cNvPicPr>
-            <a:picLocks noChangeAspect="1"/>
-          </p:cNvPicPr>
-          <p:nvPr/>
-        </p:nvPicPr>
-        <p:blipFill>
-          <a:blip r:embed="rId5"/>
-          <a:stretch>
-            <a:fillRect/>
-          </a:stretch>
-        </p:blipFill>
-        <p:spPr>
-          <a:xfrm>
-            <a:off x="828839" y="4207778"/>
-            <a:ext cx="438798" cy="438798"/>
-          </a:xfrm>
-          <a:prstGeom prst="rect">
-            <a:avLst/>
-          </a:prstGeom>
-          <a:solidFill>
-            <a:srgbClr val="0D2318"/>
-          </a:solidFill>
-          <a:ln>
-            <a:noFill/>
-          </a:ln>
-        </p:spPr>
-      </p:pic>
-      <p:sp>
-        <p:nvSpPr>
-          <p:cNvPr id="24" name="Text 19"/>
-          <p:cNvSpPr/>
-          <p:nvPr/>
-        </p:nvSpPr>
-        <p:spPr>
-          <a:xfrm>
-            <a:off x="1389525" y="4183401"/>
-            <a:ext cx="4546432" cy="463175"/>
-          </a:xfrm>
-          <a:prstGeom prst="rect">
-            <a:avLst/>
-          </a:prstGeom>
-          <a:solidFill>
-            <a:srgbClr val="0D2318"/>
-          </a:solidFill>
-          <a:ln>
-            <a:noFill/>
-          </a:ln>
-        </p:spPr>
-        <p:txBody>
-          <a:bodyPr wrap="square" lIns="0" tIns="0" rIns="0" bIns="0" rtlCol="0" anchor="ctr"/>
-          <a:lstStyle/>
-          <a:p>
-            <a:pPr defTabSz="1218895"/>
-            <a:r>
-              <a:rPr lang="en-US" sz="1600" b="1" dirty="0">
-                <a:solidFill>
-                  <a:srgbClr val="FFFFFF"/>
-                </a:solidFill>
-                <a:latin typeface="Candara" panose="020E0502030303020204" pitchFamily="34" charset="0"/>
-                <a:ea typeface="Calibri" pitchFamily="34" charset="-122"/>
-                <a:cs typeface="Calibri" pitchFamily="34" charset="-120"/>
-              </a:rPr>
-              <a:t>Cross-Layer Data Flow Design</a:t>
-            </a:r>
-            <a:endParaRPr lang="en-US" sz="1600" dirty="0">
-              <a:solidFill>
-                <a:prstClr val="black"/>
-              </a:solidFill>
-              <a:latin typeface="Candara" panose="020E0502030303020204" pitchFamily="34" charset="0"/>
-            </a:endParaRPr>
-          </a:p>
-        </p:txBody>
-      </p:sp>
-      <p:sp>
-        <p:nvSpPr>
-          <p:cNvPr id="25" name="Shape 20"/>
-          <p:cNvSpPr/>
-          <p:nvPr/>
-        </p:nvSpPr>
-        <p:spPr>
-          <a:xfrm>
-            <a:off x="828839" y="4719709"/>
-            <a:ext cx="5107118" cy="0"/>
-          </a:xfrm>
-          <a:prstGeom prst="line">
-            <a:avLst/>
-          </a:prstGeom>
-          <a:noFill/>
-          <a:ln w="9525">
-            <a:noFill/>
-            <a:prstDash val="solid"/>
-          </a:ln>
-        </p:spPr>
-        <p:txBody>
-          <a:bodyPr/>
-          <a:lstStyle/>
-          <a:p>
-            <a:pPr defTabSz="1218895"/>
-            <a:endParaRPr lang="en-US" sz="1600">
-              <a:solidFill>
-                <a:prstClr val="black"/>
-              </a:solidFill>
-              <a:latin typeface="Candara" panose="020E0502030303020204" pitchFamily="34" charset="0"/>
-            </a:endParaRPr>
-          </a:p>
-        </p:txBody>
-      </p:sp>
-      <p:sp>
-        <p:nvSpPr>
-          <p:cNvPr id="26" name="Text 21"/>
-          <p:cNvSpPr/>
-          <p:nvPr/>
-        </p:nvSpPr>
-        <p:spPr>
-          <a:xfrm>
-            <a:off x="828839" y="4805031"/>
-            <a:ext cx="5107118" cy="792274"/>
-          </a:xfrm>
-          <a:prstGeom prst="rect">
-            <a:avLst/>
-          </a:prstGeom>
-          <a:solidFill>
-            <a:srgbClr val="0D2318"/>
-          </a:solidFill>
-          <a:ln>
-            <a:noFill/>
-          </a:ln>
-        </p:spPr>
-        <p:txBody>
-          <a:bodyPr wrap="square" lIns="0" tIns="0" rIns="0" bIns="0" rtlCol="0" anchor="t"/>
-          <a:lstStyle/>
-          <a:p>
-            <a:pPr defTabSz="1218895"/>
-            <a:r>
-              <a:rPr lang="en-US" sz="1600" b="1" dirty="0">
-                <a:solidFill>
-                  <a:srgbClr val="FF8A65"/>
-                </a:solidFill>
-                <a:latin typeface="Candara" panose="020E0502030303020204" pitchFamily="34" charset="0"/>
-                <a:ea typeface="Calibri" pitchFamily="34" charset="-122"/>
-                <a:cs typeface="Calibri" pitchFamily="34" charset="-120"/>
-              </a:rPr>
-              <a:t>Challenge  </a:t>
-            </a:r>
-            <a:r>
-              <a:rPr lang="en-US" sz="1600" dirty="0">
-                <a:solidFill>
-                  <a:srgbClr val="A8C4B0"/>
-                </a:solidFill>
-                <a:latin typeface="Candara" panose="020E0502030303020204" pitchFamily="34" charset="0"/>
-                <a:ea typeface="Calibri" pitchFamily="34" charset="-122"/>
-                <a:cs typeface="Calibri" pitchFamily="34" charset="-120"/>
-              </a:rPr>
-              <a:t>One sensor reading must flow cleanly: edge device → API → DB → SignalR → React chart.</a:t>
-            </a:r>
-            <a:endParaRPr lang="en-US" sz="1600" dirty="0">
-              <a:solidFill>
-                <a:prstClr val="black"/>
-              </a:solidFill>
-              <a:latin typeface="Candara" panose="020E0502030303020204" pitchFamily="34" charset="0"/>
-            </a:endParaRPr>
-          </a:p>
-        </p:txBody>
-      </p:sp>
-      <p:sp>
-        <p:nvSpPr>
-          <p:cNvPr id="27" name="Text 22"/>
-          <p:cNvSpPr/>
-          <p:nvPr/>
-        </p:nvSpPr>
-        <p:spPr>
-          <a:xfrm>
-            <a:off x="828839" y="5670437"/>
-            <a:ext cx="5107118" cy="914162"/>
-          </a:xfrm>
-          <a:prstGeom prst="rect">
-            <a:avLst/>
-          </a:prstGeom>
-          <a:solidFill>
-            <a:srgbClr val="0D2318"/>
-          </a:solidFill>
-          <a:ln>
-            <a:noFill/>
-          </a:ln>
-        </p:spPr>
-        <p:txBody>
-          <a:bodyPr wrap="square" lIns="0" tIns="0" rIns="0" bIns="0" rtlCol="0" anchor="t"/>
-          <a:lstStyle/>
-          <a:p>
-            <a:pPr defTabSz="1218895"/>
-            <a:r>
-              <a:rPr lang="en-US" sz="1600" b="1" dirty="0">
-                <a:solidFill>
-                  <a:srgbClr val="F59E0B"/>
-                </a:solidFill>
-                <a:latin typeface="Candara" panose="020E0502030303020204" pitchFamily="34" charset="0"/>
-                <a:ea typeface="Calibri" pitchFamily="34" charset="-122"/>
-                <a:cs typeface="Calibri" pitchFamily="34" charset="-120"/>
-              </a:rPr>
-              <a:t>Solution  </a:t>
-            </a:r>
-            <a:r>
-              <a:rPr lang="en-US" sz="1600" dirty="0">
-                <a:solidFill>
-                  <a:srgbClr val="C8DDD0"/>
-                </a:solidFill>
-                <a:latin typeface="Candara" panose="020E0502030303020204" pitchFamily="34" charset="0"/>
-                <a:ea typeface="Calibri" pitchFamily="34" charset="-122"/>
-                <a:cs typeface="Calibri" pitchFamily="34" charset="-120"/>
-              </a:rPr>
-              <a:t>Layered architecture (Controller → Service → Repository → DB). SignalR notifies after DB write. DTOs decouple layers.</a:t>
-            </a:r>
-            <a:endParaRPr lang="en-US" sz="1600" dirty="0">
-              <a:solidFill>
-                <a:prstClr val="black"/>
-              </a:solidFill>
-              <a:latin typeface="Candara" panose="020E0502030303020204" pitchFamily="34" charset="0"/>
-            </a:endParaRPr>
-          </a:p>
-        </p:txBody>
-      </p:sp>
-      <p:sp>
-        <p:nvSpPr>
-          <p:cNvPr id="28" name="Shape 23"/>
-          <p:cNvSpPr/>
-          <p:nvPr/>
-        </p:nvSpPr>
-        <p:spPr>
-          <a:xfrm>
-            <a:off x="6399133" y="4005792"/>
-            <a:ext cx="5545915" cy="2657164"/>
-          </a:xfrm>
-          <a:prstGeom prst="rect">
-            <a:avLst/>
-          </a:prstGeom>
-          <a:solidFill>
-            <a:srgbClr val="0D2318"/>
-          </a:solidFill>
-          <a:ln w="9525">
-            <a:noFill/>
-            <a:prstDash val="solid"/>
-          </a:ln>
-          <a:effectLst>
-            <a:outerShdw blurRad="76200" dist="25400" dir="8100000" algn="bl" rotWithShape="0">
-              <a:srgbClr val="000000">
-                <a:alpha val="25000"/>
-              </a:srgbClr>
-            </a:outerShdw>
-          </a:effectLst>
-        </p:spPr>
-        <p:txBody>
-          <a:bodyPr/>
-          <a:lstStyle/>
-          <a:p>
-            <a:pPr defTabSz="1218895"/>
-            <a:endParaRPr lang="en-US" sz="1600">
-              <a:solidFill>
-                <a:prstClr val="black"/>
-              </a:solidFill>
-              <a:latin typeface="Candara" panose="020E0502030303020204" pitchFamily="34" charset="0"/>
-            </a:endParaRPr>
-          </a:p>
-        </p:txBody>
-      </p:sp>
-      <p:sp>
-        <p:nvSpPr>
-          <p:cNvPr id="29" name="Shape 24"/>
-          <p:cNvSpPr/>
-          <p:nvPr/>
-        </p:nvSpPr>
-        <p:spPr>
-          <a:xfrm>
-            <a:off x="6399133" y="4005792"/>
-            <a:ext cx="5545915" cy="60944"/>
-          </a:xfrm>
-          <a:prstGeom prst="rect">
-            <a:avLst/>
-          </a:prstGeom>
-          <a:solidFill>
-            <a:srgbClr val="0D2318"/>
-          </a:solidFill>
-          <a:ln w="12700">
-            <a:noFill/>
-            <a:prstDash val="solid"/>
-          </a:ln>
-        </p:spPr>
-        <p:txBody>
-          <a:bodyPr/>
-          <a:lstStyle/>
-          <a:p>
-            <a:pPr defTabSz="1218895"/>
-            <a:endParaRPr lang="en-US" sz="1600">
-              <a:solidFill>
-                <a:prstClr val="black"/>
-              </a:solidFill>
-              <a:latin typeface="Candara" panose="020E0502030303020204" pitchFamily="34" charset="0"/>
-            </a:endParaRPr>
-          </a:p>
-        </p:txBody>
-      </p:sp>
-      <p:sp>
-        <p:nvSpPr>
-          <p:cNvPr id="30" name="Text 25"/>
-          <p:cNvSpPr/>
-          <p:nvPr/>
-        </p:nvSpPr>
-        <p:spPr>
-          <a:xfrm>
-            <a:off x="11189341" y="4127681"/>
-            <a:ext cx="609441" cy="390042"/>
-          </a:xfrm>
-          <a:prstGeom prst="rect">
-            <a:avLst/>
-          </a:prstGeom>
-          <a:solidFill>
-            <a:srgbClr val="0D2318"/>
-          </a:solidFill>
-          <a:ln>
-            <a:noFill/>
-          </a:ln>
-        </p:spPr>
-        <p:txBody>
-          <a:bodyPr wrap="square" lIns="0" tIns="0" rIns="0" bIns="0" rtlCol="0" anchor="ctr"/>
-          <a:lstStyle/>
-          <a:p>
-            <a:pPr algn="r" defTabSz="1218895"/>
-            <a:r>
-              <a:rPr lang="en-US" sz="1600" b="1" dirty="0">
-                <a:solidFill>
-                  <a:srgbClr val="A78BFA">
-                    <a:alpha val="40000"/>
-                  </a:srgbClr>
-                </a:solidFill>
-                <a:latin typeface="Candara" panose="020E0502030303020204" pitchFamily="34" charset="0"/>
-                <a:ea typeface="Calibri" pitchFamily="34" charset="-122"/>
-                <a:cs typeface="Calibri" pitchFamily="34" charset="-120"/>
-              </a:rPr>
-              <a:t>04</a:t>
-            </a:r>
-            <a:endParaRPr lang="en-US" sz="1600" dirty="0">
-              <a:solidFill>
-                <a:prstClr val="black"/>
-              </a:solidFill>
-              <a:latin typeface="Candara" panose="020E0502030303020204" pitchFamily="34" charset="0"/>
-            </a:endParaRPr>
-          </a:p>
-        </p:txBody>
-      </p:sp>
       <p:pic>
         <p:nvPicPr>
           <p:cNvPr id="31" name="Image 3" descr="preencoded.png"/>
@@ -15395,7 +15070,7 @@
         <p:spPr>
           <a:xfrm>
             <a:off x="6618531" y="4773688"/>
-            <a:ext cx="5107118" cy="792274"/>
+            <a:ext cx="5107118" cy="376983"/>
           </a:xfrm>
           <a:prstGeom prst="rect">
             <a:avLst/>
@@ -15424,7 +15099,7 @@
               <a:t>Challenge  </a:t>
             </a:r>
             <a:r>
-              <a:rPr lang="en-US" sz="1600" dirty="0">
+              <a:rPr lang="en-US" sz="1600" b="1" dirty="0">
                 <a:solidFill>
                   <a:srgbClr val="A8C4B0"/>
                 </a:solidFill>
@@ -15432,7 +15107,7 @@
                 <a:ea typeface="Calibri" pitchFamily="34" charset="-122"/>
                 <a:cs typeface="Calibri" pitchFamily="34" charset="-120"/>
               </a:rPr>
-              <a:t>Supporting Arduino, ESP32, and Raspberry Pi — all with different hardware and communication capabilities.</a:t>
+              <a:t>Same backend API for multiple edge platform</a:t>
             </a:r>
             <a:endParaRPr lang="en-US" sz="1600" dirty="0">
               <a:solidFill>
@@ -15451,7 +15126,7 @@
         </p:nvSpPr>
         <p:spPr>
           <a:xfrm>
-            <a:off x="6618531" y="5639095"/>
+            <a:off x="6618531" y="5167138"/>
             <a:ext cx="5107118" cy="914162"/>
           </a:xfrm>
           <a:prstGeom prst="rect">
@@ -15481,7 +15156,7 @@
               <a:t>Solution  </a:t>
             </a:r>
             <a:r>
-              <a:rPr lang="en-US" sz="1600" dirty="0">
+              <a:rPr lang="en-US" sz="1600" b="1" dirty="0">
                 <a:solidFill>
                   <a:srgbClr val="C8DDD0"/>
                 </a:solidFill>
@@ -15489,7 +15164,7 @@
                 <a:ea typeface="Calibri" pitchFamily="34" charset="-122"/>
                 <a:cs typeface="Calibri" pitchFamily="34" charset="-120"/>
               </a:rPr>
-              <a:t>Flexible JSON payload format. HTTP POST endpoint for all devices. EdgeDeviceId as universal identifier.</a:t>
+              <a:t>MQTT + JSON, REST for tests, shared device model: device/sensor</a:t>
             </a:r>
             <a:endParaRPr lang="en-US" sz="1600" dirty="0">
               <a:solidFill>
@@ -16576,7 +16251,7 @@
         </p:nvSpPr>
         <p:spPr>
           <a:xfrm>
-            <a:off x="3323503" y="4653270"/>
+            <a:off x="2875634" y="4858141"/>
             <a:ext cx="4556117" cy="670385"/>
           </a:xfrm>
           <a:prstGeom prst="rect">
@@ -16840,7 +16515,7 @@
         </p:nvSpPr>
         <p:spPr>
           <a:xfrm>
-            <a:off x="3323503" y="2309161"/>
+            <a:off x="2875634" y="2147498"/>
             <a:ext cx="6702550" cy="1631780"/>
           </a:xfrm>
           <a:prstGeom prst="rect">
@@ -16863,7 +16538,7 @@
               </a:lnSpc>
               <a:defRPr/>
             </a:pPr>
-            <a:endParaRPr lang="en-US" sz="1400" dirty="0">
+            <a:endParaRPr lang="en-US" sz="1600" dirty="0">
               <a:solidFill>
                 <a:schemeClr val="bg1"/>
               </a:solidFill>
@@ -16878,7 +16553,7 @@
               <a:defRPr/>
             </a:pPr>
             <a:r>
-              <a:rPr lang="en-US" sz="1400" dirty="0">
+              <a:rPr lang="en-US" sz="1600" dirty="0">
                 <a:solidFill>
                   <a:schemeClr val="bg1"/>
                 </a:solidFill>
@@ -16886,7 +16561,7 @@
               </a:rPr>
               <a:t>I would like to take this opportunity to express my sincere gratitude to the instructors especially Naser Chowdhury who guided and supported us throughout the program over the past two years, to RTC School for giving me the opportunity to achieve my first educational milestone in the United States, and to my colleagues who worked hard to balance work and study at the same time so that we could achieve this goal together.</a:t>
             </a:r>
-            <a:endParaRPr kumimoji="0" lang="en-US" sz="1400" b="0" u="none" strike="noStrike" kern="1200" cap="none" spc="0" normalizeH="0" baseline="0" noProof="0" dirty="0">
+            <a:endParaRPr kumimoji="0" lang="en-US" sz="1600" b="0" u="none" strike="noStrike" kern="1200" cap="none" spc="0" normalizeH="0" baseline="0" noProof="0" dirty="0">
               <a:ln>
                 <a:noFill/>
               </a:ln>
@@ -16915,8 +16590,8 @@
         </p:nvSpPr>
         <p:spPr>
           <a:xfrm>
-            <a:off x="1744824" y="1302940"/>
-            <a:ext cx="5822302" cy="1569660"/>
+            <a:off x="1530220" y="860041"/>
+            <a:ext cx="5822302" cy="830997"/>
           </a:xfrm>
           <a:prstGeom prst="rect">
             <a:avLst/>
@@ -16938,8 +16613,6 @@
               </a:rPr>
               <a:t>Thank You</a:t>
             </a:r>
-          </a:p>
-          <a:p>
             <a:endParaRPr lang="en-US" sz="4800" i="1" dirty="0">
               <a:latin typeface="Candara" panose="020E0502030303020204" pitchFamily="34" charset="0"/>
             </a:endParaRPr>
@@ -18372,7 +18045,7 @@
               <a:defRPr/>
             </a:pPr>
             <a:r>
-              <a:rPr kumimoji="0" sz="1400" b="0" i="0" u="none" strike="noStrike" kern="1200" cap="none" spc="0" normalizeH="0" baseline="0" noProof="0">
+              <a:rPr kumimoji="0" sz="1400" b="0" i="0" u="none" strike="noStrike" kern="1200" cap="none" spc="0" normalizeH="0" baseline="0" noProof="0" dirty="0">
                 <a:ln>
                   <a:noFill/>
                 </a:ln>
@@ -18386,7 +18059,75 @@
                 <a:ea typeface="+mn-ea"/>
                 <a:cs typeface="+mn-cs"/>
               </a:rPr>
-              <a:t>Edge → API → DB → SignalR → React</a:t>
+              <a:t>Edge</a:t>
+            </a:r>
+            <a:r>
+              <a:rPr kumimoji="0" lang="en-US" sz="1400" b="0" i="0" u="none" strike="noStrike" kern="1200" cap="none" spc="0" normalizeH="0" baseline="0" noProof="0" dirty="0">
+                <a:ln>
+                  <a:noFill/>
+                </a:ln>
+                <a:solidFill>
+                  <a:srgbClr val="7AAB8A"/>
+                </a:solidFill>
+                <a:effectLst/>
+                <a:uLnTx/>
+                <a:uFillTx/>
+                <a:latin typeface="Candara"/>
+                <a:ea typeface="+mn-ea"/>
+                <a:cs typeface="+mn-cs"/>
+              </a:rPr>
+              <a:t> → MQTT</a:t>
+            </a:r>
+            <a:r>
+              <a:rPr kumimoji="0" sz="1400" b="0" i="0" u="none" strike="noStrike" kern="1200" cap="none" spc="0" normalizeH="0" baseline="0" noProof="0" dirty="0">
+                <a:ln>
+                  <a:noFill/>
+                </a:ln>
+                <a:solidFill>
+                  <a:srgbClr val="7AAB8A"/>
+                </a:solidFill>
+                <a:effectLst/>
+                <a:uLnTx/>
+                <a:uFillTx/>
+                <a:latin typeface="Candara"/>
+                <a:ea typeface="+mn-ea"/>
+                <a:cs typeface="+mn-cs"/>
+              </a:rPr>
+              <a:t> → API → DB → </a:t>
+            </a:r>
+            <a:r>
+              <a:rPr kumimoji="0" sz="1400" b="0" i="0" u="none" strike="noStrike" kern="1200" cap="none" spc="0" normalizeH="0" baseline="0" noProof="0" dirty="0" err="1">
+                <a:ln>
+                  <a:noFill/>
+                </a:ln>
+                <a:solidFill>
+                  <a:srgbClr val="7AAB8A"/>
+                </a:solidFill>
+                <a:effectLst/>
+                <a:uLnTx/>
+                <a:uFillTx/>
+                <a:latin typeface="Candara"/>
+                <a:ea typeface="+mn-ea"/>
+                <a:cs typeface="+mn-cs"/>
+              </a:rPr>
+              <a:t>SignalR</a:t>
+            </a:r>
+            <a:r>
+              <a:rPr kumimoji="0" sz="1400" b="0" i="0" u="none" strike="noStrike" kern="1200" cap="none" spc="0" normalizeH="0" baseline="0" noProof="0" dirty="0">
+                <a:ln>
+                  <a:noFill/>
+                </a:ln>
+                <a:solidFill>
+                  <a:srgbClr val="7AAB8A"/>
+                </a:solidFill>
+                <a:effectLst/>
+                <a:uLnTx/>
+                <a:uFillTx/>
+                <a:latin typeface="Candara"/>
+                <a:ea typeface="+mn-ea"/>
+                <a:cs typeface="+mn-cs"/>
+              </a:rPr>
+              <a:t> → React</a:t>
             </a:r>
           </a:p>
         </p:txBody>
@@ -21350,185 +21091,6 @@
               <a:uLnTx/>
               <a:uFillTx/>
               <a:latin typeface="Calibri"/>
-              <a:ea typeface="+mn-ea"/>
-              <a:cs typeface="+mn-cs"/>
-            </a:endParaRPr>
-          </a:p>
-        </p:txBody>
-      </p:sp>
-      <p:sp>
-        <p:nvSpPr>
-          <p:cNvPr id="78" name="Rounded Rectangle 67">
-            <a:extLst>
-              <a:ext uri="{FF2B5EF4-FFF2-40B4-BE49-F238E27FC236}">
-                <a16:creationId xmlns:a16="http://schemas.microsoft.com/office/drawing/2014/main" id="{393D4FDF-306E-5F8B-2AE3-3DC411ACC2EB}"/>
-              </a:ext>
-            </a:extLst>
-          </p:cNvPr>
-          <p:cNvSpPr/>
-          <p:nvPr/>
-        </p:nvSpPr>
-        <p:spPr>
-          <a:xfrm>
-            <a:off x="8014335" y="5427344"/>
-            <a:ext cx="420624" cy="329184"/>
-          </a:xfrm>
-          <a:prstGeom prst="roundRect">
-            <a:avLst>
-              <a:gd name="adj" fmla="val 4000"/>
-            </a:avLst>
-          </a:prstGeom>
-          <a:solidFill>
-            <a:srgbClr val="143A26"/>
-          </a:solidFill>
-          <a:ln w="6350">
-            <a:solidFill>
-              <a:srgbClr val="3ECF80"/>
-            </a:solidFill>
-          </a:ln>
-        </p:spPr>
-        <p:style>
-          <a:lnRef idx="1">
-            <a:schemeClr val="accent1"/>
-          </a:lnRef>
-          <a:fillRef idx="3">
-            <a:schemeClr val="accent1"/>
-          </a:fillRef>
-          <a:effectRef idx="2">
-            <a:schemeClr val="accent1"/>
-          </a:effectRef>
-          <a:fontRef idx="minor">
-            <a:schemeClr val="lt1"/>
-          </a:fontRef>
-        </p:style>
-        <p:txBody>
-          <a:bodyPr rtlCol="0" anchor="ctr"/>
-          <a:lstStyle/>
-          <a:p>
-            <a:pPr marL="0" marR="0" lvl="0" indent="0" algn="ctr" defTabSz="457200" rtl="0" eaLnBrk="1" fontAlgn="auto" latinLnBrk="0" hangingPunct="1">
-              <a:lnSpc>
-                <a:spcPct val="100000"/>
-              </a:lnSpc>
-              <a:spcBef>
-                <a:spcPts val="0"/>
-              </a:spcBef>
-              <a:spcAft>
-                <a:spcPts val="0"/>
-              </a:spcAft>
-              <a:buClrTx/>
-              <a:buSzTx/>
-              <a:buFontTx/>
-              <a:buNone/>
-              <a:tabLst/>
-              <a:defRPr/>
-            </a:pPr>
-            <a:endParaRPr kumimoji="0" sz="1800" b="0" i="0" u="none" strike="noStrike" kern="1200" cap="none" spc="0" normalizeH="0" baseline="0" noProof="0">
-              <a:ln>
-                <a:noFill/>
-              </a:ln>
-              <a:solidFill>
-                <a:prstClr val="white"/>
-              </a:solidFill>
-              <a:effectLst/>
-              <a:uLnTx/>
-              <a:uFillTx/>
-              <a:latin typeface="Calibri"/>
-              <a:ea typeface="+mn-ea"/>
-              <a:cs typeface="+mn-cs"/>
-            </a:endParaRPr>
-          </a:p>
-        </p:txBody>
-      </p:sp>
-      <p:sp>
-        <p:nvSpPr>
-          <p:cNvPr id="79" name="TextBox 78">
-            <a:extLst>
-              <a:ext uri="{FF2B5EF4-FFF2-40B4-BE49-F238E27FC236}">
-                <a16:creationId xmlns:a16="http://schemas.microsoft.com/office/drawing/2014/main" id="{9B8A8FEF-47C5-679C-F49E-19721944EA82}"/>
-              </a:ext>
-            </a:extLst>
-          </p:cNvPr>
-          <p:cNvSpPr txBox="1"/>
-          <p:nvPr/>
-        </p:nvSpPr>
-        <p:spPr>
-          <a:xfrm>
-            <a:off x="8014335" y="5418200"/>
-            <a:ext cx="420624" cy="307777"/>
-          </a:xfrm>
-          <a:prstGeom prst="rect">
-            <a:avLst/>
-          </a:prstGeom>
-          <a:noFill/>
-        </p:spPr>
-        <p:txBody>
-          <a:bodyPr wrap="square">
-            <a:spAutoFit/>
-          </a:bodyPr>
-          <a:lstStyle/>
-          <a:p>
-            <a:pPr marL="0" marR="0" lvl="0" indent="0" algn="ctr" defTabSz="457200" rtl="0" eaLnBrk="1" fontAlgn="auto" latinLnBrk="0" hangingPunct="1">
-              <a:lnSpc>
-                <a:spcPct val="100000"/>
-              </a:lnSpc>
-              <a:spcBef>
-                <a:spcPts val="0"/>
-              </a:spcBef>
-              <a:spcAft>
-                <a:spcPts val="0"/>
-              </a:spcAft>
-              <a:buClrTx/>
-              <a:buSzTx/>
-              <a:buFontTx/>
-              <a:buNone/>
-              <a:tabLst/>
-              <a:defRPr/>
-            </a:pPr>
-            <a:r>
-              <a:rPr kumimoji="0" sz="1400" b="1" i="0" u="none" strike="noStrike" kern="1200" cap="none" spc="0" normalizeH="0" baseline="0" noProof="0" dirty="0">
-                <a:ln>
-                  <a:noFill/>
-                </a:ln>
-                <a:solidFill>
-                  <a:srgbClr val="3ECF80"/>
-                </a:solidFill>
-                <a:effectLst/>
-                <a:uLnTx/>
-                <a:uFillTx/>
-                <a:latin typeface="Candara"/>
-                <a:ea typeface="+mn-ea"/>
-                <a:cs typeface="+mn-cs"/>
-              </a:rPr>
-              <a:t>1</a:t>
-            </a:r>
-            <a:r>
-              <a:rPr kumimoji="0" lang="en-US" sz="1400" b="1" i="0" u="none" strike="noStrike" kern="1200" cap="none" spc="0" normalizeH="0" baseline="0" noProof="0" dirty="0">
-                <a:ln>
-                  <a:noFill/>
-                </a:ln>
-                <a:solidFill>
-                  <a:srgbClr val="3ECF80"/>
-                </a:solidFill>
-                <a:effectLst/>
-                <a:uLnTx/>
-                <a:uFillTx/>
-                <a:latin typeface="Candara"/>
-                <a:ea typeface="+mn-ea"/>
-                <a:cs typeface="+mn-cs"/>
-              </a:rPr>
-              <a:t>2</a:t>
-            </a:r>
-            <a:endParaRPr kumimoji="0" sz="1400" b="1" i="0" u="none" strike="noStrike" kern="1200" cap="none" spc="0" normalizeH="0" baseline="0" noProof="0" dirty="0">
-              <a:ln>
-                <a:noFill/>
-              </a:ln>
-              <a:solidFill>
-                <a:srgbClr val="3ECF80"/>
-              </a:solidFill>
-              <a:effectLst/>
-              <a:uLnTx/>
-              <a:uFillTx/>
-              <a:latin typeface="Candara"/>
               <a:ea typeface="+mn-ea"/>
               <a:cs typeface="+mn-cs"/>
             </a:endParaRPr>
@@ -23075,7 +22637,7 @@
                   <a:schemeClr val="bg1"/>
                 </a:solidFill>
               </a:rPr>
-              <a:t>Traditional systems cost too much and lock</a:t>
+              <a:t>Traditional lock into proprietary hardware and software, cost.</a:t>
             </a:r>
             <a:endParaRPr kumimoji="0" b="1" i="0" u="none" strike="noStrike" kern="1200" cap="none" spc="0" normalizeH="0" baseline="0" noProof="0" dirty="0">
               <a:ln>
@@ -24231,7 +23793,7 @@
                 </a:solidFill>
                 <a:latin typeface="Candara" panose="020E0502030303020204" pitchFamily="34" charset="0"/>
               </a:rPr>
-              <a:t>Live sensor reading &amp; Device On/Offline Status</a:t>
+              <a:t>Live sensor reading &amp; Device on/off-line status</a:t>
             </a:r>
             <a:endParaRPr kumimoji="0" sz="1400" b="0" i="0" u="none" strike="noStrike" kern="1200" cap="none" spc="0" normalizeH="0" baseline="0" noProof="0" dirty="0">
               <a:ln>
@@ -24458,7 +24020,7 @@
                 </a:solidFill>
                 <a:latin typeface="Candara" panose="020E0502030303020204" pitchFamily="34" charset="0"/>
               </a:rPr>
-              <a:t>Store Readings &amp; Rolling Time Windows</a:t>
+              <a:t>Store readings &amp; rolling time windows</a:t>
             </a:r>
             <a:endParaRPr kumimoji="0" sz="1400" b="0" i="0" u="none" strike="noStrike" kern="1200" cap="none" spc="0" normalizeH="0" baseline="0" noProof="0" dirty="0">
               <a:ln>
@@ -24685,7 +24247,7 @@
                 </a:solidFill>
                 <a:latin typeface="Candara" panose="020E0502030303020204" pitchFamily="34" charset="0"/>
               </a:rPr>
-              <a:t>Remote Output Control With Command History</a:t>
+              <a:t>Remote output control with command history</a:t>
             </a:r>
             <a:endParaRPr kumimoji="0" sz="1400" b="0" i="0" u="none" strike="noStrike" kern="1200" cap="none" spc="0" normalizeH="0" baseline="0" noProof="0" dirty="0">
               <a:ln>
@@ -24923,7 +24485,16 @@
                 <a:ea typeface="+mn-ea"/>
                 <a:cs typeface="+mn-cs"/>
               </a:rPr>
-              <a:t>End-to-end pipeline: Device → MQTT → Backend → </a:t>
+              <a:t>Device → MQTT → </a:t>
+            </a:r>
+            <a:r>
+              <a:rPr lang="en-US" sz="1600" b="1" dirty="0">
+                <a:solidFill>
+                  <a:srgbClr val="FFFF00"/>
+                </a:solidFill>
+                <a:latin typeface="Candara" panose="020E0502030303020204" pitchFamily="34" charset="0"/>
+              </a:rPr>
+              <a:t>API → SQL Server . </a:t>
             </a:r>
             <a:r>
               <a:rPr kumimoji="0" sz="1600" b="1" i="0" u="none" strike="noStrike" kern="1200" cap="none" spc="0" normalizeH="0" baseline="0" noProof="0" dirty="0" err="1">
@@ -25606,7 +25177,75 @@
                 <a:ea typeface="+mn-ea"/>
                 <a:cs typeface="+mn-cs"/>
               </a:rPr>
-              <a:t>MQTT + Broker (Mosquito/EMQX)</a:t>
+              <a:t>MQTT + Broker (</a:t>
+            </a:r>
+            <a:r>
+              <a:rPr kumimoji="0" sz="1400" b="0" i="0" u="none" strike="noStrike" kern="1200" cap="none" spc="0" normalizeH="0" baseline="0" noProof="0" dirty="0" err="1">
+                <a:ln>
+                  <a:noFill/>
+                </a:ln>
+                <a:solidFill>
+                  <a:srgbClr val="3ECF80"/>
+                </a:solidFill>
+                <a:effectLst/>
+                <a:uLnTx/>
+                <a:uFillTx/>
+                <a:latin typeface="Candara" panose="020E0502030303020204" pitchFamily="34" charset="0"/>
+                <a:ea typeface="+mn-ea"/>
+                <a:cs typeface="+mn-cs"/>
+              </a:rPr>
+              <a:t>Mosquit</a:t>
+            </a:r>
+            <a:r>
+              <a:rPr kumimoji="0" lang="en-US" sz="1400" b="0" i="0" u="none" strike="noStrike" kern="1200" cap="none" spc="0" normalizeH="0" baseline="0" noProof="0" dirty="0" err="1">
+                <a:ln>
+                  <a:noFill/>
+                </a:ln>
+                <a:solidFill>
+                  <a:srgbClr val="3ECF80"/>
+                </a:solidFill>
+                <a:effectLst/>
+                <a:uLnTx/>
+                <a:uFillTx/>
+                <a:latin typeface="Candara" panose="020E0502030303020204" pitchFamily="34" charset="0"/>
+                <a:ea typeface="+mn-ea"/>
+                <a:cs typeface="+mn-cs"/>
+              </a:rPr>
+              <a:t>t</a:t>
+            </a:r>
+            <a:r>
+              <a:rPr kumimoji="0" sz="1400" b="0" i="0" u="none" strike="noStrike" kern="1200" cap="none" spc="0" normalizeH="0" baseline="0" noProof="0" dirty="0" err="1">
+                <a:ln>
+                  <a:noFill/>
+                </a:ln>
+                <a:solidFill>
+                  <a:srgbClr val="3ECF80"/>
+                </a:solidFill>
+                <a:effectLst/>
+                <a:uLnTx/>
+                <a:uFillTx/>
+                <a:latin typeface="Candara" panose="020E0502030303020204" pitchFamily="34" charset="0"/>
+                <a:ea typeface="+mn-ea"/>
+                <a:cs typeface="+mn-cs"/>
+              </a:rPr>
+              <a:t>o</a:t>
+            </a:r>
+            <a:r>
+              <a:rPr kumimoji="0" sz="1400" b="0" i="0" u="none" strike="noStrike" kern="1200" cap="none" spc="0" normalizeH="0" baseline="0" noProof="0" dirty="0">
+                <a:ln>
+                  <a:noFill/>
+                </a:ln>
+                <a:solidFill>
+                  <a:srgbClr val="3ECF80"/>
+                </a:solidFill>
+                <a:effectLst/>
+                <a:uLnTx/>
+                <a:uFillTx/>
+                <a:latin typeface="Candara" panose="020E0502030303020204" pitchFamily="34" charset="0"/>
+                <a:ea typeface="+mn-ea"/>
+                <a:cs typeface="+mn-cs"/>
+              </a:rPr>
+              <a:t>/EMQX)</a:t>
             </a:r>
           </a:p>
         </p:txBody>
@@ -39848,7 +39487,7 @@
           <a:lstStyle/>
           <a:p>
             <a:r>
-              <a:rPr lang="en-US" sz="3200" b="1" dirty="0">
+              <a:rPr lang="en-US" sz="2800" b="1" dirty="0">
                 <a:solidFill>
                   <a:srgbClr val="FFFFFF"/>
                 </a:solidFill>
@@ -39858,7 +39497,7 @@
               </a:rPr>
               <a:t>Backend &amp; API Design</a:t>
             </a:r>
-            <a:endParaRPr lang="en-US" sz="3200" dirty="0">
+            <a:endParaRPr lang="en-US" sz="2800" dirty="0">
               <a:latin typeface="Candara" panose="020E0502030303020204" pitchFamily="34" charset="0"/>
             </a:endParaRPr>
           </a:p>
@@ -48252,7 +47891,7 @@
                 <a:ea typeface="Calibri" pitchFamily="34" charset="-122"/>
                 <a:cs typeface="Calibri" pitchFamily="34" charset="-120"/>
               </a:rPr>
-              <a:t>Front end Design</a:t>
+              <a:t>Frontend Design</a:t>
             </a:r>
             <a:r>
               <a:rPr lang="en-US" sz="2800" b="1" dirty="0">
@@ -48282,8 +47921,8 @@
         </p:nvSpPr>
         <p:spPr>
           <a:xfrm>
-            <a:off x="365664" y="762702"/>
-            <a:ext cx="11646422" cy="219399"/>
+            <a:off x="365664" y="836875"/>
+            <a:ext cx="6668928" cy="228542"/>
           </a:xfrm>
           <a:prstGeom prst="rect">
             <a:avLst/>
@@ -50432,8 +50071,8 @@
         </p:nvSpPr>
         <p:spPr>
           <a:xfrm>
-            <a:off x="3432678" y="5622988"/>
-            <a:ext cx="1307251" cy="274249"/>
+            <a:off x="3432677" y="5622988"/>
+            <a:ext cx="1643175" cy="274249"/>
           </a:xfrm>
           <a:prstGeom prst="rect">
             <a:avLst/>
@@ -53013,7 +52652,18 @@
                 <a:ea typeface="Calibri" pitchFamily="34" charset="-122"/>
                 <a:cs typeface="Calibri" pitchFamily="34" charset="-120"/>
               </a:rPr>
-              <a:t>Pending → Sent → Completed</a:t>
+              <a:t>Pending → Sent → </a:t>
+            </a:r>
+            <a:r>
+              <a:rPr lang="en-US" sz="1200" b="1" dirty="0" err="1">
+                <a:solidFill>
+                  <a:srgbClr val="FFFF00"/>
+                </a:solidFill>
+                <a:latin typeface="Candara" panose="020E0502030303020204" pitchFamily="34" charset="0"/>
+                <a:ea typeface="Calibri" pitchFamily="34" charset="-122"/>
+                <a:cs typeface="Calibri" pitchFamily="34" charset="-120"/>
+              </a:rPr>
+              <a:t>Acked</a:t>
             </a:r>
             <a:endParaRPr lang="en-US" sz="1200" b="1" dirty="0">
               <a:solidFill>
@@ -53373,57 +53023,6 @@
               </a:solidFill>
               <a:latin typeface="Candara" panose="020E0502030303020204" pitchFamily="34" charset="0"/>
             </a:endParaRPr>
-          </a:p>
-        </p:txBody>
-      </p:sp>
-      <p:sp>
-        <p:nvSpPr>
-          <p:cNvPr id="5" name="Rectangle: Rounded Corners 4">
-            <a:extLst>
-              <a:ext uri="{FF2B5EF4-FFF2-40B4-BE49-F238E27FC236}">
-                <a16:creationId xmlns:a16="http://schemas.microsoft.com/office/drawing/2014/main" id="{717A4F75-0830-66B3-F03E-A96FD6A108D1}"/>
-              </a:ext>
-            </a:extLst>
-          </p:cNvPr>
-          <p:cNvSpPr/>
-          <p:nvPr/>
-        </p:nvSpPr>
-        <p:spPr>
-          <a:xfrm>
-            <a:off x="5443832" y="982101"/>
-            <a:ext cx="6134350" cy="5887197"/>
-          </a:xfrm>
-          <a:prstGeom prst="roundRect">
-            <a:avLst/>
-          </a:prstGeom>
-          <a:solidFill>
-            <a:schemeClr val="accent1">
-              <a:alpha val="23000"/>
-            </a:schemeClr>
-          </a:solidFill>
-        </p:spPr>
-        <p:style>
-          <a:lnRef idx="2">
-            <a:schemeClr val="accent1">
-              <a:shade val="15000"/>
-            </a:schemeClr>
-          </a:lnRef>
-          <a:fillRef idx="1">
-            <a:schemeClr val="accent1"/>
-          </a:fillRef>
-          <a:effectRef idx="0">
-            <a:schemeClr val="accent1"/>
-          </a:effectRef>
-          <a:fontRef idx="minor">
-            <a:schemeClr val="lt1"/>
-          </a:fontRef>
-        </p:style>
-        <p:txBody>
-          <a:bodyPr rtlCol="0" anchor="ctr"/>
-          <a:lstStyle/>
-          <a:p>
-            <a:pPr algn="ctr"/>
-            <a:endParaRPr lang="en-US"/>
           </a:p>
         </p:txBody>
       </p:sp>

</xml_diff>

<commit_message>
working with final ppt
</commit_message>
<xml_diff>
--- a/Documents/Presentation/Capstone Project Presentation.pptx
+++ b/Documents/Presentation/Capstone Project Presentation.pptx
@@ -138,6 +138,9 @@
         </p15:guide>
       </p15:sldGuideLst>
     </p:ext>
+    <p:ext uri="{2D200454-40CA-4A62-9FC3-DE9A4176ACB9}">
+      <p15:notesGuideLst xmlns:p15="http://schemas.microsoft.com/office/powerpoint/2012/main"/>
+    </p:ext>
   </p:extLst>
 </p:presentation>
 </file>
@@ -224,7 +227,7 @@
           <a:p>
             <a:fld id="{01EDE3E3-4DC4-4033-AB14-8C688262196C}" type="datetimeFigureOut">
               <a:rPr lang="en-US" smtClean="0"/>
-              <a:t>6/10/2026</a:t>
+              <a:t>6/16/2026</a:t>
             </a:fld>
             <a:endParaRPr lang="en-US"/>
           </a:p>
@@ -2344,7 +2347,7 @@
           <a:p>
             <a:r>
               <a:rPr lang="en-US" dirty="0"/>
-              <a:t>The database consists of eleven normalized tables, with Devices serving as the central entity. Most other tables are connected to a device, allowing the system to manage multiple devices within a single platform.</a:t>
+              <a:t>The database consists of 8 normalized tables, with Devices serving as the central entity. Most other tables are connected to a device, allowing the system to manage multiple devices within a single platform.</a:t>
             </a:r>
           </a:p>
           <a:p>
@@ -2358,15 +2361,7 @@
             </a:r>
             <a:r>
               <a:rPr lang="en-US" dirty="0"/>
-              <a:t> stores time-series sensor data, while </a:t>
-            </a:r>
-            <a:r>
-              <a:rPr lang="en-US" dirty="0" err="1"/>
-              <a:t>DeviceStatusHistories</a:t>
-            </a:r>
-            <a:r>
-              <a:rPr lang="en-US" dirty="0"/>
-              <a:t> records device connectivity and status changes over time.</a:t>
+              <a:t> stores time-series sensor data.</a:t>
             </a:r>
           </a:p>
           <a:p>
@@ -2394,15 +2389,7 @@
           <a:p>
             <a:r>
               <a:rPr lang="en-US" dirty="0"/>
-              <a:t>Additional tables, such as </a:t>
-            </a:r>
-            <a:r>
-              <a:rPr lang="en-US" dirty="0" err="1"/>
-              <a:t>DeviceConfigurations</a:t>
-            </a:r>
-            <a:r>
-              <a:rPr lang="en-US" dirty="0"/>
-              <a:t> and Users, support system configuration, authentication, and access control.</a:t>
+              <a:t>Additional tables Users, support authentication, and access control.</a:t>
             </a:r>
           </a:p>
           <a:p>
@@ -2951,7 +2938,7 @@
           <a:p>
             <a:fld id="{5BCAD085-E8A6-8845-BD4E-CB4CCA059FC4}" type="datetimeFigureOut">
               <a:rPr lang="en-US" smtClean="0"/>
-              <a:t>6/10/2026</a:t>
+              <a:t>6/16/2026</a:t>
             </a:fld>
             <a:endParaRPr lang="en-US"/>
           </a:p>
@@ -3119,7 +3106,7 @@
           <a:p>
             <a:fld id="{5BCAD085-E8A6-8845-BD4E-CB4CCA059FC4}" type="datetimeFigureOut">
               <a:rPr lang="en-US" smtClean="0"/>
-              <a:t>6/10/2026</a:t>
+              <a:t>6/16/2026</a:t>
             </a:fld>
             <a:endParaRPr lang="en-US"/>
           </a:p>
@@ -3297,7 +3284,7 @@
           <a:p>
             <a:fld id="{5BCAD085-E8A6-8845-BD4E-CB4CCA059FC4}" type="datetimeFigureOut">
               <a:rPr lang="en-US" smtClean="0"/>
-              <a:t>6/10/2026</a:t>
+              <a:t>6/16/2026</a:t>
             </a:fld>
             <a:endParaRPr lang="en-US"/>
           </a:p>
@@ -3537,7 +3524,7 @@
           <a:p>
             <a:fld id="{5BCAD085-E8A6-8845-BD4E-CB4CCA059FC4}" type="datetimeFigureOut">
               <a:rPr lang="en-US" smtClean="0"/>
-              <a:t>6/10/2026</a:t>
+              <a:t>6/16/2026</a:t>
             </a:fld>
             <a:endParaRPr lang="en-US"/>
           </a:p>
@@ -3705,7 +3692,7 @@
           <a:p>
             <a:fld id="{5BCAD085-E8A6-8845-BD4E-CB4CCA059FC4}" type="datetimeFigureOut">
               <a:rPr lang="en-US" smtClean="0"/>
-              <a:t>6/10/2026</a:t>
+              <a:t>6/16/2026</a:t>
             </a:fld>
             <a:endParaRPr lang="en-US"/>
           </a:p>
@@ -3950,7 +3937,7 @@
           <a:p>
             <a:fld id="{5BCAD085-E8A6-8845-BD4E-CB4CCA059FC4}" type="datetimeFigureOut">
               <a:rPr lang="en-US" smtClean="0"/>
-              <a:t>6/10/2026</a:t>
+              <a:t>6/16/2026</a:t>
             </a:fld>
             <a:endParaRPr lang="en-US"/>
           </a:p>
@@ -4235,7 +4222,7 @@
           <a:p>
             <a:fld id="{5BCAD085-E8A6-8845-BD4E-CB4CCA059FC4}" type="datetimeFigureOut">
               <a:rPr lang="en-US" smtClean="0"/>
-              <a:t>6/10/2026</a:t>
+              <a:t>6/16/2026</a:t>
             </a:fld>
             <a:endParaRPr lang="en-US"/>
           </a:p>
@@ -4654,7 +4641,7 @@
           <a:p>
             <a:fld id="{5BCAD085-E8A6-8845-BD4E-CB4CCA059FC4}" type="datetimeFigureOut">
               <a:rPr lang="en-US" smtClean="0"/>
-              <a:t>6/10/2026</a:t>
+              <a:t>6/16/2026</a:t>
             </a:fld>
             <a:endParaRPr lang="en-US"/>
           </a:p>
@@ -4771,7 +4758,7 @@
           <a:p>
             <a:fld id="{5BCAD085-E8A6-8845-BD4E-CB4CCA059FC4}" type="datetimeFigureOut">
               <a:rPr lang="en-US" smtClean="0"/>
-              <a:t>6/10/2026</a:t>
+              <a:t>6/16/2026</a:t>
             </a:fld>
             <a:endParaRPr lang="en-US"/>
           </a:p>
@@ -4866,7 +4853,7 @@
           <a:p>
             <a:fld id="{5BCAD085-E8A6-8845-BD4E-CB4CCA059FC4}" type="datetimeFigureOut">
               <a:rPr lang="en-US" smtClean="0"/>
-              <a:t>6/10/2026</a:t>
+              <a:t>6/16/2026</a:t>
             </a:fld>
             <a:endParaRPr lang="en-US"/>
           </a:p>
@@ -5141,7 +5128,7 @@
           <a:p>
             <a:fld id="{5BCAD085-E8A6-8845-BD4E-CB4CCA059FC4}" type="datetimeFigureOut">
               <a:rPr lang="en-US" smtClean="0"/>
-              <a:t>6/10/2026</a:t>
+              <a:t>6/16/2026</a:t>
             </a:fld>
             <a:endParaRPr lang="en-US"/>
           </a:p>
@@ -5309,7 +5296,7 @@
           <a:p>
             <a:fld id="{5BCAD085-E8A6-8845-BD4E-CB4CCA059FC4}" type="datetimeFigureOut">
               <a:rPr lang="en-US" smtClean="0"/>
-              <a:t>6/10/2026</a:t>
+              <a:t>6/16/2026</a:t>
             </a:fld>
             <a:endParaRPr lang="en-US"/>
           </a:p>
@@ -5561,7 +5548,7 @@
           <a:p>
             <a:fld id="{5BCAD085-E8A6-8845-BD4E-CB4CCA059FC4}" type="datetimeFigureOut">
               <a:rPr lang="en-US" smtClean="0"/>
-              <a:t>6/10/2026</a:t>
+              <a:t>6/16/2026</a:t>
             </a:fld>
             <a:endParaRPr lang="en-US"/>
           </a:p>
@@ -5729,7 +5716,7 @@
           <a:p>
             <a:fld id="{5BCAD085-E8A6-8845-BD4E-CB4CCA059FC4}" type="datetimeFigureOut">
               <a:rPr lang="en-US" smtClean="0"/>
-              <a:t>6/10/2026</a:t>
+              <a:t>6/16/2026</a:t>
             </a:fld>
             <a:endParaRPr lang="en-US"/>
           </a:p>
@@ -5907,7 +5894,7 @@
           <a:p>
             <a:fld id="{5BCAD085-E8A6-8845-BD4E-CB4CCA059FC4}" type="datetimeFigureOut">
               <a:rPr lang="en-US" smtClean="0"/>
-              <a:t>6/10/2026</a:t>
+              <a:t>6/16/2026</a:t>
             </a:fld>
             <a:endParaRPr lang="en-US"/>
           </a:p>
@@ -6182,7 +6169,7 @@
           <a:p>
             <a:fld id="{5BCAD085-E8A6-8845-BD4E-CB4CCA059FC4}" type="datetimeFigureOut">
               <a:rPr lang="en-US" smtClean="0"/>
-              <a:t>6/10/2026</a:t>
+              <a:t>6/16/2026</a:t>
             </a:fld>
             <a:endParaRPr lang="en-US"/>
           </a:p>
@@ -6350,7 +6337,7 @@
           <a:p>
             <a:fld id="{5BCAD085-E8A6-8845-BD4E-CB4CCA059FC4}" type="datetimeFigureOut">
               <a:rPr lang="en-US" smtClean="0"/>
-              <a:t>6/10/2026</a:t>
+              <a:t>6/16/2026</a:t>
             </a:fld>
             <a:endParaRPr lang="en-US"/>
           </a:p>
@@ -6595,7 +6582,7 @@
           <a:p>
             <a:fld id="{5BCAD085-E8A6-8845-BD4E-CB4CCA059FC4}" type="datetimeFigureOut">
               <a:rPr lang="en-US" smtClean="0"/>
-              <a:t>6/10/2026</a:t>
+              <a:t>6/16/2026</a:t>
             </a:fld>
             <a:endParaRPr lang="en-US"/>
           </a:p>
@@ -6880,7 +6867,7 @@
           <a:p>
             <a:fld id="{5BCAD085-E8A6-8845-BD4E-CB4CCA059FC4}" type="datetimeFigureOut">
               <a:rPr lang="en-US" smtClean="0"/>
-              <a:t>6/10/2026</a:t>
+              <a:t>6/16/2026</a:t>
             </a:fld>
             <a:endParaRPr lang="en-US"/>
           </a:p>
@@ -7299,7 +7286,7 @@
           <a:p>
             <a:fld id="{5BCAD085-E8A6-8845-BD4E-CB4CCA059FC4}" type="datetimeFigureOut">
               <a:rPr lang="en-US" smtClean="0"/>
-              <a:t>6/10/2026</a:t>
+              <a:t>6/16/2026</a:t>
             </a:fld>
             <a:endParaRPr lang="en-US"/>
           </a:p>
@@ -7416,7 +7403,7 @@
           <a:p>
             <a:fld id="{5BCAD085-E8A6-8845-BD4E-CB4CCA059FC4}" type="datetimeFigureOut">
               <a:rPr lang="en-US" smtClean="0"/>
-              <a:t>6/10/2026</a:t>
+              <a:t>6/16/2026</a:t>
             </a:fld>
             <a:endParaRPr lang="en-US"/>
           </a:p>
@@ -7661,7 +7648,7 @@
           <a:p>
             <a:fld id="{5BCAD085-E8A6-8845-BD4E-CB4CCA059FC4}" type="datetimeFigureOut">
               <a:rPr lang="en-US" smtClean="0"/>
-              <a:t>6/10/2026</a:t>
+              <a:t>6/16/2026</a:t>
             </a:fld>
             <a:endParaRPr lang="en-US"/>
           </a:p>
@@ -7756,7 +7743,7 @@
           <a:p>
             <a:fld id="{5BCAD085-E8A6-8845-BD4E-CB4CCA059FC4}" type="datetimeFigureOut">
               <a:rPr lang="en-US" smtClean="0"/>
-              <a:t>6/10/2026</a:t>
+              <a:t>6/16/2026</a:t>
             </a:fld>
             <a:endParaRPr lang="en-US"/>
           </a:p>
@@ -8031,7 +8018,7 @@
           <a:p>
             <a:fld id="{5BCAD085-E8A6-8845-BD4E-CB4CCA059FC4}" type="datetimeFigureOut">
               <a:rPr lang="en-US" smtClean="0"/>
-              <a:t>6/10/2026</a:t>
+              <a:t>6/16/2026</a:t>
             </a:fld>
             <a:endParaRPr lang="en-US"/>
           </a:p>
@@ -8283,7 +8270,7 @@
           <a:p>
             <a:fld id="{5BCAD085-E8A6-8845-BD4E-CB4CCA059FC4}" type="datetimeFigureOut">
               <a:rPr lang="en-US" smtClean="0"/>
-              <a:t>6/10/2026</a:t>
+              <a:t>6/16/2026</a:t>
             </a:fld>
             <a:endParaRPr lang="en-US"/>
           </a:p>
@@ -8451,7 +8438,7 @@
           <a:p>
             <a:fld id="{5BCAD085-E8A6-8845-BD4E-CB4CCA059FC4}" type="datetimeFigureOut">
               <a:rPr lang="en-US" smtClean="0"/>
-              <a:t>6/10/2026</a:t>
+              <a:t>6/16/2026</a:t>
             </a:fld>
             <a:endParaRPr lang="en-US"/>
           </a:p>
@@ -8629,7 +8616,7 @@
           <a:p>
             <a:fld id="{5BCAD085-E8A6-8845-BD4E-CB4CCA059FC4}" type="datetimeFigureOut">
               <a:rPr lang="en-US" smtClean="0"/>
-              <a:t>6/10/2026</a:t>
+              <a:t>6/16/2026</a:t>
             </a:fld>
             <a:endParaRPr lang="en-US"/>
           </a:p>
@@ -8984,7 +8971,7 @@
           <a:p>
             <a:fld id="{5BCAD085-E8A6-8845-BD4E-CB4CCA059FC4}" type="datetimeFigureOut">
               <a:rPr lang="en-US" smtClean="0"/>
-              <a:t>6/10/2026</a:t>
+              <a:t>6/16/2026</a:t>
             </a:fld>
             <a:endParaRPr lang="en-US"/>
           </a:p>
@@ -9403,7 +9390,7 @@
           <a:p>
             <a:fld id="{5BCAD085-E8A6-8845-BD4E-CB4CCA059FC4}" type="datetimeFigureOut">
               <a:rPr lang="en-US" smtClean="0"/>
-              <a:t>6/10/2026</a:t>
+              <a:t>6/16/2026</a:t>
             </a:fld>
             <a:endParaRPr lang="en-US"/>
           </a:p>
@@ -9520,7 +9507,7 @@
           <a:p>
             <a:fld id="{5BCAD085-E8A6-8845-BD4E-CB4CCA059FC4}" type="datetimeFigureOut">
               <a:rPr lang="en-US" smtClean="0"/>
-              <a:t>6/10/2026</a:t>
+              <a:t>6/16/2026</a:t>
             </a:fld>
             <a:endParaRPr lang="en-US"/>
           </a:p>
@@ -9615,7 +9602,7 @@
           <a:p>
             <a:fld id="{5BCAD085-E8A6-8845-BD4E-CB4CCA059FC4}" type="datetimeFigureOut">
               <a:rPr lang="en-US" smtClean="0"/>
-              <a:t>6/10/2026</a:t>
+              <a:t>6/16/2026</a:t>
             </a:fld>
             <a:endParaRPr lang="en-US"/>
           </a:p>
@@ -9890,7 +9877,7 @@
           <a:p>
             <a:fld id="{5BCAD085-E8A6-8845-BD4E-CB4CCA059FC4}" type="datetimeFigureOut">
               <a:rPr lang="en-US" smtClean="0"/>
-              <a:t>6/10/2026</a:t>
+              <a:t>6/16/2026</a:t>
             </a:fld>
             <a:endParaRPr lang="en-US"/>
           </a:p>
@@ -10142,7 +10129,7 @@
           <a:p>
             <a:fld id="{5BCAD085-E8A6-8845-BD4E-CB4CCA059FC4}" type="datetimeFigureOut">
               <a:rPr lang="en-US" smtClean="0"/>
-              <a:t>6/10/2026</a:t>
+              <a:t>6/16/2026</a:t>
             </a:fld>
             <a:endParaRPr lang="en-US"/>
           </a:p>
@@ -10353,7 +10340,7 @@
           <a:p>
             <a:fld id="{5BCAD085-E8A6-8845-BD4E-CB4CCA059FC4}" type="datetimeFigureOut">
               <a:rPr lang="en-US" smtClean="0"/>
-              <a:t>6/10/2026</a:t>
+              <a:t>6/16/2026</a:t>
             </a:fld>
             <a:endParaRPr lang="en-US"/>
           </a:p>
@@ -10861,7 +10848,7 @@
           <a:p>
             <a:fld id="{5BCAD085-E8A6-8845-BD4E-CB4CCA059FC4}" type="datetimeFigureOut">
               <a:rPr lang="en-US" smtClean="0"/>
-              <a:t>6/10/2026</a:t>
+              <a:t>6/16/2026</a:t>
             </a:fld>
             <a:endParaRPr lang="en-US"/>
           </a:p>
@@ -11370,7 +11357,7 @@
           <a:p>
             <a:fld id="{5BCAD085-E8A6-8845-BD4E-CB4CCA059FC4}" type="datetimeFigureOut">
               <a:rPr lang="en-US" smtClean="0"/>
-              <a:t>6/10/2026</a:t>
+              <a:t>6/16/2026</a:t>
             </a:fld>
             <a:endParaRPr lang="en-US"/>
           </a:p>
@@ -12197,17 +12184,7 @@
                 <a:latin typeface="Candara" panose="020E0502030303020204" pitchFamily="34" charset="0"/>
                 <a:ea typeface="Cambria Math" panose="02040503050406030204" pitchFamily="18" charset="0"/>
               </a:rPr>
-              <a:t> </a:t>
-            </a:r>
-            <a:r>
-              <a:rPr lang="en-US" sz="1400" dirty="0">
-                <a:solidFill>
-                  <a:srgbClr val="9EC4AE"/>
-                </a:solidFill>
-                <a:latin typeface="Candara" panose="020E0502030303020204" pitchFamily="34" charset="0"/>
-                <a:ea typeface="Cambria Math" panose="02040503050406030204" pitchFamily="18" charset="0"/>
-              </a:rPr>
-              <a:t>SPA</a:t>
+              <a:t> SPA</a:t>
             </a:r>
             <a:endParaRPr sz="1400" b="1" i="0" dirty="0">
               <a:solidFill>
@@ -12263,7 +12240,7 @@
         <p:spPr>
           <a:xfrm>
             <a:off x="2685119" y="4313770"/>
-            <a:ext cx="1943028" cy="523220"/>
+            <a:ext cx="1943028" cy="307777"/>
           </a:xfrm>
           <a:prstGeom prst="rect">
             <a:avLst/>
@@ -12287,34 +12264,14 @@
               <a:t>SignalR</a:t>
             </a:r>
             <a:r>
-              <a:rPr lang="en-US" sz="1400" b="1" dirty="0">
+              <a:rPr lang="en-US" sz="1400" b="1" i="0" dirty="0">
                 <a:solidFill>
                   <a:srgbClr val="00B8D4"/>
                 </a:solidFill>
                 <a:latin typeface="Candara" panose="020E0502030303020204" pitchFamily="34" charset="0"/>
                 <a:ea typeface="Cambria Math" panose="02040503050406030204" pitchFamily="18" charset="0"/>
               </a:rPr>
-              <a:t> | Web Service</a:t>
-            </a:r>
-            <a:r>
-              <a:rPr lang="en-US" sz="1400" b="1" i="0" dirty="0">
-                <a:solidFill>
-                  <a:srgbClr val="00B8D4"/>
-                </a:solidFill>
-                <a:latin typeface="Candara" panose="020E0502030303020204" pitchFamily="34" charset="0"/>
-                <a:ea typeface="Cambria Math" panose="02040503050406030204" pitchFamily="18" charset="0"/>
-              </a:rPr>
               <a:t> </a:t>
-            </a:r>
-            <a:r>
-              <a:rPr lang="en-US" sz="1400" dirty="0">
-                <a:solidFill>
-                  <a:srgbClr val="9EC4AE"/>
-                </a:solidFill>
-                <a:latin typeface="Candara" panose="020E0502030303020204" pitchFamily="34" charset="0"/>
-                <a:ea typeface="Cambria Math" panose="02040503050406030204" pitchFamily="18" charset="0"/>
-              </a:rPr>
-              <a:t>Hub</a:t>
             </a:r>
             <a:endParaRPr sz="1400" b="1" i="0" dirty="0">
               <a:solidFill>
@@ -12669,8 +12626,8 @@
         </p:nvSpPr>
         <p:spPr>
           <a:xfrm>
-            <a:off x="2685119" y="2415632"/>
-            <a:ext cx="1524342" cy="523220"/>
+            <a:off x="2685118" y="2415632"/>
+            <a:ext cx="1589701" cy="523220"/>
           </a:xfrm>
           <a:prstGeom prst="rect">
             <a:avLst/>
@@ -12691,27 +12648,7 @@
                 <a:latin typeface="Candara" panose="020E0502030303020204" pitchFamily="34" charset="0"/>
                 <a:ea typeface="Cambria Math" panose="02040503050406030204" pitchFamily="18" charset="0"/>
               </a:rPr>
-              <a:t>C#, ASP.NET Core, </a:t>
-            </a:r>
-            <a:r>
-              <a:rPr lang="en-US" sz="1400" b="1" dirty="0" err="1">
-                <a:solidFill>
-                  <a:srgbClr val="009A72"/>
-                </a:solidFill>
-                <a:latin typeface="Candara" panose="020E0502030303020204" pitchFamily="34" charset="0"/>
-                <a:ea typeface="Cambria Math" panose="02040503050406030204" pitchFamily="18" charset="0"/>
-              </a:rPr>
-              <a:t>RESt</a:t>
-            </a:r>
-            <a:r>
-              <a:rPr lang="en-US" sz="1400" b="1" dirty="0">
-                <a:solidFill>
-                  <a:srgbClr val="009A72"/>
-                </a:solidFill>
-                <a:latin typeface="Candara" panose="020E0502030303020204" pitchFamily="34" charset="0"/>
-                <a:ea typeface="Cambria Math" panose="02040503050406030204" pitchFamily="18" charset="0"/>
-              </a:rPr>
-              <a:t> </a:t>
+              <a:t>C#, ASP.NET Core, REST </a:t>
             </a:r>
             <a:r>
               <a:rPr lang="en-US" sz="1400" dirty="0">
@@ -12781,7 +12718,7 @@
                 <a:latin typeface="Candara" panose="020E0502030303020204" pitchFamily="34" charset="0"/>
                 <a:ea typeface="Cambria Math" panose="02040503050406030204" pitchFamily="18" charset="0"/>
               </a:rPr>
-              <a:t>MQTT Broker</a:t>
+              <a:t>MQTT </a:t>
             </a:r>
             <a:endParaRPr sz="1400" b="1" i="0" dirty="0">
               <a:solidFill>
@@ -12798,14 +12735,6 @@
   <p:clrMapOvr>
     <a:masterClrMapping/>
   </p:clrMapOvr>
-  <mc:AlternateContent xmlns:mc="http://schemas.openxmlformats.org/markup-compatibility/2006" xmlns:p14="http://schemas.microsoft.com/office/powerpoint/2010/main">
-    <mc:Choice Requires="p14">
-      <p:transition spd="slow" p14:dur="2000" advTm="23957"/>
-    </mc:Choice>
-    <mc:Fallback xmlns="">
-      <p:transition spd="slow" advTm="23957"/>
-    </mc:Fallback>
-  </mc:AlternateContent>
 </p:sld>
 </file>
 
@@ -13778,7 +13707,7 @@
           <p:nvPr>
             <p:extLst>
               <p:ext uri="{D42A27DB-BD31-4B8C-83A1-F6EECF244321}">
-                <p14:modId xmlns:p14="http://schemas.microsoft.com/office/powerpoint/2010/main" val="88501286"/>
+                <p14:modId xmlns:p14="http://schemas.microsoft.com/office/powerpoint/2010/main" val="63962351"/>
               </p:ext>
             </p:extLst>
           </p:nvPr>
@@ -14141,14 +14070,14 @@
                         <a:buNone/>
                       </a:pPr>
                       <a:r>
-                        <a:rPr lang="en-US" sz="1800">
+                        <a:rPr lang="en-US" sz="1800" dirty="0">
                           <a:solidFill>
                             <a:schemeClr val="bg1"/>
                           </a:solidFill>
                           <a:effectLst/>
                           <a:latin typeface="Candara" panose="020E0502030303020204" pitchFamily="34" charset="0"/>
                         </a:rPr>
-                        <a:t>Connect Arduino; run firmware (local MQTT)</a:t>
+                        <a:t>Connect Arduino; run firmware</a:t>
                       </a:r>
                     </a:p>
                   </a:txBody>
@@ -14599,27 +14528,7 @@
                           <a:effectLst/>
                           <a:latin typeface="Candara" panose="020E0502030303020204" pitchFamily="34" charset="0"/>
                         </a:rPr>
-                        <a:t>Alert appears (</a:t>
-                      </a:r>
-                      <a:r>
-                        <a:rPr lang="en-US" sz="1800" dirty="0" err="1">
-                          <a:solidFill>
-                            <a:schemeClr val="bg1"/>
-                          </a:solidFill>
-                          <a:effectLst/>
-                          <a:latin typeface="Candara" panose="020E0502030303020204" pitchFamily="34" charset="0"/>
-                        </a:rPr>
-                        <a:t>SignalR</a:t>
-                      </a:r>
-                      <a:r>
-                        <a:rPr lang="en-US" sz="1800" dirty="0">
-                          <a:solidFill>
-                            <a:schemeClr val="bg1"/>
-                          </a:solidFill>
-                          <a:effectLst/>
-                          <a:latin typeface="Candara" panose="020E0502030303020204" pitchFamily="34" charset="0"/>
-                        </a:rPr>
-                        <a:t>)</a:t>
+                        <a:t>Alert appears</a:t>
                       </a:r>
                     </a:p>
                   </a:txBody>
@@ -16777,7 +16686,7 @@
         </p:nvSpPr>
         <p:spPr>
           <a:xfrm>
-            <a:off x="1727200" y="4705741"/>
+            <a:off x="1727200" y="969904"/>
             <a:ext cx="4556117" cy="670385"/>
           </a:xfrm>
           <a:prstGeom prst="rect">
@@ -17085,7 +16994,7 @@
                 </a:solidFill>
                 <a:latin typeface="Candara" panose="020E0502030303020204" pitchFamily="34" charset="0"/>
               </a:rPr>
-              <a:t>I would like to express my sincere gratitude to the instructors, especially Naser Chowdhury, for their guidance and support throughout the past two years. I would also like to thank RTC School for giving me the opportunity to achieve my first educational milestone in the United States, and my classmates and colleagues for their hard work, dedication, and support as we balanced work and study together to reach this achievement.</a:t>
+              <a:t>I would like to express my sincere gratitude to the instructors, especially Naser Chowdhury, for the guidance and support throughout the past two years. I would also like to thank RTC School for giving me the opportunity to achieve my first educational milestone in the United States, and my classmates and colleagues for their hard work, dedication, and support as we balanced work and study together to reach this achievement.</a:t>
             </a:r>
             <a:endParaRPr kumimoji="0" lang="en-US" sz="1600" b="0" u="none" strike="noStrike" kern="1200" cap="none" spc="0" normalizeH="0" baseline="0" noProof="0" dirty="0">
               <a:ln>
@@ -17104,10 +17013,10 @@
       </p:sp>
       <p:sp>
         <p:nvSpPr>
-          <p:cNvPr id="3" name="TextBox 2">
+          <p:cNvPr id="5" name="TextBox 4">
             <a:extLst>
               <a:ext uri="{FF2B5EF4-FFF2-40B4-BE49-F238E27FC236}">
-                <a16:creationId xmlns:a16="http://schemas.microsoft.com/office/drawing/2014/main" id="{8A007543-48F6-8493-80CF-D65E66082C51}"/>
+                <a16:creationId xmlns:a16="http://schemas.microsoft.com/office/drawing/2014/main" id="{FA09E5FA-DB4E-A610-E8C1-21624C372F45}"/>
               </a:ext>
             </a:extLst>
           </p:cNvPr>
@@ -17116,7 +17025,7 @@
         </p:nvSpPr>
         <p:spPr>
           <a:xfrm>
-            <a:off x="1530220" y="860041"/>
+            <a:off x="4864262" y="4703483"/>
             <a:ext cx="5822302" cy="830997"/>
           </a:xfrm>
           <a:prstGeom prst="rect">
@@ -30194,7 +30103,7 @@
                 <a:ea typeface="Calibri" pitchFamily="34" charset="-122"/>
                 <a:cs typeface="Calibri" pitchFamily="34" charset="-120"/>
               </a:rPr>
-              <a:t>11 tables  •  Devices = central hub  •  Key fields and relationships shown</a:t>
+              <a:t>8 tables  •  Devices = central hub  •  Key fields and relationships shown</a:t>
             </a:r>
             <a:endParaRPr lang="en-US" sz="1200" dirty="0">
               <a:latin typeface="Candara" panose="020E0502030303020204" pitchFamily="34" charset="0"/>
@@ -30300,70 +30209,6 @@
       </p:sp>
       <p:sp>
         <p:nvSpPr>
-          <p:cNvPr id="7" name="Shape 5"/>
-          <p:cNvSpPr/>
-          <p:nvPr/>
-        </p:nvSpPr>
-        <p:spPr>
-          <a:xfrm flipV="1">
-            <a:off x="7084754" y="3100816"/>
-            <a:ext cx="2559653" cy="281562"/>
-          </a:xfrm>
-          <a:prstGeom prst="line">
-            <a:avLst/>
-          </a:prstGeom>
-          <a:noFill/>
-          <a:ln w="19050">
-            <a:solidFill>
-              <a:srgbClr val="3ECF80"/>
-            </a:solidFill>
-            <a:prstDash val="solid"/>
-          </a:ln>
-        </p:spPr>
-        <p:txBody>
-          <a:bodyPr/>
-          <a:lstStyle/>
-          <a:p>
-            <a:endParaRPr lang="en-US" sz="1799">
-              <a:latin typeface="Candara" panose="020E0502030303020204" pitchFamily="34" charset="0"/>
-            </a:endParaRPr>
-          </a:p>
-        </p:txBody>
-      </p:sp>
-      <p:sp>
-        <p:nvSpPr>
-          <p:cNvPr id="8" name="Shape 6"/>
-          <p:cNvSpPr/>
-          <p:nvPr/>
-        </p:nvSpPr>
-        <p:spPr>
-          <a:xfrm>
-            <a:off x="7084754" y="3704163"/>
-            <a:ext cx="2559653" cy="537527"/>
-          </a:xfrm>
-          <a:prstGeom prst="line">
-            <a:avLst/>
-          </a:prstGeom>
-          <a:noFill/>
-          <a:ln w="19050">
-            <a:solidFill>
-              <a:srgbClr val="3ECF80"/>
-            </a:solidFill>
-            <a:prstDash val="solid"/>
-          </a:ln>
-        </p:spPr>
-        <p:txBody>
-          <a:bodyPr/>
-          <a:lstStyle/>
-          <a:p>
-            <a:endParaRPr lang="en-US" sz="1799">
-              <a:latin typeface="Candara" panose="020E0502030303020204" pitchFamily="34" charset="0"/>
-            </a:endParaRPr>
-          </a:p>
-        </p:txBody>
-      </p:sp>
-      <p:sp>
-        <p:nvSpPr>
           <p:cNvPr id="9" name="Shape 7"/>
           <p:cNvSpPr/>
           <p:nvPr/>
@@ -30372,38 +30217,6 @@
           <a:xfrm>
             <a:off x="7084754" y="4025947"/>
             <a:ext cx="2559653" cy="1356617"/>
-          </a:xfrm>
-          <a:prstGeom prst="line">
-            <a:avLst/>
-          </a:prstGeom>
-          <a:noFill/>
-          <a:ln w="19050">
-            <a:solidFill>
-              <a:srgbClr val="3ECF80"/>
-            </a:solidFill>
-            <a:prstDash val="solid"/>
-          </a:ln>
-        </p:spPr>
-        <p:txBody>
-          <a:bodyPr/>
-          <a:lstStyle/>
-          <a:p>
-            <a:endParaRPr lang="en-US" sz="1799">
-              <a:latin typeface="Candara" panose="020E0502030303020204" pitchFamily="34" charset="0"/>
-            </a:endParaRPr>
-          </a:p>
-        </p:txBody>
-      </p:sp>
-      <p:sp>
-        <p:nvSpPr>
-          <p:cNvPr id="10" name="Shape 8"/>
-          <p:cNvSpPr/>
-          <p:nvPr/>
-        </p:nvSpPr>
-        <p:spPr>
-          <a:xfrm flipV="1">
-            <a:off x="4316367" y="4059772"/>
-            <a:ext cx="1148797" cy="1060428"/>
           </a:xfrm>
           <a:prstGeom prst="line">
             <a:avLst/>
@@ -33977,13 +33790,13 @@
       </p:sp>
       <p:sp>
         <p:nvSpPr>
-          <p:cNvPr id="107" name="Shape 105"/>
-          <p:cNvSpPr/>
-          <p:nvPr/>
-        </p:nvSpPr>
-        <p:spPr>
-          <a:xfrm>
-            <a:off x="9671832" y="2450847"/>
+          <p:cNvPr id="124" name="Shape 122"/>
+          <p:cNvSpPr/>
+          <p:nvPr/>
+        </p:nvSpPr>
+        <p:spPr>
+          <a:xfrm>
+            <a:off x="9671832" y="3913506"/>
             <a:ext cx="2011156" cy="1133561"/>
           </a:xfrm>
           <a:prstGeom prst="roundRect">
@@ -34015,611 +33828,13 @@
       </p:sp>
       <p:sp>
         <p:nvSpPr>
-          <p:cNvPr id="108" name="Shape 106"/>
-          <p:cNvSpPr/>
-          <p:nvPr/>
-        </p:nvSpPr>
-        <p:spPr>
-          <a:xfrm>
-            <a:off x="9644407" y="2423422"/>
-            <a:ext cx="2011156" cy="1133561"/>
-          </a:xfrm>
-          <a:prstGeom prst="roundRect">
-            <a:avLst>
-              <a:gd name="adj" fmla="val 6452"/>
-            </a:avLst>
-          </a:prstGeom>
-          <a:solidFill>
-            <a:srgbClr val="112B1D"/>
-          </a:solidFill>
-          <a:ln w="9525">
-            <a:solidFill>
-              <a:srgbClr val="1E3D2A"/>
-            </a:solidFill>
-            <a:prstDash val="solid"/>
-          </a:ln>
-        </p:spPr>
-        <p:txBody>
-          <a:bodyPr/>
-          <a:lstStyle/>
-          <a:p>
-            <a:endParaRPr lang="en-US" sz="1799">
-              <a:latin typeface="Candara" panose="020E0502030303020204" pitchFamily="34" charset="0"/>
-            </a:endParaRPr>
-          </a:p>
-        </p:txBody>
-      </p:sp>
-      <p:sp>
-        <p:nvSpPr>
-          <p:cNvPr id="109" name="Shape 107"/>
-          <p:cNvSpPr/>
-          <p:nvPr/>
-        </p:nvSpPr>
-        <p:spPr>
-          <a:xfrm>
-            <a:off x="9644407" y="2496555"/>
-            <a:ext cx="50279" cy="987295"/>
-          </a:xfrm>
-          <a:prstGeom prst="rect">
-            <a:avLst/>
-          </a:prstGeom>
-          <a:solidFill>
-            <a:srgbClr val="1B5C3A"/>
-          </a:solidFill>
-          <a:ln w="12700">
-            <a:solidFill>
-              <a:srgbClr val="1B5C3A"/>
-            </a:solidFill>
-            <a:prstDash val="solid"/>
-          </a:ln>
-        </p:spPr>
-        <p:txBody>
-          <a:bodyPr/>
-          <a:lstStyle/>
-          <a:p>
-            <a:endParaRPr lang="en-US" sz="1799">
-              <a:latin typeface="Candara" panose="020E0502030303020204" pitchFamily="34" charset="0"/>
-            </a:endParaRPr>
-          </a:p>
-        </p:txBody>
-      </p:sp>
-      <p:sp>
-        <p:nvSpPr>
-          <p:cNvPr id="110" name="Shape 108"/>
-          <p:cNvSpPr/>
-          <p:nvPr/>
-        </p:nvSpPr>
-        <p:spPr>
-          <a:xfrm>
-            <a:off x="9644407" y="2423422"/>
-            <a:ext cx="50279" cy="164549"/>
-          </a:xfrm>
-          <a:prstGeom prst="roundRect">
-            <a:avLst>
-              <a:gd name="adj" fmla="val 72727"/>
-            </a:avLst>
-          </a:prstGeom>
-          <a:solidFill>
-            <a:srgbClr val="1B5C3A"/>
-          </a:solidFill>
-          <a:ln w="12700">
-            <a:solidFill>
-              <a:srgbClr val="1B5C3A"/>
-            </a:solidFill>
-            <a:prstDash val="solid"/>
-          </a:ln>
-        </p:spPr>
-        <p:txBody>
-          <a:bodyPr/>
-          <a:lstStyle/>
-          <a:p>
-            <a:endParaRPr lang="en-US" sz="1799">
-              <a:latin typeface="Candara" panose="020E0502030303020204" pitchFamily="34" charset="0"/>
-            </a:endParaRPr>
-          </a:p>
-        </p:txBody>
-      </p:sp>
-      <p:sp>
-        <p:nvSpPr>
-          <p:cNvPr id="111" name="Text 109"/>
-          <p:cNvSpPr/>
-          <p:nvPr/>
-        </p:nvSpPr>
-        <p:spPr>
-          <a:xfrm>
-            <a:off x="9790673" y="2441705"/>
-            <a:ext cx="1810041" cy="237682"/>
-          </a:xfrm>
-          <a:prstGeom prst="rect">
-            <a:avLst/>
-          </a:prstGeom>
-          <a:noFill/>
-          <a:ln/>
-        </p:spPr>
-        <p:txBody>
-          <a:bodyPr wrap="square" lIns="0" tIns="0" rIns="0" bIns="0" rtlCol="0" anchor="ctr"/>
-          <a:lstStyle/>
-          <a:p>
-            <a:r>
-              <a:rPr lang="en-US" sz="1100" b="1" dirty="0">
-                <a:solidFill>
-                  <a:srgbClr val="3ECF80"/>
-                </a:solidFill>
-                <a:latin typeface="Candara" panose="020E0502030303020204" pitchFamily="34" charset="0"/>
-                <a:ea typeface="Calibri" pitchFamily="34" charset="-122"/>
-                <a:cs typeface="Calibri" pitchFamily="34" charset="-120"/>
-              </a:rPr>
-              <a:t>DeviceStatusHistories</a:t>
-            </a:r>
-            <a:endParaRPr lang="en-US" sz="1100" dirty="0">
-              <a:latin typeface="Candara" panose="020E0502030303020204" pitchFamily="34" charset="0"/>
-            </a:endParaRPr>
-          </a:p>
-        </p:txBody>
-      </p:sp>
-      <p:sp>
-        <p:nvSpPr>
-          <p:cNvPr id="112" name="Text 110"/>
-          <p:cNvSpPr/>
-          <p:nvPr/>
-        </p:nvSpPr>
-        <p:spPr>
-          <a:xfrm>
-            <a:off x="9790673" y="2715954"/>
-            <a:ext cx="1810041" cy="164549"/>
-          </a:xfrm>
-          <a:prstGeom prst="rect">
-            <a:avLst/>
-          </a:prstGeom>
-          <a:noFill/>
-          <a:ln/>
-        </p:spPr>
-        <p:txBody>
-          <a:bodyPr wrap="square" lIns="0" tIns="0" rIns="0" bIns="0" rtlCol="0" anchor="t"/>
-          <a:lstStyle/>
-          <a:p>
-            <a:r>
-              <a:rPr lang="en-US" sz="850" i="1" dirty="0">
-                <a:solidFill>
-                  <a:srgbClr val="7AB896"/>
-                </a:solidFill>
-                <a:latin typeface="Candara" panose="020E0502030303020204" pitchFamily="34" charset="0"/>
-                <a:ea typeface="Calibri" pitchFamily="34" charset="-122"/>
-                <a:cs typeface="Calibri" pitchFamily="34" charset="-120"/>
-              </a:rPr>
-              <a:t>Device status change log</a:t>
-            </a:r>
-            <a:endParaRPr lang="en-US" sz="850" dirty="0">
-              <a:latin typeface="Candara" panose="020E0502030303020204" pitchFamily="34" charset="0"/>
-            </a:endParaRPr>
-          </a:p>
-        </p:txBody>
-      </p:sp>
-      <p:sp>
-        <p:nvSpPr>
-          <p:cNvPr id="113" name="Shape 111"/>
-          <p:cNvSpPr/>
-          <p:nvPr/>
-        </p:nvSpPr>
-        <p:spPr>
-          <a:xfrm>
-            <a:off x="9772390" y="2898786"/>
-            <a:ext cx="1828324" cy="0"/>
-          </a:xfrm>
-          <a:prstGeom prst="line">
-            <a:avLst/>
-          </a:prstGeom>
-          <a:noFill/>
-          <a:ln w="9525">
-            <a:solidFill>
-              <a:srgbClr val="1E3D2A"/>
-            </a:solidFill>
-            <a:prstDash val="solid"/>
-          </a:ln>
-        </p:spPr>
-        <p:txBody>
-          <a:bodyPr/>
-          <a:lstStyle/>
-          <a:p>
-            <a:endParaRPr lang="en-US" sz="1799">
-              <a:latin typeface="Candara" panose="020E0502030303020204" pitchFamily="34" charset="0"/>
-            </a:endParaRPr>
-          </a:p>
-        </p:txBody>
-      </p:sp>
-      <p:sp>
-        <p:nvSpPr>
-          <p:cNvPr id="114" name="Text 112"/>
-          <p:cNvSpPr/>
-          <p:nvPr/>
-        </p:nvSpPr>
-        <p:spPr>
-          <a:xfrm>
-            <a:off x="9790673" y="2935353"/>
-            <a:ext cx="274249" cy="141695"/>
-          </a:xfrm>
-          <a:prstGeom prst="rect">
-            <a:avLst/>
-          </a:prstGeom>
-          <a:noFill/>
-          <a:ln/>
-        </p:spPr>
-        <p:txBody>
-          <a:bodyPr wrap="square" lIns="0" tIns="0" rIns="0" bIns="0" rtlCol="0" anchor="ctr"/>
-          <a:lstStyle/>
-          <a:p>
-            <a:r>
-              <a:rPr lang="en-US" sz="700" b="1" dirty="0">
-                <a:solidFill>
-                  <a:srgbClr val="F6C90E"/>
-                </a:solidFill>
-                <a:latin typeface="Candara" panose="020E0502030303020204" pitchFamily="34" charset="0"/>
-                <a:ea typeface="Calibri" pitchFamily="34" charset="-122"/>
-                <a:cs typeface="Calibri" pitchFamily="34" charset="-120"/>
-              </a:rPr>
-              <a:t>PK</a:t>
-            </a:r>
-            <a:endParaRPr lang="en-US" sz="700" dirty="0">
-              <a:latin typeface="Candara" panose="020E0502030303020204" pitchFamily="34" charset="0"/>
-            </a:endParaRPr>
-          </a:p>
-        </p:txBody>
-      </p:sp>
-      <p:sp>
-        <p:nvSpPr>
-          <p:cNvPr id="115" name="Text 113"/>
-          <p:cNvSpPr/>
-          <p:nvPr/>
-        </p:nvSpPr>
-        <p:spPr>
-          <a:xfrm>
-            <a:off x="10083205" y="2935353"/>
-            <a:ext cx="1005578" cy="141695"/>
-          </a:xfrm>
-          <a:prstGeom prst="rect">
-            <a:avLst/>
-          </a:prstGeom>
-          <a:noFill/>
-          <a:ln/>
-        </p:spPr>
-        <p:txBody>
-          <a:bodyPr wrap="square" lIns="0" tIns="0" rIns="0" bIns="0" rtlCol="0" anchor="ctr"/>
-          <a:lstStyle/>
-          <a:p>
-            <a:r>
-              <a:rPr lang="en-US" sz="850" b="1" dirty="0">
-                <a:solidFill>
-                  <a:srgbClr val="FFFFFF"/>
-                </a:solidFill>
-                <a:latin typeface="Candara" panose="020E0502030303020204" pitchFamily="34" charset="0"/>
-                <a:ea typeface="Calibri" pitchFamily="34" charset="-122"/>
-                <a:cs typeface="Calibri" pitchFamily="34" charset="-120"/>
-              </a:rPr>
-              <a:t>StatusHistoryId</a:t>
-            </a:r>
-            <a:endParaRPr lang="en-US" sz="850" dirty="0">
-              <a:latin typeface="Candara" panose="020E0502030303020204" pitchFamily="34" charset="0"/>
-            </a:endParaRPr>
-          </a:p>
-        </p:txBody>
-      </p:sp>
-      <p:sp>
-        <p:nvSpPr>
-          <p:cNvPr id="116" name="Text 114"/>
-          <p:cNvSpPr/>
-          <p:nvPr/>
-        </p:nvSpPr>
-        <p:spPr>
-          <a:xfrm>
-            <a:off x="11088783" y="2935353"/>
-            <a:ext cx="475364" cy="141695"/>
-          </a:xfrm>
-          <a:prstGeom prst="rect">
-            <a:avLst/>
-          </a:prstGeom>
-          <a:noFill/>
-          <a:ln/>
-        </p:spPr>
-        <p:txBody>
-          <a:bodyPr wrap="square" lIns="0" tIns="0" rIns="0" bIns="0" rtlCol="0" anchor="ctr"/>
-          <a:lstStyle/>
-          <a:p>
-            <a:pPr algn="r"/>
-            <a:r>
-              <a:rPr lang="en-US" sz="750" dirty="0">
-                <a:solidFill>
-                  <a:srgbClr val="4D8C6A"/>
-                </a:solidFill>
-                <a:latin typeface="Candara" panose="020E0502030303020204" pitchFamily="34" charset="0"/>
-                <a:ea typeface="Calibri" pitchFamily="34" charset="-122"/>
-                <a:cs typeface="Calibri" pitchFamily="34" charset="-120"/>
-              </a:rPr>
-              <a:t>long</a:t>
-            </a:r>
-            <a:endParaRPr lang="en-US" sz="750" dirty="0">
-              <a:latin typeface="Candara" panose="020E0502030303020204" pitchFamily="34" charset="0"/>
-            </a:endParaRPr>
-          </a:p>
-        </p:txBody>
-      </p:sp>
-      <p:sp>
-        <p:nvSpPr>
-          <p:cNvPr id="117" name="Text 115"/>
-          <p:cNvSpPr/>
-          <p:nvPr/>
-        </p:nvSpPr>
-        <p:spPr>
-          <a:xfrm>
-            <a:off x="9790673" y="3077048"/>
-            <a:ext cx="274249" cy="141695"/>
-          </a:xfrm>
-          <a:prstGeom prst="rect">
-            <a:avLst/>
-          </a:prstGeom>
-          <a:noFill/>
-          <a:ln/>
-        </p:spPr>
-        <p:txBody>
-          <a:bodyPr wrap="square" lIns="0" tIns="0" rIns="0" bIns="0" rtlCol="0" anchor="ctr"/>
-          <a:lstStyle/>
-          <a:p>
-            <a:r>
-              <a:rPr lang="en-US" sz="700" b="1" dirty="0">
-                <a:solidFill>
-                  <a:srgbClr val="60B8FF"/>
-                </a:solidFill>
-                <a:latin typeface="Candara" panose="020E0502030303020204" pitchFamily="34" charset="0"/>
-                <a:ea typeface="Calibri" pitchFamily="34" charset="-122"/>
-                <a:cs typeface="Calibri" pitchFamily="34" charset="-120"/>
-              </a:rPr>
-              <a:t>FK</a:t>
-            </a:r>
-            <a:endParaRPr lang="en-US" sz="700" dirty="0">
-              <a:latin typeface="Candara" panose="020E0502030303020204" pitchFamily="34" charset="0"/>
-            </a:endParaRPr>
-          </a:p>
-        </p:txBody>
-      </p:sp>
-      <p:sp>
-        <p:nvSpPr>
-          <p:cNvPr id="118" name="Text 116"/>
-          <p:cNvSpPr/>
-          <p:nvPr/>
-        </p:nvSpPr>
-        <p:spPr>
-          <a:xfrm>
-            <a:off x="10083205" y="3077048"/>
-            <a:ext cx="1005578" cy="141695"/>
-          </a:xfrm>
-          <a:prstGeom prst="rect">
-            <a:avLst/>
-          </a:prstGeom>
-          <a:noFill/>
-          <a:ln/>
-        </p:spPr>
-        <p:txBody>
-          <a:bodyPr wrap="square" lIns="0" tIns="0" rIns="0" bIns="0" rtlCol="0" anchor="ctr"/>
-          <a:lstStyle/>
-          <a:p>
-            <a:r>
-              <a:rPr lang="en-US" sz="850" i="1" dirty="0">
-                <a:solidFill>
-                  <a:srgbClr val="7AB896"/>
-                </a:solidFill>
-                <a:latin typeface="Candara" panose="020E0502030303020204" pitchFamily="34" charset="0"/>
-                <a:ea typeface="Calibri" pitchFamily="34" charset="-122"/>
-                <a:cs typeface="Calibri" pitchFamily="34" charset="-120"/>
-              </a:rPr>
-              <a:t>DeviceId</a:t>
-            </a:r>
-            <a:endParaRPr lang="en-US" sz="850" dirty="0">
-              <a:latin typeface="Candara" panose="020E0502030303020204" pitchFamily="34" charset="0"/>
-            </a:endParaRPr>
-          </a:p>
-        </p:txBody>
-      </p:sp>
-      <p:sp>
-        <p:nvSpPr>
-          <p:cNvPr id="119" name="Text 117"/>
-          <p:cNvSpPr/>
-          <p:nvPr/>
-        </p:nvSpPr>
-        <p:spPr>
-          <a:xfrm>
-            <a:off x="11088783" y="3077048"/>
-            <a:ext cx="475364" cy="141695"/>
-          </a:xfrm>
-          <a:prstGeom prst="rect">
-            <a:avLst/>
-          </a:prstGeom>
-          <a:noFill/>
-          <a:ln/>
-        </p:spPr>
-        <p:txBody>
-          <a:bodyPr wrap="square" lIns="0" tIns="0" rIns="0" bIns="0" rtlCol="0" anchor="ctr"/>
-          <a:lstStyle/>
-          <a:p>
-            <a:pPr algn="r"/>
-            <a:r>
-              <a:rPr lang="en-US" sz="750" dirty="0">
-                <a:solidFill>
-                  <a:srgbClr val="4D8C6A"/>
-                </a:solidFill>
-                <a:latin typeface="Candara" panose="020E0502030303020204" pitchFamily="34" charset="0"/>
-                <a:ea typeface="Calibri" pitchFamily="34" charset="-122"/>
-                <a:cs typeface="Calibri" pitchFamily="34" charset="-120"/>
-              </a:rPr>
-              <a:t>int</a:t>
-            </a:r>
-            <a:endParaRPr lang="en-US" sz="750" dirty="0">
-              <a:latin typeface="Candara" panose="020E0502030303020204" pitchFamily="34" charset="0"/>
-            </a:endParaRPr>
-          </a:p>
-        </p:txBody>
-      </p:sp>
-      <p:sp>
-        <p:nvSpPr>
-          <p:cNvPr id="120" name="Text 118"/>
-          <p:cNvSpPr/>
-          <p:nvPr/>
-        </p:nvSpPr>
-        <p:spPr>
-          <a:xfrm>
-            <a:off x="10083205" y="3218743"/>
-            <a:ext cx="1005578" cy="141695"/>
-          </a:xfrm>
-          <a:prstGeom prst="rect">
-            <a:avLst/>
-          </a:prstGeom>
-          <a:noFill/>
-          <a:ln/>
-        </p:spPr>
-        <p:txBody>
-          <a:bodyPr wrap="square" lIns="0" tIns="0" rIns="0" bIns="0" rtlCol="0" anchor="ctr"/>
-          <a:lstStyle/>
-          <a:p>
-            <a:r>
-              <a:rPr lang="en-US" sz="850" dirty="0">
-                <a:solidFill>
-                  <a:srgbClr val="FFFFFF"/>
-                </a:solidFill>
-                <a:latin typeface="Candara" panose="020E0502030303020204" pitchFamily="34" charset="0"/>
-                <a:ea typeface="Calibri" pitchFamily="34" charset="-122"/>
-                <a:cs typeface="Calibri" pitchFamily="34" charset="-120"/>
-              </a:rPr>
-              <a:t>Status</a:t>
-            </a:r>
-            <a:endParaRPr lang="en-US" sz="850" dirty="0">
-              <a:latin typeface="Candara" panose="020E0502030303020204" pitchFamily="34" charset="0"/>
-            </a:endParaRPr>
-          </a:p>
-        </p:txBody>
-      </p:sp>
-      <p:sp>
-        <p:nvSpPr>
-          <p:cNvPr id="121" name="Text 119"/>
-          <p:cNvSpPr/>
-          <p:nvPr/>
-        </p:nvSpPr>
-        <p:spPr>
-          <a:xfrm>
-            <a:off x="11088783" y="3218743"/>
-            <a:ext cx="475364" cy="141695"/>
-          </a:xfrm>
-          <a:prstGeom prst="rect">
-            <a:avLst/>
-          </a:prstGeom>
-          <a:noFill/>
-          <a:ln/>
-        </p:spPr>
-        <p:txBody>
-          <a:bodyPr wrap="square" lIns="0" tIns="0" rIns="0" bIns="0" rtlCol="0" anchor="ctr"/>
-          <a:lstStyle/>
-          <a:p>
-            <a:pPr algn="r"/>
-            <a:r>
-              <a:rPr lang="en-US" sz="750" dirty="0">
-                <a:solidFill>
-                  <a:srgbClr val="4D8C6A"/>
-                </a:solidFill>
-                <a:latin typeface="Candara" panose="020E0502030303020204" pitchFamily="34" charset="0"/>
-                <a:ea typeface="Calibri" pitchFamily="34" charset="-122"/>
-                <a:cs typeface="Calibri" pitchFamily="34" charset="-120"/>
-              </a:rPr>
-              <a:t>string(50)</a:t>
-            </a:r>
-            <a:endParaRPr lang="en-US" sz="750" dirty="0">
-              <a:latin typeface="Candara" panose="020E0502030303020204" pitchFamily="34" charset="0"/>
-            </a:endParaRPr>
-          </a:p>
-        </p:txBody>
-      </p:sp>
-      <p:sp>
-        <p:nvSpPr>
-          <p:cNvPr id="122" name="Text 120"/>
-          <p:cNvSpPr/>
-          <p:nvPr/>
-        </p:nvSpPr>
-        <p:spPr>
-          <a:xfrm>
-            <a:off x="10083205" y="3360438"/>
-            <a:ext cx="1005578" cy="141695"/>
-          </a:xfrm>
-          <a:prstGeom prst="rect">
-            <a:avLst/>
-          </a:prstGeom>
-          <a:noFill/>
-          <a:ln/>
-        </p:spPr>
-        <p:txBody>
-          <a:bodyPr wrap="square" lIns="0" tIns="0" rIns="0" bIns="0" rtlCol="0" anchor="ctr"/>
-          <a:lstStyle/>
-          <a:p>
-            <a:r>
-              <a:rPr lang="en-US" sz="850" dirty="0">
-                <a:solidFill>
-                  <a:srgbClr val="FFFFFF"/>
-                </a:solidFill>
-                <a:latin typeface="Candara" panose="020E0502030303020204" pitchFamily="34" charset="0"/>
-                <a:ea typeface="Calibri" pitchFamily="34" charset="-122"/>
-                <a:cs typeface="Calibri" pitchFamily="34" charset="-120"/>
-              </a:rPr>
-              <a:t>Timestamp</a:t>
-            </a:r>
-            <a:endParaRPr lang="en-US" sz="850" dirty="0">
-              <a:latin typeface="Candara" panose="020E0502030303020204" pitchFamily="34" charset="0"/>
-            </a:endParaRPr>
-          </a:p>
-        </p:txBody>
-      </p:sp>
-      <p:sp>
-        <p:nvSpPr>
-          <p:cNvPr id="123" name="Text 121"/>
-          <p:cNvSpPr/>
-          <p:nvPr/>
-        </p:nvSpPr>
-        <p:spPr>
-          <a:xfrm>
-            <a:off x="11088783" y="3360438"/>
-            <a:ext cx="475364" cy="141695"/>
-          </a:xfrm>
-          <a:prstGeom prst="rect">
-            <a:avLst/>
-          </a:prstGeom>
-          <a:noFill/>
-          <a:ln/>
-        </p:spPr>
-        <p:txBody>
-          <a:bodyPr wrap="square" lIns="0" tIns="0" rIns="0" bIns="0" rtlCol="0" anchor="ctr"/>
-          <a:lstStyle/>
-          <a:p>
-            <a:pPr algn="r"/>
-            <a:r>
-              <a:rPr lang="en-US" sz="750" dirty="0">
-                <a:solidFill>
-                  <a:srgbClr val="4D8C6A"/>
-                </a:solidFill>
-                <a:latin typeface="Candara" panose="020E0502030303020204" pitchFamily="34" charset="0"/>
-                <a:ea typeface="Calibri" pitchFamily="34" charset="-122"/>
-                <a:cs typeface="Calibri" pitchFamily="34" charset="-120"/>
-              </a:rPr>
-              <a:t>DateTime</a:t>
-            </a:r>
-            <a:endParaRPr lang="en-US" sz="750" dirty="0">
-              <a:latin typeface="Candara" panose="020E0502030303020204" pitchFamily="34" charset="0"/>
-            </a:endParaRPr>
-          </a:p>
-        </p:txBody>
-      </p:sp>
-      <p:sp>
-        <p:nvSpPr>
-          <p:cNvPr id="124" name="Shape 122"/>
-          <p:cNvSpPr/>
-          <p:nvPr/>
-        </p:nvSpPr>
-        <p:spPr>
-          <a:xfrm>
-            <a:off x="9671832" y="3913506"/>
+          <p:cNvPr id="141" name="Shape 139"/>
+          <p:cNvSpPr/>
+          <p:nvPr/>
+        </p:nvSpPr>
+        <p:spPr>
+          <a:xfrm>
+            <a:off x="9671832" y="5376165"/>
             <a:ext cx="2011156" cy="1133561"/>
           </a:xfrm>
           <a:prstGeom prst="roundRect">
@@ -34651,13 +33866,13 @@
       </p:sp>
       <p:sp>
         <p:nvSpPr>
-          <p:cNvPr id="125" name="Shape 123"/>
-          <p:cNvSpPr/>
-          <p:nvPr/>
-        </p:nvSpPr>
-        <p:spPr>
-          <a:xfrm>
-            <a:off x="9644407" y="3886081"/>
+          <p:cNvPr id="142" name="Shape 140"/>
+          <p:cNvSpPr/>
+          <p:nvPr/>
+        </p:nvSpPr>
+        <p:spPr>
+          <a:xfrm>
+            <a:off x="9644407" y="5348740"/>
             <a:ext cx="2011156" cy="1133561"/>
           </a:xfrm>
           <a:prstGeom prst="roundRect">
@@ -34687,13 +33902,13 @@
       </p:sp>
       <p:sp>
         <p:nvSpPr>
-          <p:cNvPr id="126" name="Shape 124"/>
-          <p:cNvSpPr/>
-          <p:nvPr/>
-        </p:nvSpPr>
-        <p:spPr>
-          <a:xfrm>
-            <a:off x="9644407" y="3959214"/>
+          <p:cNvPr id="143" name="Shape 141"/>
+          <p:cNvSpPr/>
+          <p:nvPr/>
+        </p:nvSpPr>
+        <p:spPr>
+          <a:xfrm>
+            <a:off x="9644407" y="5421873"/>
             <a:ext cx="50279" cy="987295"/>
           </a:xfrm>
           <a:prstGeom prst="rect">
@@ -34721,13 +33936,13 @@
       </p:sp>
       <p:sp>
         <p:nvSpPr>
-          <p:cNvPr id="127" name="Shape 125"/>
-          <p:cNvSpPr/>
-          <p:nvPr/>
-        </p:nvSpPr>
-        <p:spPr>
-          <a:xfrm>
-            <a:off x="9644407" y="3886081"/>
+          <p:cNvPr id="144" name="Shape 142"/>
+          <p:cNvSpPr/>
+          <p:nvPr/>
+        </p:nvSpPr>
+        <p:spPr>
+          <a:xfrm>
+            <a:off x="9644407" y="5348740"/>
             <a:ext cx="50279" cy="164549"/>
           </a:xfrm>
           <a:prstGeom prst="roundRect">
@@ -34757,13 +33972,13 @@
       </p:sp>
       <p:sp>
         <p:nvSpPr>
-          <p:cNvPr id="128" name="Text 126"/>
-          <p:cNvSpPr/>
-          <p:nvPr/>
-        </p:nvSpPr>
-        <p:spPr>
-          <a:xfrm>
-            <a:off x="9790673" y="3904364"/>
+          <p:cNvPr id="145" name="Text 143"/>
+          <p:cNvSpPr/>
+          <p:nvPr/>
+        </p:nvSpPr>
+        <p:spPr>
+          <a:xfrm>
+            <a:off x="9790673" y="5367023"/>
             <a:ext cx="1810041" cy="237682"/>
           </a:xfrm>
           <a:prstGeom prst="rect">
@@ -34785,7 +34000,7 @@
                 <a:ea typeface="Calibri" pitchFamily="34" charset="-122"/>
                 <a:cs typeface="Calibri" pitchFamily="34" charset="-120"/>
               </a:rPr>
-              <a:t>OperationalMetrics</a:t>
+              <a:t>Alerts</a:t>
             </a:r>
             <a:endParaRPr lang="en-US" sz="1100" dirty="0">
               <a:latin typeface="Candara" panose="020E0502030303020204" pitchFamily="34" charset="0"/>
@@ -34795,13 +34010,13 @@
       </p:sp>
       <p:sp>
         <p:nvSpPr>
-          <p:cNvPr id="129" name="Text 127"/>
-          <p:cNvSpPr/>
-          <p:nvPr/>
-        </p:nvSpPr>
-        <p:spPr>
-          <a:xfrm>
-            <a:off x="9790673" y="4178613"/>
+          <p:cNvPr id="146" name="Text 144"/>
+          <p:cNvSpPr/>
+          <p:nvPr/>
+        </p:nvSpPr>
+        <p:spPr>
+          <a:xfrm>
+            <a:off x="9790673" y="5641272"/>
             <a:ext cx="1810041" cy="164549"/>
           </a:xfrm>
           <a:prstGeom prst="rect">
@@ -34823,7 +34038,7 @@
                 <a:ea typeface="Calibri" pitchFamily="34" charset="-122"/>
                 <a:cs typeface="Calibri" pitchFamily="34" charset="-120"/>
               </a:rPr>
-              <a:t>Calculated KPIs per device</a:t>
+              <a:t>Fired alert records</a:t>
             </a:r>
             <a:endParaRPr lang="en-US" sz="850" dirty="0">
               <a:latin typeface="Candara" panose="020E0502030303020204" pitchFamily="34" charset="0"/>
@@ -34833,13 +34048,13 @@
       </p:sp>
       <p:sp>
         <p:nvSpPr>
-          <p:cNvPr id="130" name="Shape 128"/>
-          <p:cNvSpPr/>
-          <p:nvPr/>
-        </p:nvSpPr>
-        <p:spPr>
-          <a:xfrm>
-            <a:off x="9772390" y="4361445"/>
+          <p:cNvPr id="147" name="Shape 145"/>
+          <p:cNvSpPr/>
+          <p:nvPr/>
+        </p:nvSpPr>
+        <p:spPr>
+          <a:xfrm>
+            <a:off x="9772390" y="5824104"/>
             <a:ext cx="1828324" cy="0"/>
           </a:xfrm>
           <a:prstGeom prst="line">
@@ -34865,13 +34080,13 @@
       </p:sp>
       <p:sp>
         <p:nvSpPr>
-          <p:cNvPr id="131" name="Text 129"/>
-          <p:cNvSpPr/>
-          <p:nvPr/>
-        </p:nvSpPr>
-        <p:spPr>
-          <a:xfrm>
-            <a:off x="9790673" y="4398012"/>
+          <p:cNvPr id="148" name="Text 146"/>
+          <p:cNvSpPr/>
+          <p:nvPr/>
+        </p:nvSpPr>
+        <p:spPr>
+          <a:xfrm>
+            <a:off x="9790673" y="5860671"/>
             <a:ext cx="274249" cy="141695"/>
           </a:xfrm>
           <a:prstGeom prst="rect">
@@ -34903,13 +34118,13 @@
       </p:sp>
       <p:sp>
         <p:nvSpPr>
-          <p:cNvPr id="132" name="Text 130"/>
-          <p:cNvSpPr/>
-          <p:nvPr/>
-        </p:nvSpPr>
-        <p:spPr>
-          <a:xfrm>
-            <a:off x="10083205" y="4398012"/>
+          <p:cNvPr id="149" name="Text 147"/>
+          <p:cNvSpPr/>
+          <p:nvPr/>
+        </p:nvSpPr>
+        <p:spPr>
+          <a:xfrm>
+            <a:off x="10083205" y="5860671"/>
             <a:ext cx="1005578" cy="141695"/>
           </a:xfrm>
           <a:prstGeom prst="rect">
@@ -34931,7 +34146,7 @@
                 <a:ea typeface="Calibri" pitchFamily="34" charset="-122"/>
                 <a:cs typeface="Calibri" pitchFamily="34" charset="-120"/>
               </a:rPr>
-              <a:t>MetricId</a:t>
+              <a:t>AlertId</a:t>
             </a:r>
             <a:endParaRPr lang="en-US" sz="850" dirty="0">
               <a:latin typeface="Candara" panose="020E0502030303020204" pitchFamily="34" charset="0"/>
@@ -34941,13 +34156,13 @@
       </p:sp>
       <p:sp>
         <p:nvSpPr>
-          <p:cNvPr id="133" name="Text 131"/>
-          <p:cNvSpPr/>
-          <p:nvPr/>
-        </p:nvSpPr>
-        <p:spPr>
-          <a:xfrm>
-            <a:off x="11088783" y="4398012"/>
+          <p:cNvPr id="150" name="Text 148"/>
+          <p:cNvSpPr/>
+          <p:nvPr/>
+        </p:nvSpPr>
+        <p:spPr>
+          <a:xfrm>
+            <a:off x="11088783" y="5860671"/>
             <a:ext cx="475364" cy="141695"/>
           </a:xfrm>
           <a:prstGeom prst="rect">
@@ -34980,13 +34195,13 @@
       </p:sp>
       <p:sp>
         <p:nvSpPr>
-          <p:cNvPr id="134" name="Text 132"/>
-          <p:cNvSpPr/>
-          <p:nvPr/>
-        </p:nvSpPr>
-        <p:spPr>
-          <a:xfrm>
-            <a:off x="9790673" y="4539707"/>
+          <p:cNvPr id="151" name="Text 149"/>
+          <p:cNvSpPr/>
+          <p:nvPr/>
+        </p:nvSpPr>
+        <p:spPr>
+          <a:xfrm>
+            <a:off x="9790673" y="6002366"/>
             <a:ext cx="274249" cy="141695"/>
           </a:xfrm>
           <a:prstGeom prst="rect">
@@ -35018,13 +34233,13 @@
       </p:sp>
       <p:sp>
         <p:nvSpPr>
-          <p:cNvPr id="135" name="Text 133"/>
-          <p:cNvSpPr/>
-          <p:nvPr/>
-        </p:nvSpPr>
-        <p:spPr>
-          <a:xfrm>
-            <a:off x="10083205" y="4539707"/>
+          <p:cNvPr id="152" name="Text 150"/>
+          <p:cNvSpPr/>
+          <p:nvPr/>
+        </p:nvSpPr>
+        <p:spPr>
+          <a:xfrm>
+            <a:off x="10083205" y="6002366"/>
             <a:ext cx="1005578" cy="141695"/>
           </a:xfrm>
           <a:prstGeom prst="rect">
@@ -35046,7 +34261,7 @@
                 <a:ea typeface="Calibri" pitchFamily="34" charset="-122"/>
                 <a:cs typeface="Calibri" pitchFamily="34" charset="-120"/>
               </a:rPr>
-              <a:t>DeviceId</a:t>
+              <a:t>AlertRuleId</a:t>
             </a:r>
             <a:endParaRPr lang="en-US" sz="850" dirty="0">
               <a:latin typeface="Candara" panose="020E0502030303020204" pitchFamily="34" charset="0"/>
@@ -35056,13 +34271,13 @@
       </p:sp>
       <p:sp>
         <p:nvSpPr>
-          <p:cNvPr id="136" name="Text 134"/>
-          <p:cNvSpPr/>
-          <p:nvPr/>
-        </p:nvSpPr>
-        <p:spPr>
-          <a:xfrm>
-            <a:off x="11088783" y="4539707"/>
+          <p:cNvPr id="153" name="Text 151"/>
+          <p:cNvSpPr/>
+          <p:nvPr/>
+        </p:nvSpPr>
+        <p:spPr>
+          <a:xfrm>
+            <a:off x="11088783" y="6002366"/>
             <a:ext cx="475364" cy="141695"/>
           </a:xfrm>
           <a:prstGeom prst="rect">
@@ -35095,14 +34310,14 @@
       </p:sp>
       <p:sp>
         <p:nvSpPr>
-          <p:cNvPr id="137" name="Text 135"/>
-          <p:cNvSpPr/>
-          <p:nvPr/>
-        </p:nvSpPr>
-        <p:spPr>
-          <a:xfrm>
-            <a:off x="10083205" y="4681402"/>
-            <a:ext cx="1005578" cy="141695"/>
+          <p:cNvPr id="154" name="Text 152"/>
+          <p:cNvSpPr/>
+          <p:nvPr/>
+        </p:nvSpPr>
+        <p:spPr>
+          <a:xfrm>
+            <a:off x="9790673" y="6144061"/>
+            <a:ext cx="274249" cy="141695"/>
           </a:xfrm>
           <a:prstGeom prst="rect">
             <a:avLst/>
@@ -35115,32 +34330,32 @@
           <a:lstStyle/>
           <a:p>
             <a:r>
-              <a:rPr lang="en-US" sz="850" dirty="0">
-                <a:solidFill>
-                  <a:srgbClr val="FFFFFF"/>
+              <a:rPr lang="en-US" sz="700" b="1" dirty="0">
+                <a:solidFill>
+                  <a:srgbClr val="60B8FF"/>
                 </a:solidFill>
                 <a:latin typeface="Candara" panose="020E0502030303020204" pitchFamily="34" charset="0"/>
                 <a:ea typeface="Calibri" pitchFamily="34" charset="-122"/>
                 <a:cs typeface="Calibri" pitchFamily="34" charset="-120"/>
               </a:rPr>
-              <a:t>MetricType</a:t>
-            </a:r>
-            <a:endParaRPr lang="en-US" sz="850" dirty="0">
-              <a:latin typeface="Candara" panose="020E0502030303020204" pitchFamily="34" charset="0"/>
-            </a:endParaRPr>
-          </a:p>
-        </p:txBody>
-      </p:sp>
-      <p:sp>
-        <p:nvSpPr>
-          <p:cNvPr id="138" name="Text 136"/>
-          <p:cNvSpPr/>
-          <p:nvPr/>
-        </p:nvSpPr>
-        <p:spPr>
-          <a:xfrm>
-            <a:off x="11088783" y="4681402"/>
-            <a:ext cx="475364" cy="141695"/>
+              <a:t>FK</a:t>
+            </a:r>
+            <a:endParaRPr lang="en-US" sz="700" dirty="0">
+              <a:latin typeface="Candara" panose="020E0502030303020204" pitchFamily="34" charset="0"/>
+            </a:endParaRPr>
+          </a:p>
+        </p:txBody>
+      </p:sp>
+      <p:sp>
+        <p:nvSpPr>
+          <p:cNvPr id="155" name="Text 153"/>
+          <p:cNvSpPr/>
+          <p:nvPr/>
+        </p:nvSpPr>
+        <p:spPr>
+          <a:xfrm>
+            <a:off x="10083205" y="6144061"/>
+            <a:ext cx="1005578" cy="141695"/>
           </a:xfrm>
           <a:prstGeom prst="rect">
             <a:avLst/>
@@ -35152,34 +34367,33 @@
           <a:bodyPr wrap="square" lIns="0" tIns="0" rIns="0" bIns="0" rtlCol="0" anchor="ctr"/>
           <a:lstStyle/>
           <a:p>
-            <a:pPr algn="r"/>
-            <a:r>
-              <a:rPr lang="en-US" sz="750" dirty="0">
-                <a:solidFill>
-                  <a:srgbClr val="4D8C6A"/>
+            <a:r>
+              <a:rPr lang="en-US" sz="850" i="1" dirty="0">
+                <a:solidFill>
+                  <a:srgbClr val="7AB896"/>
                 </a:solidFill>
                 <a:latin typeface="Candara" panose="020E0502030303020204" pitchFamily="34" charset="0"/>
                 <a:ea typeface="Calibri" pitchFamily="34" charset="-122"/>
                 <a:cs typeface="Calibri" pitchFamily="34" charset="-120"/>
               </a:rPr>
-              <a:t>string(50)</a:t>
-            </a:r>
-            <a:endParaRPr lang="en-US" sz="750" dirty="0">
-              <a:latin typeface="Candara" panose="020E0502030303020204" pitchFamily="34" charset="0"/>
-            </a:endParaRPr>
-          </a:p>
-        </p:txBody>
-      </p:sp>
-      <p:sp>
-        <p:nvSpPr>
-          <p:cNvPr id="139" name="Text 137"/>
-          <p:cNvSpPr/>
-          <p:nvPr/>
-        </p:nvSpPr>
-        <p:spPr>
-          <a:xfrm>
-            <a:off x="10083205" y="4823097"/>
-            <a:ext cx="1005578" cy="141695"/>
+              <a:t>DeviceId</a:t>
+            </a:r>
+            <a:endParaRPr lang="en-US" sz="850" dirty="0">
+              <a:latin typeface="Candara" panose="020E0502030303020204" pitchFamily="34" charset="0"/>
+            </a:endParaRPr>
+          </a:p>
+        </p:txBody>
+      </p:sp>
+      <p:sp>
+        <p:nvSpPr>
+          <p:cNvPr id="156" name="Text 154"/>
+          <p:cNvSpPr/>
+          <p:nvPr/>
+        </p:nvSpPr>
+        <p:spPr>
+          <a:xfrm>
+            <a:off x="11088783" y="6144061"/>
+            <a:ext cx="475364" cy="141695"/>
           </a:xfrm>
           <a:prstGeom prst="rect">
             <a:avLst/>
@@ -35191,33 +34405,34 @@
           <a:bodyPr wrap="square" lIns="0" tIns="0" rIns="0" bIns="0" rtlCol="0" anchor="ctr"/>
           <a:lstStyle/>
           <a:p>
-            <a:r>
-              <a:rPr lang="en-US" sz="850" dirty="0">
-                <a:solidFill>
-                  <a:srgbClr val="FFFFFF"/>
+            <a:pPr algn="r"/>
+            <a:r>
+              <a:rPr lang="en-US" sz="750" dirty="0">
+                <a:solidFill>
+                  <a:srgbClr val="4D8C6A"/>
                 </a:solidFill>
                 <a:latin typeface="Candara" panose="020E0502030303020204" pitchFamily="34" charset="0"/>
                 <a:ea typeface="Calibri" pitchFamily="34" charset="-122"/>
                 <a:cs typeface="Calibri" pitchFamily="34" charset="-120"/>
               </a:rPr>
-              <a:t>MetricValue</a:t>
-            </a:r>
-            <a:endParaRPr lang="en-US" sz="850" dirty="0">
-              <a:latin typeface="Candara" panose="020E0502030303020204" pitchFamily="34" charset="0"/>
-            </a:endParaRPr>
-          </a:p>
-        </p:txBody>
-      </p:sp>
-      <p:sp>
-        <p:nvSpPr>
-          <p:cNvPr id="140" name="Text 138"/>
-          <p:cNvSpPr/>
-          <p:nvPr/>
-        </p:nvSpPr>
-        <p:spPr>
-          <a:xfrm>
-            <a:off x="11088783" y="4823097"/>
-            <a:ext cx="475364" cy="141695"/>
+              <a:t>int</a:t>
+            </a:r>
+            <a:endParaRPr lang="en-US" sz="750" dirty="0">
+              <a:latin typeface="Candara" panose="020E0502030303020204" pitchFamily="34" charset="0"/>
+            </a:endParaRPr>
+          </a:p>
+        </p:txBody>
+      </p:sp>
+      <p:sp>
+        <p:nvSpPr>
+          <p:cNvPr id="157" name="Text 155"/>
+          <p:cNvSpPr/>
+          <p:nvPr/>
+        </p:nvSpPr>
+        <p:spPr>
+          <a:xfrm>
+            <a:off x="9790673" y="6285756"/>
+            <a:ext cx="274249" cy="141695"/>
           </a:xfrm>
           <a:prstGeom prst="rect">
             <a:avLst/>
@@ -35229,17 +34444,93 @@
           <a:bodyPr wrap="square" lIns="0" tIns="0" rIns="0" bIns="0" rtlCol="0" anchor="ctr"/>
           <a:lstStyle/>
           <a:p>
-            <a:pPr algn="r"/>
-            <a:r>
-              <a:rPr lang="en-US" sz="750" dirty="0">
-                <a:solidFill>
-                  <a:srgbClr val="4D8C6A"/>
+            <a:r>
+              <a:rPr lang="en-US" sz="700" b="1" dirty="0">
+                <a:solidFill>
+                  <a:srgbClr val="60B8FF"/>
                 </a:solidFill>
                 <a:latin typeface="Candara" panose="020E0502030303020204" pitchFamily="34" charset="0"/>
                 <a:ea typeface="Calibri" pitchFamily="34" charset="-122"/>
                 <a:cs typeface="Calibri" pitchFamily="34" charset="-120"/>
               </a:rPr>
-              <a:t>dec(18,4)</a:t>
+              <a:t>FK?</a:t>
+            </a:r>
+            <a:endParaRPr lang="en-US" sz="700" dirty="0">
+              <a:latin typeface="Candara" panose="020E0502030303020204" pitchFamily="34" charset="0"/>
+            </a:endParaRPr>
+          </a:p>
+        </p:txBody>
+      </p:sp>
+      <p:sp>
+        <p:nvSpPr>
+          <p:cNvPr id="158" name="Text 156"/>
+          <p:cNvSpPr/>
+          <p:nvPr/>
+        </p:nvSpPr>
+        <p:spPr>
+          <a:xfrm>
+            <a:off x="10083205" y="6285756"/>
+            <a:ext cx="1005578" cy="141695"/>
+          </a:xfrm>
+          <a:prstGeom prst="rect">
+            <a:avLst/>
+          </a:prstGeom>
+          <a:noFill/>
+          <a:ln/>
+        </p:spPr>
+        <p:txBody>
+          <a:bodyPr wrap="square" lIns="0" tIns="0" rIns="0" bIns="0" rtlCol="0" anchor="ctr"/>
+          <a:lstStyle/>
+          <a:p>
+            <a:r>
+              <a:rPr lang="en-US" sz="850" i="1" dirty="0">
+                <a:solidFill>
+                  <a:srgbClr val="7AB896"/>
+                </a:solidFill>
+                <a:latin typeface="Candara" panose="020E0502030303020204" pitchFamily="34" charset="0"/>
+                <a:ea typeface="Calibri" pitchFamily="34" charset="-122"/>
+                <a:cs typeface="Calibri" pitchFamily="34" charset="-120"/>
+              </a:rPr>
+              <a:t>SensorId</a:t>
+            </a:r>
+            <a:endParaRPr lang="en-US" sz="850" dirty="0">
+              <a:latin typeface="Candara" panose="020E0502030303020204" pitchFamily="34" charset="0"/>
+            </a:endParaRPr>
+          </a:p>
+        </p:txBody>
+      </p:sp>
+      <p:sp>
+        <p:nvSpPr>
+          <p:cNvPr id="159" name="Text 157"/>
+          <p:cNvSpPr/>
+          <p:nvPr/>
+        </p:nvSpPr>
+        <p:spPr>
+          <a:xfrm>
+            <a:off x="11088783" y="6285756"/>
+            <a:ext cx="475364" cy="141695"/>
+          </a:xfrm>
+          <a:prstGeom prst="rect">
+            <a:avLst/>
+          </a:prstGeom>
+          <a:noFill/>
+          <a:ln/>
+        </p:spPr>
+        <p:txBody>
+          <a:bodyPr wrap="square" lIns="0" tIns="0" rIns="0" bIns="0" rtlCol="0" anchor="ctr"/>
+          <a:lstStyle/>
+          <a:p>
+            <a:pPr algn="r"/>
+            <a:r>
+              <a:rPr lang="en-US" sz="750" dirty="0">
+                <a:solidFill>
+                  <a:srgbClr val="4D8C6A"/>
+                </a:solidFill>
+                <a:latin typeface="Candara" panose="020E0502030303020204" pitchFamily="34" charset="0"/>
+                <a:ea typeface="Calibri" pitchFamily="34" charset="-122"/>
+                <a:cs typeface="Calibri" pitchFamily="34" charset="-120"/>
+              </a:rPr>
+              <a:t>int?</a:t>
             </a:r>
             <a:endParaRPr lang="en-US" sz="750" dirty="0">
               <a:latin typeface="Candara" panose="020E0502030303020204" pitchFamily="34" charset="0"/>
@@ -35249,13 +34540,13 @@
       </p:sp>
       <p:sp>
         <p:nvSpPr>
-          <p:cNvPr id="141" name="Shape 139"/>
-          <p:cNvSpPr/>
-          <p:nvPr/>
-        </p:nvSpPr>
-        <p:spPr>
-          <a:xfrm>
-            <a:off x="9671832" y="5376165"/>
+          <p:cNvPr id="177" name="Shape 175"/>
+          <p:cNvSpPr/>
+          <p:nvPr/>
+        </p:nvSpPr>
+        <p:spPr>
+          <a:xfrm>
+            <a:off x="4963899" y="5147624"/>
             <a:ext cx="2011156" cy="1133561"/>
           </a:xfrm>
           <a:prstGeom prst="roundRect">
@@ -35287,13 +34578,13 @@
       </p:sp>
       <p:sp>
         <p:nvSpPr>
-          <p:cNvPr id="142" name="Shape 140"/>
-          <p:cNvSpPr/>
-          <p:nvPr/>
-        </p:nvSpPr>
-        <p:spPr>
-          <a:xfrm>
-            <a:off x="9644407" y="5348740"/>
+          <p:cNvPr id="178" name="Shape 176"/>
+          <p:cNvSpPr/>
+          <p:nvPr/>
+        </p:nvSpPr>
+        <p:spPr>
+          <a:xfrm>
+            <a:off x="4936474" y="5120199"/>
             <a:ext cx="2011156" cy="1133561"/>
           </a:xfrm>
           <a:prstGeom prst="roundRect">
@@ -35323,83 +34614,13 @@
       </p:sp>
       <p:sp>
         <p:nvSpPr>
-          <p:cNvPr id="143" name="Shape 141"/>
-          <p:cNvSpPr/>
-          <p:nvPr/>
-        </p:nvSpPr>
-        <p:spPr>
-          <a:xfrm>
-            <a:off x="9644407" y="5421873"/>
-            <a:ext cx="50279" cy="987295"/>
-          </a:xfrm>
-          <a:prstGeom prst="rect">
-            <a:avLst/>
-          </a:prstGeom>
-          <a:solidFill>
-            <a:srgbClr val="1B5C3A"/>
-          </a:solidFill>
-          <a:ln w="12700">
-            <a:solidFill>
-              <a:srgbClr val="1B5C3A"/>
-            </a:solidFill>
-            <a:prstDash val="solid"/>
-          </a:ln>
-        </p:spPr>
-        <p:txBody>
-          <a:bodyPr/>
-          <a:lstStyle/>
-          <a:p>
-            <a:endParaRPr lang="en-US" sz="1799">
-              <a:latin typeface="Candara" panose="020E0502030303020204" pitchFamily="34" charset="0"/>
-            </a:endParaRPr>
-          </a:p>
-        </p:txBody>
-      </p:sp>
-      <p:sp>
-        <p:nvSpPr>
-          <p:cNvPr id="144" name="Shape 142"/>
-          <p:cNvSpPr/>
-          <p:nvPr/>
-        </p:nvSpPr>
-        <p:spPr>
-          <a:xfrm>
-            <a:off x="9644407" y="5348740"/>
-            <a:ext cx="50279" cy="164549"/>
-          </a:xfrm>
-          <a:prstGeom prst="roundRect">
-            <a:avLst>
-              <a:gd name="adj" fmla="val 72727"/>
-            </a:avLst>
-          </a:prstGeom>
-          <a:solidFill>
-            <a:srgbClr val="1B5C3A"/>
-          </a:solidFill>
-          <a:ln w="12700">
-            <a:solidFill>
-              <a:srgbClr val="1B5C3A"/>
-            </a:solidFill>
-            <a:prstDash val="solid"/>
-          </a:ln>
-        </p:spPr>
-        <p:txBody>
-          <a:bodyPr/>
-          <a:lstStyle/>
-          <a:p>
-            <a:endParaRPr lang="en-US" sz="1799">
-              <a:latin typeface="Candara" panose="020E0502030303020204" pitchFamily="34" charset="0"/>
-            </a:endParaRPr>
-          </a:p>
-        </p:txBody>
-      </p:sp>
-      <p:sp>
-        <p:nvSpPr>
-          <p:cNvPr id="145" name="Text 143"/>
-          <p:cNvSpPr/>
-          <p:nvPr/>
-        </p:nvSpPr>
-        <p:spPr>
-          <a:xfrm>
-            <a:off x="9790673" y="5367023"/>
+          <p:cNvPr id="181" name="Text 179"/>
+          <p:cNvSpPr/>
+          <p:nvPr/>
+        </p:nvSpPr>
+        <p:spPr>
+          <a:xfrm>
+            <a:off x="5082739" y="5138483"/>
             <a:ext cx="1810041" cy="237682"/>
           </a:xfrm>
           <a:prstGeom prst="rect">
@@ -35421,7 +34642,7 @@
                 <a:ea typeface="Calibri" pitchFamily="34" charset="-122"/>
                 <a:cs typeface="Calibri" pitchFamily="34" charset="-120"/>
               </a:rPr>
-              <a:t>Alerts</a:t>
+              <a:t>DeviceCommands</a:t>
             </a:r>
             <a:endParaRPr lang="en-US" sz="1100" dirty="0">
               <a:latin typeface="Candara" panose="020E0502030303020204" pitchFamily="34" charset="0"/>
@@ -35431,13 +34652,13 @@
       </p:sp>
       <p:sp>
         <p:nvSpPr>
-          <p:cNvPr id="146" name="Text 144"/>
-          <p:cNvSpPr/>
-          <p:nvPr/>
-        </p:nvSpPr>
-        <p:spPr>
-          <a:xfrm>
-            <a:off x="9790673" y="5641272"/>
+          <p:cNvPr id="182" name="Text 180"/>
+          <p:cNvSpPr/>
+          <p:nvPr/>
+        </p:nvSpPr>
+        <p:spPr>
+          <a:xfrm>
+            <a:off x="5082739" y="5412731"/>
             <a:ext cx="1810041" cy="164549"/>
           </a:xfrm>
           <a:prstGeom prst="rect">
@@ -35459,7 +34680,7 @@
                 <a:ea typeface="Calibri" pitchFamily="34" charset="-122"/>
                 <a:cs typeface="Calibri" pitchFamily="34" charset="-120"/>
               </a:rPr>
-              <a:t>Fired alert records</a:t>
+              <a:t>Commands sent to device / actuator</a:t>
             </a:r>
             <a:endParaRPr lang="en-US" sz="850" dirty="0">
               <a:latin typeface="Candara" panose="020E0502030303020204" pitchFamily="34" charset="0"/>
@@ -35469,13 +34690,13 @@
       </p:sp>
       <p:sp>
         <p:nvSpPr>
-          <p:cNvPr id="147" name="Shape 145"/>
-          <p:cNvSpPr/>
-          <p:nvPr/>
-        </p:nvSpPr>
-        <p:spPr>
-          <a:xfrm>
-            <a:off x="9772390" y="5824104"/>
+          <p:cNvPr id="183" name="Shape 181"/>
+          <p:cNvSpPr/>
+          <p:nvPr/>
+        </p:nvSpPr>
+        <p:spPr>
+          <a:xfrm>
+            <a:off x="5064456" y="5595564"/>
             <a:ext cx="1828324" cy="0"/>
           </a:xfrm>
           <a:prstGeom prst="line">
@@ -35501,13 +34722,13 @@
       </p:sp>
       <p:sp>
         <p:nvSpPr>
-          <p:cNvPr id="148" name="Text 146"/>
-          <p:cNvSpPr/>
-          <p:nvPr/>
-        </p:nvSpPr>
-        <p:spPr>
-          <a:xfrm>
-            <a:off x="9790673" y="5860671"/>
+          <p:cNvPr id="184" name="Text 182"/>
+          <p:cNvSpPr/>
+          <p:nvPr/>
+        </p:nvSpPr>
+        <p:spPr>
+          <a:xfrm>
+            <a:off x="5082739" y="5632130"/>
             <a:ext cx="274249" cy="141695"/>
           </a:xfrm>
           <a:prstGeom prst="rect">
@@ -35539,13 +34760,13 @@
       </p:sp>
       <p:sp>
         <p:nvSpPr>
-          <p:cNvPr id="149" name="Text 147"/>
-          <p:cNvSpPr/>
-          <p:nvPr/>
-        </p:nvSpPr>
-        <p:spPr>
-          <a:xfrm>
-            <a:off x="10083205" y="5860671"/>
+          <p:cNvPr id="185" name="Text 183"/>
+          <p:cNvSpPr/>
+          <p:nvPr/>
+        </p:nvSpPr>
+        <p:spPr>
+          <a:xfrm>
+            <a:off x="5375271" y="5632130"/>
             <a:ext cx="1005578" cy="141695"/>
           </a:xfrm>
           <a:prstGeom prst="rect">
@@ -35567,7 +34788,7 @@
                 <a:ea typeface="Calibri" pitchFamily="34" charset="-122"/>
                 <a:cs typeface="Calibri" pitchFamily="34" charset="-120"/>
               </a:rPr>
-              <a:t>AlertId</a:t>
+              <a:t>CommandId</a:t>
             </a:r>
             <a:endParaRPr lang="en-US" sz="850" dirty="0">
               <a:latin typeface="Candara" panose="020E0502030303020204" pitchFamily="34" charset="0"/>
@@ -35577,13 +34798,13 @@
       </p:sp>
       <p:sp>
         <p:nvSpPr>
-          <p:cNvPr id="150" name="Text 148"/>
-          <p:cNvSpPr/>
-          <p:nvPr/>
-        </p:nvSpPr>
-        <p:spPr>
-          <a:xfrm>
-            <a:off x="11088783" y="5860671"/>
+          <p:cNvPr id="186" name="Text 184"/>
+          <p:cNvSpPr/>
+          <p:nvPr/>
+        </p:nvSpPr>
+        <p:spPr>
+          <a:xfrm>
+            <a:off x="6380849" y="5632130"/>
             <a:ext cx="475364" cy="141695"/>
           </a:xfrm>
           <a:prstGeom prst="rect">
@@ -35616,13 +34837,13 @@
       </p:sp>
       <p:sp>
         <p:nvSpPr>
-          <p:cNvPr id="151" name="Text 149"/>
-          <p:cNvSpPr/>
-          <p:nvPr/>
-        </p:nvSpPr>
-        <p:spPr>
-          <a:xfrm>
-            <a:off x="9790673" y="6002366"/>
+          <p:cNvPr id="187" name="Text 185"/>
+          <p:cNvSpPr/>
+          <p:nvPr/>
+        </p:nvSpPr>
+        <p:spPr>
+          <a:xfrm>
+            <a:off x="5082739" y="5773825"/>
             <a:ext cx="274249" cy="141695"/>
           </a:xfrm>
           <a:prstGeom prst="rect">
@@ -35654,13 +34875,13 @@
       </p:sp>
       <p:sp>
         <p:nvSpPr>
-          <p:cNvPr id="152" name="Text 150"/>
-          <p:cNvSpPr/>
-          <p:nvPr/>
-        </p:nvSpPr>
-        <p:spPr>
-          <a:xfrm>
-            <a:off x="10083205" y="6002366"/>
+          <p:cNvPr id="188" name="Text 186"/>
+          <p:cNvSpPr/>
+          <p:nvPr/>
+        </p:nvSpPr>
+        <p:spPr>
+          <a:xfrm>
+            <a:off x="5375271" y="5773825"/>
             <a:ext cx="1005578" cy="141695"/>
           </a:xfrm>
           <a:prstGeom prst="rect">
@@ -35682,7 +34903,7 @@
                 <a:ea typeface="Calibri" pitchFamily="34" charset="-122"/>
                 <a:cs typeface="Calibri" pitchFamily="34" charset="-120"/>
               </a:rPr>
-              <a:t>AlertRuleId</a:t>
+              <a:t>DeviceId</a:t>
             </a:r>
             <a:endParaRPr lang="en-US" sz="850" dirty="0">
               <a:latin typeface="Candara" panose="020E0502030303020204" pitchFamily="34" charset="0"/>
@@ -35692,13 +34913,13 @@
       </p:sp>
       <p:sp>
         <p:nvSpPr>
-          <p:cNvPr id="153" name="Text 151"/>
-          <p:cNvSpPr/>
-          <p:nvPr/>
-        </p:nvSpPr>
-        <p:spPr>
-          <a:xfrm>
-            <a:off x="11088783" y="6002366"/>
+          <p:cNvPr id="189" name="Text 187"/>
+          <p:cNvSpPr/>
+          <p:nvPr/>
+        </p:nvSpPr>
+        <p:spPr>
+          <a:xfrm>
+            <a:off x="6380849" y="5773825"/>
             <a:ext cx="475364" cy="141695"/>
           </a:xfrm>
           <a:prstGeom prst="rect">
@@ -35731,13 +34952,13 @@
       </p:sp>
       <p:sp>
         <p:nvSpPr>
-          <p:cNvPr id="154" name="Text 152"/>
-          <p:cNvSpPr/>
-          <p:nvPr/>
-        </p:nvSpPr>
-        <p:spPr>
-          <a:xfrm>
-            <a:off x="9790673" y="6144061"/>
+          <p:cNvPr id="190" name="Text 188"/>
+          <p:cNvSpPr/>
+          <p:nvPr/>
+        </p:nvSpPr>
+        <p:spPr>
+          <a:xfrm>
+            <a:off x="5082739" y="5915520"/>
             <a:ext cx="274249" cy="141695"/>
           </a:xfrm>
           <a:prstGeom prst="rect">
@@ -35759,7 +34980,7 @@
                 <a:ea typeface="Calibri" pitchFamily="34" charset="-122"/>
                 <a:cs typeface="Calibri" pitchFamily="34" charset="-120"/>
               </a:rPr>
-              <a:t>FK</a:t>
+              <a:t>FK?</a:t>
             </a:r>
             <a:endParaRPr lang="en-US" sz="700" dirty="0">
               <a:latin typeface="Candara" panose="020E0502030303020204" pitchFamily="34" charset="0"/>
@@ -35769,13 +34990,13 @@
       </p:sp>
       <p:sp>
         <p:nvSpPr>
-          <p:cNvPr id="155" name="Text 153"/>
-          <p:cNvSpPr/>
-          <p:nvPr/>
-        </p:nvSpPr>
-        <p:spPr>
-          <a:xfrm>
-            <a:off x="10083205" y="6144061"/>
+          <p:cNvPr id="191" name="Text 189"/>
+          <p:cNvSpPr/>
+          <p:nvPr/>
+        </p:nvSpPr>
+        <p:spPr>
+          <a:xfrm>
+            <a:off x="5375271" y="5915520"/>
             <a:ext cx="1005578" cy="141695"/>
           </a:xfrm>
           <a:prstGeom prst="rect">
@@ -35797,7 +35018,7 @@
                 <a:ea typeface="Calibri" pitchFamily="34" charset="-122"/>
                 <a:cs typeface="Calibri" pitchFamily="34" charset="-120"/>
               </a:rPr>
-              <a:t>DeviceId</a:t>
+              <a:t>ActuatorId</a:t>
             </a:r>
             <a:endParaRPr lang="en-US" sz="850" dirty="0">
               <a:latin typeface="Candara" panose="020E0502030303020204" pitchFamily="34" charset="0"/>
@@ -35807,13 +35028,13 @@
       </p:sp>
       <p:sp>
         <p:nvSpPr>
-          <p:cNvPr id="156" name="Text 154"/>
-          <p:cNvSpPr/>
-          <p:nvPr/>
-        </p:nvSpPr>
-        <p:spPr>
-          <a:xfrm>
-            <a:off x="11088783" y="6144061"/>
+          <p:cNvPr id="192" name="Text 190"/>
+          <p:cNvSpPr/>
+          <p:nvPr/>
+        </p:nvSpPr>
+        <p:spPr>
+          <a:xfrm>
+            <a:off x="6380849" y="5915520"/>
             <a:ext cx="475364" cy="141695"/>
           </a:xfrm>
           <a:prstGeom prst="rect">
@@ -35836,7 +35057,7 @@
                 <a:ea typeface="Calibri" pitchFamily="34" charset="-122"/>
                 <a:cs typeface="Calibri" pitchFamily="34" charset="-120"/>
               </a:rPr>
-              <a:t>int</a:t>
+              <a:t>int?</a:t>
             </a:r>
             <a:endParaRPr lang="en-US" sz="750" dirty="0">
               <a:latin typeface="Candara" panose="020E0502030303020204" pitchFamily="34" charset="0"/>
@@ -35846,14 +35067,14 @@
       </p:sp>
       <p:sp>
         <p:nvSpPr>
-          <p:cNvPr id="157" name="Text 155"/>
-          <p:cNvSpPr/>
-          <p:nvPr/>
-        </p:nvSpPr>
-        <p:spPr>
-          <a:xfrm>
-            <a:off x="9790673" y="6285756"/>
-            <a:ext cx="274249" cy="141695"/>
+          <p:cNvPr id="193" name="Text 191"/>
+          <p:cNvSpPr/>
+          <p:nvPr/>
+        </p:nvSpPr>
+        <p:spPr>
+          <a:xfrm>
+            <a:off x="5375271" y="6057215"/>
+            <a:ext cx="1005578" cy="141695"/>
           </a:xfrm>
           <a:prstGeom prst="rect">
             <a:avLst/>
@@ -35866,32 +35087,32 @@
           <a:lstStyle/>
           <a:p>
             <a:r>
-              <a:rPr lang="en-US" sz="700" b="1" dirty="0">
-                <a:solidFill>
-                  <a:srgbClr val="60B8FF"/>
+              <a:rPr lang="en-US" sz="850" dirty="0">
+                <a:solidFill>
+                  <a:srgbClr val="FFFFFF"/>
                 </a:solidFill>
                 <a:latin typeface="Candara" panose="020E0502030303020204" pitchFamily="34" charset="0"/>
                 <a:ea typeface="Calibri" pitchFamily="34" charset="-122"/>
                 <a:cs typeface="Calibri" pitchFamily="34" charset="-120"/>
               </a:rPr>
-              <a:t>FK?</a:t>
-            </a:r>
-            <a:endParaRPr lang="en-US" sz="700" dirty="0">
-              <a:latin typeface="Candara" panose="020E0502030303020204" pitchFamily="34" charset="0"/>
-            </a:endParaRPr>
-          </a:p>
-        </p:txBody>
-      </p:sp>
-      <p:sp>
-        <p:nvSpPr>
-          <p:cNvPr id="158" name="Text 156"/>
-          <p:cNvSpPr/>
-          <p:nvPr/>
-        </p:nvSpPr>
-        <p:spPr>
-          <a:xfrm>
-            <a:off x="10083205" y="6285756"/>
-            <a:ext cx="1005578" cy="141695"/>
+              <a:t>CommandType</a:t>
+            </a:r>
+            <a:endParaRPr lang="en-US" sz="850" dirty="0">
+              <a:latin typeface="Candara" panose="020E0502030303020204" pitchFamily="34" charset="0"/>
+            </a:endParaRPr>
+          </a:p>
+        </p:txBody>
+      </p:sp>
+      <p:sp>
+        <p:nvSpPr>
+          <p:cNvPr id="194" name="Text 192"/>
+          <p:cNvSpPr/>
+          <p:nvPr/>
+        </p:nvSpPr>
+        <p:spPr>
+          <a:xfrm>
+            <a:off x="6380849" y="6057215"/>
+            <a:ext cx="475364" cy="141695"/>
           </a:xfrm>
           <a:prstGeom prst="rect">
             <a:avLst/>
@@ -35903,55 +35124,17 @@
           <a:bodyPr wrap="square" lIns="0" tIns="0" rIns="0" bIns="0" rtlCol="0" anchor="ctr"/>
           <a:lstStyle/>
           <a:p>
-            <a:r>
-              <a:rPr lang="en-US" sz="850" i="1" dirty="0">
-                <a:solidFill>
-                  <a:srgbClr val="7AB896"/>
+            <a:pPr algn="r"/>
+            <a:r>
+              <a:rPr lang="en-US" sz="750" dirty="0">
+                <a:solidFill>
+                  <a:srgbClr val="4D8C6A"/>
                 </a:solidFill>
                 <a:latin typeface="Candara" panose="020E0502030303020204" pitchFamily="34" charset="0"/>
                 <a:ea typeface="Calibri" pitchFamily="34" charset="-122"/>
                 <a:cs typeface="Calibri" pitchFamily="34" charset="-120"/>
               </a:rPr>
-              <a:t>SensorId</a:t>
-            </a:r>
-            <a:endParaRPr lang="en-US" sz="850" dirty="0">
-              <a:latin typeface="Candara" panose="020E0502030303020204" pitchFamily="34" charset="0"/>
-            </a:endParaRPr>
-          </a:p>
-        </p:txBody>
-      </p:sp>
-      <p:sp>
-        <p:nvSpPr>
-          <p:cNvPr id="159" name="Text 157"/>
-          <p:cNvSpPr/>
-          <p:nvPr/>
-        </p:nvSpPr>
-        <p:spPr>
-          <a:xfrm>
-            <a:off x="11088783" y="6285756"/>
-            <a:ext cx="475364" cy="141695"/>
-          </a:xfrm>
-          <a:prstGeom prst="rect">
-            <a:avLst/>
-          </a:prstGeom>
-          <a:noFill/>
-          <a:ln/>
-        </p:spPr>
-        <p:txBody>
-          <a:bodyPr wrap="square" lIns="0" tIns="0" rIns="0" bIns="0" rtlCol="0" anchor="ctr"/>
-          <a:lstStyle/>
-          <a:p>
-            <a:pPr algn="r"/>
-            <a:r>
-              <a:rPr lang="en-US" sz="750" dirty="0">
-                <a:solidFill>
-                  <a:srgbClr val="4D8C6A"/>
-                </a:solidFill>
-                <a:latin typeface="Candara" panose="020E0502030303020204" pitchFamily="34" charset="0"/>
-                <a:ea typeface="Calibri" pitchFamily="34" charset="-122"/>
-                <a:cs typeface="Calibri" pitchFamily="34" charset="-120"/>
-              </a:rPr>
-              <a:t>int?</a:t>
+              <a:t>string(50)</a:t>
             </a:r>
             <a:endParaRPr lang="en-US" sz="750" dirty="0">
               <a:latin typeface="Candara" panose="020E0502030303020204" pitchFamily="34" charset="0"/>
@@ -35961,13 +35144,13 @@
       </p:sp>
       <p:sp>
         <p:nvSpPr>
-          <p:cNvPr id="160" name="Shape 158"/>
-          <p:cNvSpPr/>
-          <p:nvPr/>
-        </p:nvSpPr>
-        <p:spPr>
-          <a:xfrm>
-            <a:off x="2724202" y="5147624"/>
+          <p:cNvPr id="195" name="Shape 193"/>
+          <p:cNvSpPr/>
+          <p:nvPr/>
+        </p:nvSpPr>
+        <p:spPr>
+          <a:xfrm>
+            <a:off x="7157887" y="5147624"/>
             <a:ext cx="2011156" cy="1133561"/>
           </a:xfrm>
           <a:prstGeom prst="roundRect">
@@ -35999,13 +35182,13 @@
       </p:sp>
       <p:sp>
         <p:nvSpPr>
-          <p:cNvPr id="161" name="Shape 159"/>
-          <p:cNvSpPr/>
-          <p:nvPr/>
-        </p:nvSpPr>
-        <p:spPr>
-          <a:xfrm>
-            <a:off x="2696777" y="5120199"/>
+          <p:cNvPr id="196" name="Shape 194"/>
+          <p:cNvSpPr/>
+          <p:nvPr/>
+        </p:nvSpPr>
+        <p:spPr>
+          <a:xfrm>
+            <a:off x="7130462" y="5120199"/>
             <a:ext cx="2011156" cy="1133561"/>
           </a:xfrm>
           <a:prstGeom prst="roundRect">
@@ -36035,13 +35218,13 @@
       </p:sp>
       <p:sp>
         <p:nvSpPr>
-          <p:cNvPr id="162" name="Shape 160"/>
-          <p:cNvSpPr/>
-          <p:nvPr/>
-        </p:nvSpPr>
-        <p:spPr>
-          <a:xfrm>
-            <a:off x="2696777" y="5193332"/>
+          <p:cNvPr id="197" name="Shape 195"/>
+          <p:cNvSpPr/>
+          <p:nvPr/>
+        </p:nvSpPr>
+        <p:spPr>
+          <a:xfrm>
+            <a:off x="7130462" y="5193332"/>
             <a:ext cx="50279" cy="987295"/>
           </a:xfrm>
           <a:prstGeom prst="rect">
@@ -36069,13 +35252,13 @@
       </p:sp>
       <p:sp>
         <p:nvSpPr>
-          <p:cNvPr id="163" name="Shape 161"/>
-          <p:cNvSpPr/>
-          <p:nvPr/>
-        </p:nvSpPr>
-        <p:spPr>
-          <a:xfrm>
-            <a:off x="2696777" y="5120200"/>
+          <p:cNvPr id="198" name="Shape 196"/>
+          <p:cNvSpPr/>
+          <p:nvPr/>
+        </p:nvSpPr>
+        <p:spPr>
+          <a:xfrm>
+            <a:off x="7130462" y="5120200"/>
             <a:ext cx="50279" cy="164549"/>
           </a:xfrm>
           <a:prstGeom prst="roundRect">
@@ -36105,1316 +35288,6 @@
       </p:sp>
       <p:sp>
         <p:nvSpPr>
-          <p:cNvPr id="164" name="Text 162"/>
-          <p:cNvSpPr/>
-          <p:nvPr/>
-        </p:nvSpPr>
-        <p:spPr>
-          <a:xfrm>
-            <a:off x="2843043" y="5138483"/>
-            <a:ext cx="1810041" cy="237682"/>
-          </a:xfrm>
-          <a:prstGeom prst="rect">
-            <a:avLst/>
-          </a:prstGeom>
-          <a:noFill/>
-          <a:ln/>
-        </p:spPr>
-        <p:txBody>
-          <a:bodyPr wrap="square" lIns="0" tIns="0" rIns="0" bIns="0" rtlCol="0" anchor="ctr"/>
-          <a:lstStyle/>
-          <a:p>
-            <a:r>
-              <a:rPr lang="en-US" sz="1100" b="1" dirty="0">
-                <a:solidFill>
-                  <a:srgbClr val="3ECF80"/>
-                </a:solidFill>
-                <a:latin typeface="Candara" panose="020E0502030303020204" pitchFamily="34" charset="0"/>
-                <a:ea typeface="Calibri" pitchFamily="34" charset="-122"/>
-                <a:cs typeface="Calibri" pitchFamily="34" charset="-120"/>
-              </a:rPr>
-              <a:t>DeviceConfigurations</a:t>
-            </a:r>
-            <a:endParaRPr lang="en-US" sz="1100" dirty="0">
-              <a:latin typeface="Candara" panose="020E0502030303020204" pitchFamily="34" charset="0"/>
-            </a:endParaRPr>
-          </a:p>
-        </p:txBody>
-      </p:sp>
-      <p:sp>
-        <p:nvSpPr>
-          <p:cNvPr id="165" name="Text 163"/>
-          <p:cNvSpPr/>
-          <p:nvPr/>
-        </p:nvSpPr>
-        <p:spPr>
-          <a:xfrm>
-            <a:off x="2843043" y="5412731"/>
-            <a:ext cx="1810041" cy="164549"/>
-          </a:xfrm>
-          <a:prstGeom prst="rect">
-            <a:avLst/>
-          </a:prstGeom>
-          <a:noFill/>
-          <a:ln/>
-        </p:spPr>
-        <p:txBody>
-          <a:bodyPr wrap="square" lIns="0" tIns="0" rIns="0" bIns="0" rtlCol="0" anchor="t"/>
-          <a:lstStyle/>
-          <a:p>
-            <a:r>
-              <a:rPr lang="en-US" sz="850" i="1" dirty="0">
-                <a:solidFill>
-                  <a:srgbClr val="7AB896"/>
-                </a:solidFill>
-                <a:latin typeface="Candara" panose="020E0502030303020204" pitchFamily="34" charset="0"/>
-                <a:ea typeface="Calibri" pitchFamily="34" charset="-122"/>
-                <a:cs typeface="Calibri" pitchFamily="34" charset="-120"/>
-              </a:rPr>
-              <a:t>Per-device settings</a:t>
-            </a:r>
-            <a:endParaRPr lang="en-US" sz="850" dirty="0">
-              <a:latin typeface="Candara" panose="020E0502030303020204" pitchFamily="34" charset="0"/>
-            </a:endParaRPr>
-          </a:p>
-        </p:txBody>
-      </p:sp>
-      <p:sp>
-        <p:nvSpPr>
-          <p:cNvPr id="166" name="Shape 164"/>
-          <p:cNvSpPr/>
-          <p:nvPr/>
-        </p:nvSpPr>
-        <p:spPr>
-          <a:xfrm>
-            <a:off x="2824760" y="5595564"/>
-            <a:ext cx="1828324" cy="0"/>
-          </a:xfrm>
-          <a:prstGeom prst="line">
-            <a:avLst/>
-          </a:prstGeom>
-          <a:noFill/>
-          <a:ln w="9525">
-            <a:solidFill>
-              <a:srgbClr val="1E3D2A"/>
-            </a:solidFill>
-            <a:prstDash val="solid"/>
-          </a:ln>
-        </p:spPr>
-        <p:txBody>
-          <a:bodyPr/>
-          <a:lstStyle/>
-          <a:p>
-            <a:endParaRPr lang="en-US" sz="1799">
-              <a:latin typeface="Candara" panose="020E0502030303020204" pitchFamily="34" charset="0"/>
-            </a:endParaRPr>
-          </a:p>
-        </p:txBody>
-      </p:sp>
-      <p:sp>
-        <p:nvSpPr>
-          <p:cNvPr id="167" name="Text 165"/>
-          <p:cNvSpPr/>
-          <p:nvPr/>
-        </p:nvSpPr>
-        <p:spPr>
-          <a:xfrm>
-            <a:off x="2843043" y="5632130"/>
-            <a:ext cx="274249" cy="141695"/>
-          </a:xfrm>
-          <a:prstGeom prst="rect">
-            <a:avLst/>
-          </a:prstGeom>
-          <a:noFill/>
-          <a:ln/>
-        </p:spPr>
-        <p:txBody>
-          <a:bodyPr wrap="square" lIns="0" tIns="0" rIns="0" bIns="0" rtlCol="0" anchor="ctr"/>
-          <a:lstStyle/>
-          <a:p>
-            <a:r>
-              <a:rPr lang="en-US" sz="700" b="1" dirty="0">
-                <a:solidFill>
-                  <a:srgbClr val="F6C90E"/>
-                </a:solidFill>
-                <a:latin typeface="Candara" panose="020E0502030303020204" pitchFamily="34" charset="0"/>
-                <a:ea typeface="Calibri" pitchFamily="34" charset="-122"/>
-                <a:cs typeface="Calibri" pitchFamily="34" charset="-120"/>
-              </a:rPr>
-              <a:t>PK</a:t>
-            </a:r>
-            <a:endParaRPr lang="en-US" sz="700" dirty="0">
-              <a:latin typeface="Candara" panose="020E0502030303020204" pitchFamily="34" charset="0"/>
-            </a:endParaRPr>
-          </a:p>
-        </p:txBody>
-      </p:sp>
-      <p:sp>
-        <p:nvSpPr>
-          <p:cNvPr id="168" name="Text 166"/>
-          <p:cNvSpPr/>
-          <p:nvPr/>
-        </p:nvSpPr>
-        <p:spPr>
-          <a:xfrm>
-            <a:off x="3135575" y="5632130"/>
-            <a:ext cx="1005578" cy="141695"/>
-          </a:xfrm>
-          <a:prstGeom prst="rect">
-            <a:avLst/>
-          </a:prstGeom>
-          <a:noFill/>
-          <a:ln/>
-        </p:spPr>
-        <p:txBody>
-          <a:bodyPr wrap="square" lIns="0" tIns="0" rIns="0" bIns="0" rtlCol="0" anchor="ctr"/>
-          <a:lstStyle/>
-          <a:p>
-            <a:r>
-              <a:rPr lang="en-US" sz="850" b="1" dirty="0">
-                <a:solidFill>
-                  <a:srgbClr val="FFFFFF"/>
-                </a:solidFill>
-                <a:latin typeface="Candara" panose="020E0502030303020204" pitchFamily="34" charset="0"/>
-                <a:ea typeface="Calibri" pitchFamily="34" charset="-122"/>
-                <a:cs typeface="Calibri" pitchFamily="34" charset="-120"/>
-              </a:rPr>
-              <a:t>ConfigurationId</a:t>
-            </a:r>
-            <a:endParaRPr lang="en-US" sz="850" dirty="0">
-              <a:latin typeface="Candara" panose="020E0502030303020204" pitchFamily="34" charset="0"/>
-            </a:endParaRPr>
-          </a:p>
-        </p:txBody>
-      </p:sp>
-      <p:sp>
-        <p:nvSpPr>
-          <p:cNvPr id="169" name="Text 167"/>
-          <p:cNvSpPr/>
-          <p:nvPr/>
-        </p:nvSpPr>
-        <p:spPr>
-          <a:xfrm>
-            <a:off x="4141153" y="5632130"/>
-            <a:ext cx="475364" cy="141695"/>
-          </a:xfrm>
-          <a:prstGeom prst="rect">
-            <a:avLst/>
-          </a:prstGeom>
-          <a:noFill/>
-          <a:ln/>
-        </p:spPr>
-        <p:txBody>
-          <a:bodyPr wrap="square" lIns="0" tIns="0" rIns="0" bIns="0" rtlCol="0" anchor="ctr"/>
-          <a:lstStyle/>
-          <a:p>
-            <a:pPr algn="r"/>
-            <a:r>
-              <a:rPr lang="en-US" sz="750" dirty="0">
-                <a:solidFill>
-                  <a:srgbClr val="4D8C6A"/>
-                </a:solidFill>
-                <a:latin typeface="Candara" panose="020E0502030303020204" pitchFamily="34" charset="0"/>
-                <a:ea typeface="Calibri" pitchFamily="34" charset="-122"/>
-                <a:cs typeface="Calibri" pitchFamily="34" charset="-120"/>
-              </a:rPr>
-              <a:t>int</a:t>
-            </a:r>
-            <a:endParaRPr lang="en-US" sz="750" dirty="0">
-              <a:latin typeface="Candara" panose="020E0502030303020204" pitchFamily="34" charset="0"/>
-            </a:endParaRPr>
-          </a:p>
-        </p:txBody>
-      </p:sp>
-      <p:sp>
-        <p:nvSpPr>
-          <p:cNvPr id="170" name="Text 168"/>
-          <p:cNvSpPr/>
-          <p:nvPr/>
-        </p:nvSpPr>
-        <p:spPr>
-          <a:xfrm>
-            <a:off x="2843043" y="5773825"/>
-            <a:ext cx="274249" cy="141695"/>
-          </a:xfrm>
-          <a:prstGeom prst="rect">
-            <a:avLst/>
-          </a:prstGeom>
-          <a:noFill/>
-          <a:ln/>
-        </p:spPr>
-        <p:txBody>
-          <a:bodyPr wrap="square" lIns="0" tIns="0" rIns="0" bIns="0" rtlCol="0" anchor="ctr"/>
-          <a:lstStyle/>
-          <a:p>
-            <a:r>
-              <a:rPr lang="en-US" sz="700" b="1" dirty="0">
-                <a:solidFill>
-                  <a:srgbClr val="60B8FF"/>
-                </a:solidFill>
-                <a:latin typeface="Candara" panose="020E0502030303020204" pitchFamily="34" charset="0"/>
-                <a:ea typeface="Calibri" pitchFamily="34" charset="-122"/>
-                <a:cs typeface="Calibri" pitchFamily="34" charset="-120"/>
-              </a:rPr>
-              <a:t>FK</a:t>
-            </a:r>
-            <a:endParaRPr lang="en-US" sz="700" dirty="0">
-              <a:latin typeface="Candara" panose="020E0502030303020204" pitchFamily="34" charset="0"/>
-            </a:endParaRPr>
-          </a:p>
-        </p:txBody>
-      </p:sp>
-      <p:sp>
-        <p:nvSpPr>
-          <p:cNvPr id="171" name="Text 169"/>
-          <p:cNvSpPr/>
-          <p:nvPr/>
-        </p:nvSpPr>
-        <p:spPr>
-          <a:xfrm>
-            <a:off x="3135575" y="5773825"/>
-            <a:ext cx="1005578" cy="141695"/>
-          </a:xfrm>
-          <a:prstGeom prst="rect">
-            <a:avLst/>
-          </a:prstGeom>
-          <a:noFill/>
-          <a:ln/>
-        </p:spPr>
-        <p:txBody>
-          <a:bodyPr wrap="square" lIns="0" tIns="0" rIns="0" bIns="0" rtlCol="0" anchor="ctr"/>
-          <a:lstStyle/>
-          <a:p>
-            <a:r>
-              <a:rPr lang="en-US" sz="850" i="1" dirty="0">
-                <a:solidFill>
-                  <a:srgbClr val="7AB896"/>
-                </a:solidFill>
-                <a:latin typeface="Candara" panose="020E0502030303020204" pitchFamily="34" charset="0"/>
-                <a:ea typeface="Calibri" pitchFamily="34" charset="-122"/>
-                <a:cs typeface="Calibri" pitchFamily="34" charset="-120"/>
-              </a:rPr>
-              <a:t>DeviceId</a:t>
-            </a:r>
-            <a:endParaRPr lang="en-US" sz="850" dirty="0">
-              <a:latin typeface="Candara" panose="020E0502030303020204" pitchFamily="34" charset="0"/>
-            </a:endParaRPr>
-          </a:p>
-        </p:txBody>
-      </p:sp>
-      <p:sp>
-        <p:nvSpPr>
-          <p:cNvPr id="172" name="Text 170"/>
-          <p:cNvSpPr/>
-          <p:nvPr/>
-        </p:nvSpPr>
-        <p:spPr>
-          <a:xfrm>
-            <a:off x="4141153" y="5773825"/>
-            <a:ext cx="475364" cy="141695"/>
-          </a:xfrm>
-          <a:prstGeom prst="rect">
-            <a:avLst/>
-          </a:prstGeom>
-          <a:noFill/>
-          <a:ln/>
-        </p:spPr>
-        <p:txBody>
-          <a:bodyPr wrap="square" lIns="0" tIns="0" rIns="0" bIns="0" rtlCol="0" anchor="ctr"/>
-          <a:lstStyle/>
-          <a:p>
-            <a:pPr algn="r"/>
-            <a:r>
-              <a:rPr lang="en-US" sz="750" dirty="0">
-                <a:solidFill>
-                  <a:srgbClr val="4D8C6A"/>
-                </a:solidFill>
-                <a:latin typeface="Candara" panose="020E0502030303020204" pitchFamily="34" charset="0"/>
-                <a:ea typeface="Calibri" pitchFamily="34" charset="-122"/>
-                <a:cs typeface="Calibri" pitchFamily="34" charset="-120"/>
-              </a:rPr>
-              <a:t>int</a:t>
-            </a:r>
-            <a:endParaRPr lang="en-US" sz="750" dirty="0">
-              <a:latin typeface="Candara" panose="020E0502030303020204" pitchFamily="34" charset="0"/>
-            </a:endParaRPr>
-          </a:p>
-        </p:txBody>
-      </p:sp>
-      <p:sp>
-        <p:nvSpPr>
-          <p:cNvPr id="173" name="Text 171"/>
-          <p:cNvSpPr/>
-          <p:nvPr/>
-        </p:nvSpPr>
-        <p:spPr>
-          <a:xfrm>
-            <a:off x="3135575" y="5915520"/>
-            <a:ext cx="1005578" cy="141695"/>
-          </a:xfrm>
-          <a:prstGeom prst="rect">
-            <a:avLst/>
-          </a:prstGeom>
-          <a:noFill/>
-          <a:ln/>
-        </p:spPr>
-        <p:txBody>
-          <a:bodyPr wrap="square" lIns="0" tIns="0" rIns="0" bIns="0" rtlCol="0" anchor="ctr"/>
-          <a:lstStyle/>
-          <a:p>
-            <a:r>
-              <a:rPr lang="en-US" sz="850" dirty="0">
-                <a:solidFill>
-                  <a:srgbClr val="FFFFFF"/>
-                </a:solidFill>
-                <a:latin typeface="Candara" panose="020E0502030303020204" pitchFamily="34" charset="0"/>
-                <a:ea typeface="Calibri" pitchFamily="34" charset="-122"/>
-                <a:cs typeface="Calibri" pitchFamily="34" charset="-120"/>
-              </a:rPr>
-              <a:t>ConfigurationKey</a:t>
-            </a:r>
-            <a:endParaRPr lang="en-US" sz="850" dirty="0">
-              <a:latin typeface="Candara" panose="020E0502030303020204" pitchFamily="34" charset="0"/>
-            </a:endParaRPr>
-          </a:p>
-        </p:txBody>
-      </p:sp>
-      <p:sp>
-        <p:nvSpPr>
-          <p:cNvPr id="174" name="Text 172"/>
-          <p:cNvSpPr/>
-          <p:nvPr/>
-        </p:nvSpPr>
-        <p:spPr>
-          <a:xfrm>
-            <a:off x="4141153" y="5915520"/>
-            <a:ext cx="475364" cy="141695"/>
-          </a:xfrm>
-          <a:prstGeom prst="rect">
-            <a:avLst/>
-          </a:prstGeom>
-          <a:noFill/>
-          <a:ln/>
-        </p:spPr>
-        <p:txBody>
-          <a:bodyPr wrap="square" lIns="0" tIns="0" rIns="0" bIns="0" rtlCol="0" anchor="ctr"/>
-          <a:lstStyle/>
-          <a:p>
-            <a:pPr algn="r"/>
-            <a:r>
-              <a:rPr lang="en-US" sz="750" dirty="0">
-                <a:solidFill>
-                  <a:srgbClr val="4D8C6A"/>
-                </a:solidFill>
-                <a:latin typeface="Candara" panose="020E0502030303020204" pitchFamily="34" charset="0"/>
-                <a:ea typeface="Calibri" pitchFamily="34" charset="-122"/>
-                <a:cs typeface="Calibri" pitchFamily="34" charset="-120"/>
-              </a:rPr>
-              <a:t>string(100)</a:t>
-            </a:r>
-            <a:endParaRPr lang="en-US" sz="750" dirty="0">
-              <a:latin typeface="Candara" panose="020E0502030303020204" pitchFamily="34" charset="0"/>
-            </a:endParaRPr>
-          </a:p>
-        </p:txBody>
-      </p:sp>
-      <p:sp>
-        <p:nvSpPr>
-          <p:cNvPr id="175" name="Text 173"/>
-          <p:cNvSpPr/>
-          <p:nvPr/>
-        </p:nvSpPr>
-        <p:spPr>
-          <a:xfrm>
-            <a:off x="3135575" y="6057215"/>
-            <a:ext cx="1005578" cy="141695"/>
-          </a:xfrm>
-          <a:prstGeom prst="rect">
-            <a:avLst/>
-          </a:prstGeom>
-          <a:noFill/>
-          <a:ln/>
-        </p:spPr>
-        <p:txBody>
-          <a:bodyPr wrap="square" lIns="0" tIns="0" rIns="0" bIns="0" rtlCol="0" anchor="ctr"/>
-          <a:lstStyle/>
-          <a:p>
-            <a:r>
-              <a:rPr lang="en-US" sz="850" dirty="0">
-                <a:solidFill>
-                  <a:srgbClr val="FFFFFF"/>
-                </a:solidFill>
-                <a:latin typeface="Candara" panose="020E0502030303020204" pitchFamily="34" charset="0"/>
-                <a:ea typeface="Calibri" pitchFamily="34" charset="-122"/>
-                <a:cs typeface="Calibri" pitchFamily="34" charset="-120"/>
-              </a:rPr>
-              <a:t>ConfigurationValue</a:t>
-            </a:r>
-            <a:endParaRPr lang="en-US" sz="850" dirty="0">
-              <a:latin typeface="Candara" panose="020E0502030303020204" pitchFamily="34" charset="0"/>
-            </a:endParaRPr>
-          </a:p>
-        </p:txBody>
-      </p:sp>
-      <p:sp>
-        <p:nvSpPr>
-          <p:cNvPr id="176" name="Text 174"/>
-          <p:cNvSpPr/>
-          <p:nvPr/>
-        </p:nvSpPr>
-        <p:spPr>
-          <a:xfrm>
-            <a:off x="4141153" y="6057215"/>
-            <a:ext cx="475364" cy="141695"/>
-          </a:xfrm>
-          <a:prstGeom prst="rect">
-            <a:avLst/>
-          </a:prstGeom>
-          <a:noFill/>
-          <a:ln/>
-        </p:spPr>
-        <p:txBody>
-          <a:bodyPr wrap="square" lIns="0" tIns="0" rIns="0" bIns="0" rtlCol="0" anchor="ctr"/>
-          <a:lstStyle/>
-          <a:p>
-            <a:pPr algn="r"/>
-            <a:r>
-              <a:rPr lang="en-US" sz="750" dirty="0">
-                <a:solidFill>
-                  <a:srgbClr val="4D8C6A"/>
-                </a:solidFill>
-                <a:latin typeface="Candara" panose="020E0502030303020204" pitchFamily="34" charset="0"/>
-                <a:ea typeface="Calibri" pitchFamily="34" charset="-122"/>
-                <a:cs typeface="Calibri" pitchFamily="34" charset="-120"/>
-              </a:rPr>
-              <a:t>string(500)</a:t>
-            </a:r>
-            <a:endParaRPr lang="en-US" sz="750" dirty="0">
-              <a:latin typeface="Candara" panose="020E0502030303020204" pitchFamily="34" charset="0"/>
-            </a:endParaRPr>
-          </a:p>
-        </p:txBody>
-      </p:sp>
-      <p:sp>
-        <p:nvSpPr>
-          <p:cNvPr id="177" name="Shape 175"/>
-          <p:cNvSpPr/>
-          <p:nvPr/>
-        </p:nvSpPr>
-        <p:spPr>
-          <a:xfrm>
-            <a:off x="4963899" y="5147624"/>
-            <a:ext cx="2011156" cy="1133561"/>
-          </a:xfrm>
-          <a:prstGeom prst="roundRect">
-            <a:avLst>
-              <a:gd name="adj" fmla="val 6452"/>
-            </a:avLst>
-          </a:prstGeom>
-          <a:solidFill>
-            <a:srgbClr val="000000">
-              <a:alpha val="20000"/>
-            </a:srgbClr>
-          </a:solidFill>
-          <a:ln w="12700">
-            <a:solidFill>
-              <a:srgbClr val="000000"/>
-            </a:solidFill>
-            <a:prstDash val="solid"/>
-          </a:ln>
-        </p:spPr>
-        <p:txBody>
-          <a:bodyPr/>
-          <a:lstStyle/>
-          <a:p>
-            <a:endParaRPr lang="en-US" sz="1799">
-              <a:latin typeface="Candara" panose="020E0502030303020204" pitchFamily="34" charset="0"/>
-            </a:endParaRPr>
-          </a:p>
-        </p:txBody>
-      </p:sp>
-      <p:sp>
-        <p:nvSpPr>
-          <p:cNvPr id="178" name="Shape 176"/>
-          <p:cNvSpPr/>
-          <p:nvPr/>
-        </p:nvSpPr>
-        <p:spPr>
-          <a:xfrm>
-            <a:off x="4936474" y="5120199"/>
-            <a:ext cx="2011156" cy="1133561"/>
-          </a:xfrm>
-          <a:prstGeom prst="roundRect">
-            <a:avLst>
-              <a:gd name="adj" fmla="val 6452"/>
-            </a:avLst>
-          </a:prstGeom>
-          <a:solidFill>
-            <a:srgbClr val="112B1D"/>
-          </a:solidFill>
-          <a:ln w="9525">
-            <a:solidFill>
-              <a:srgbClr val="1E3D2A"/>
-            </a:solidFill>
-            <a:prstDash val="solid"/>
-          </a:ln>
-        </p:spPr>
-        <p:txBody>
-          <a:bodyPr/>
-          <a:lstStyle/>
-          <a:p>
-            <a:endParaRPr lang="en-US" sz="1799">
-              <a:latin typeface="Candara" panose="020E0502030303020204" pitchFamily="34" charset="0"/>
-            </a:endParaRPr>
-          </a:p>
-        </p:txBody>
-      </p:sp>
-      <p:sp>
-        <p:nvSpPr>
-          <p:cNvPr id="179" name="Shape 177"/>
-          <p:cNvSpPr/>
-          <p:nvPr/>
-        </p:nvSpPr>
-        <p:spPr>
-          <a:xfrm>
-            <a:off x="4936474" y="5193332"/>
-            <a:ext cx="50279" cy="987295"/>
-          </a:xfrm>
-          <a:prstGeom prst="rect">
-            <a:avLst/>
-          </a:prstGeom>
-          <a:solidFill>
-            <a:srgbClr val="1B5C3A"/>
-          </a:solidFill>
-          <a:ln w="12700">
-            <a:solidFill>
-              <a:srgbClr val="1B5C3A"/>
-            </a:solidFill>
-            <a:prstDash val="solid"/>
-          </a:ln>
-        </p:spPr>
-        <p:txBody>
-          <a:bodyPr/>
-          <a:lstStyle/>
-          <a:p>
-            <a:endParaRPr lang="en-US" sz="1799">
-              <a:latin typeface="Candara" panose="020E0502030303020204" pitchFamily="34" charset="0"/>
-            </a:endParaRPr>
-          </a:p>
-        </p:txBody>
-      </p:sp>
-      <p:sp>
-        <p:nvSpPr>
-          <p:cNvPr id="180" name="Shape 178"/>
-          <p:cNvSpPr/>
-          <p:nvPr/>
-        </p:nvSpPr>
-        <p:spPr>
-          <a:xfrm>
-            <a:off x="4936474" y="5120200"/>
-            <a:ext cx="50279" cy="164549"/>
-          </a:xfrm>
-          <a:prstGeom prst="roundRect">
-            <a:avLst>
-              <a:gd name="adj" fmla="val 72727"/>
-            </a:avLst>
-          </a:prstGeom>
-          <a:solidFill>
-            <a:srgbClr val="1B5C3A"/>
-          </a:solidFill>
-          <a:ln w="12700">
-            <a:solidFill>
-              <a:srgbClr val="1B5C3A"/>
-            </a:solidFill>
-            <a:prstDash val="solid"/>
-          </a:ln>
-        </p:spPr>
-        <p:txBody>
-          <a:bodyPr/>
-          <a:lstStyle/>
-          <a:p>
-            <a:endParaRPr lang="en-US" sz="1799">
-              <a:latin typeface="Candara" panose="020E0502030303020204" pitchFamily="34" charset="0"/>
-            </a:endParaRPr>
-          </a:p>
-        </p:txBody>
-      </p:sp>
-      <p:sp>
-        <p:nvSpPr>
-          <p:cNvPr id="181" name="Text 179"/>
-          <p:cNvSpPr/>
-          <p:nvPr/>
-        </p:nvSpPr>
-        <p:spPr>
-          <a:xfrm>
-            <a:off x="5082739" y="5138483"/>
-            <a:ext cx="1810041" cy="237682"/>
-          </a:xfrm>
-          <a:prstGeom prst="rect">
-            <a:avLst/>
-          </a:prstGeom>
-          <a:noFill/>
-          <a:ln/>
-        </p:spPr>
-        <p:txBody>
-          <a:bodyPr wrap="square" lIns="0" tIns="0" rIns="0" bIns="0" rtlCol="0" anchor="ctr"/>
-          <a:lstStyle/>
-          <a:p>
-            <a:r>
-              <a:rPr lang="en-US" sz="1100" b="1" dirty="0">
-                <a:solidFill>
-                  <a:srgbClr val="3ECF80"/>
-                </a:solidFill>
-                <a:latin typeface="Candara" panose="020E0502030303020204" pitchFamily="34" charset="0"/>
-                <a:ea typeface="Calibri" pitchFamily="34" charset="-122"/>
-                <a:cs typeface="Calibri" pitchFamily="34" charset="-120"/>
-              </a:rPr>
-              <a:t>DeviceCommands</a:t>
-            </a:r>
-            <a:endParaRPr lang="en-US" sz="1100" dirty="0">
-              <a:latin typeface="Candara" panose="020E0502030303020204" pitchFamily="34" charset="0"/>
-            </a:endParaRPr>
-          </a:p>
-        </p:txBody>
-      </p:sp>
-      <p:sp>
-        <p:nvSpPr>
-          <p:cNvPr id="182" name="Text 180"/>
-          <p:cNvSpPr/>
-          <p:nvPr/>
-        </p:nvSpPr>
-        <p:spPr>
-          <a:xfrm>
-            <a:off x="5082739" y="5412731"/>
-            <a:ext cx="1810041" cy="164549"/>
-          </a:xfrm>
-          <a:prstGeom prst="rect">
-            <a:avLst/>
-          </a:prstGeom>
-          <a:noFill/>
-          <a:ln/>
-        </p:spPr>
-        <p:txBody>
-          <a:bodyPr wrap="square" lIns="0" tIns="0" rIns="0" bIns="0" rtlCol="0" anchor="t"/>
-          <a:lstStyle/>
-          <a:p>
-            <a:r>
-              <a:rPr lang="en-US" sz="850" i="1" dirty="0">
-                <a:solidFill>
-                  <a:srgbClr val="7AB896"/>
-                </a:solidFill>
-                <a:latin typeface="Candara" panose="020E0502030303020204" pitchFamily="34" charset="0"/>
-                <a:ea typeface="Calibri" pitchFamily="34" charset="-122"/>
-                <a:cs typeface="Calibri" pitchFamily="34" charset="-120"/>
-              </a:rPr>
-              <a:t>Commands sent to device / actuator</a:t>
-            </a:r>
-            <a:endParaRPr lang="en-US" sz="850" dirty="0">
-              <a:latin typeface="Candara" panose="020E0502030303020204" pitchFamily="34" charset="0"/>
-            </a:endParaRPr>
-          </a:p>
-        </p:txBody>
-      </p:sp>
-      <p:sp>
-        <p:nvSpPr>
-          <p:cNvPr id="183" name="Shape 181"/>
-          <p:cNvSpPr/>
-          <p:nvPr/>
-        </p:nvSpPr>
-        <p:spPr>
-          <a:xfrm>
-            <a:off x="5064456" y="5595564"/>
-            <a:ext cx="1828324" cy="0"/>
-          </a:xfrm>
-          <a:prstGeom prst="line">
-            <a:avLst/>
-          </a:prstGeom>
-          <a:noFill/>
-          <a:ln w="9525">
-            <a:solidFill>
-              <a:srgbClr val="1E3D2A"/>
-            </a:solidFill>
-            <a:prstDash val="solid"/>
-          </a:ln>
-        </p:spPr>
-        <p:txBody>
-          <a:bodyPr/>
-          <a:lstStyle/>
-          <a:p>
-            <a:endParaRPr lang="en-US" sz="1799">
-              <a:latin typeface="Candara" panose="020E0502030303020204" pitchFamily="34" charset="0"/>
-            </a:endParaRPr>
-          </a:p>
-        </p:txBody>
-      </p:sp>
-      <p:sp>
-        <p:nvSpPr>
-          <p:cNvPr id="184" name="Text 182"/>
-          <p:cNvSpPr/>
-          <p:nvPr/>
-        </p:nvSpPr>
-        <p:spPr>
-          <a:xfrm>
-            <a:off x="5082739" y="5632130"/>
-            <a:ext cx="274249" cy="141695"/>
-          </a:xfrm>
-          <a:prstGeom prst="rect">
-            <a:avLst/>
-          </a:prstGeom>
-          <a:noFill/>
-          <a:ln/>
-        </p:spPr>
-        <p:txBody>
-          <a:bodyPr wrap="square" lIns="0" tIns="0" rIns="0" bIns="0" rtlCol="0" anchor="ctr"/>
-          <a:lstStyle/>
-          <a:p>
-            <a:r>
-              <a:rPr lang="en-US" sz="700" b="1" dirty="0">
-                <a:solidFill>
-                  <a:srgbClr val="F6C90E"/>
-                </a:solidFill>
-                <a:latin typeface="Candara" panose="020E0502030303020204" pitchFamily="34" charset="0"/>
-                <a:ea typeface="Calibri" pitchFamily="34" charset="-122"/>
-                <a:cs typeface="Calibri" pitchFamily="34" charset="-120"/>
-              </a:rPr>
-              <a:t>PK</a:t>
-            </a:r>
-            <a:endParaRPr lang="en-US" sz="700" dirty="0">
-              <a:latin typeface="Candara" panose="020E0502030303020204" pitchFamily="34" charset="0"/>
-            </a:endParaRPr>
-          </a:p>
-        </p:txBody>
-      </p:sp>
-      <p:sp>
-        <p:nvSpPr>
-          <p:cNvPr id="185" name="Text 183"/>
-          <p:cNvSpPr/>
-          <p:nvPr/>
-        </p:nvSpPr>
-        <p:spPr>
-          <a:xfrm>
-            <a:off x="5375271" y="5632130"/>
-            <a:ext cx="1005578" cy="141695"/>
-          </a:xfrm>
-          <a:prstGeom prst="rect">
-            <a:avLst/>
-          </a:prstGeom>
-          <a:noFill/>
-          <a:ln/>
-        </p:spPr>
-        <p:txBody>
-          <a:bodyPr wrap="square" lIns="0" tIns="0" rIns="0" bIns="0" rtlCol="0" anchor="ctr"/>
-          <a:lstStyle/>
-          <a:p>
-            <a:r>
-              <a:rPr lang="en-US" sz="850" b="1" dirty="0">
-                <a:solidFill>
-                  <a:srgbClr val="FFFFFF"/>
-                </a:solidFill>
-                <a:latin typeface="Candara" panose="020E0502030303020204" pitchFamily="34" charset="0"/>
-                <a:ea typeface="Calibri" pitchFamily="34" charset="-122"/>
-                <a:cs typeface="Calibri" pitchFamily="34" charset="-120"/>
-              </a:rPr>
-              <a:t>CommandId</a:t>
-            </a:r>
-            <a:endParaRPr lang="en-US" sz="850" dirty="0">
-              <a:latin typeface="Candara" panose="020E0502030303020204" pitchFamily="34" charset="0"/>
-            </a:endParaRPr>
-          </a:p>
-        </p:txBody>
-      </p:sp>
-      <p:sp>
-        <p:nvSpPr>
-          <p:cNvPr id="186" name="Text 184"/>
-          <p:cNvSpPr/>
-          <p:nvPr/>
-        </p:nvSpPr>
-        <p:spPr>
-          <a:xfrm>
-            <a:off x="6380849" y="5632130"/>
-            <a:ext cx="475364" cy="141695"/>
-          </a:xfrm>
-          <a:prstGeom prst="rect">
-            <a:avLst/>
-          </a:prstGeom>
-          <a:noFill/>
-          <a:ln/>
-        </p:spPr>
-        <p:txBody>
-          <a:bodyPr wrap="square" lIns="0" tIns="0" rIns="0" bIns="0" rtlCol="0" anchor="ctr"/>
-          <a:lstStyle/>
-          <a:p>
-            <a:pPr algn="r"/>
-            <a:r>
-              <a:rPr lang="en-US" sz="750" dirty="0">
-                <a:solidFill>
-                  <a:srgbClr val="4D8C6A"/>
-                </a:solidFill>
-                <a:latin typeface="Candara" panose="020E0502030303020204" pitchFamily="34" charset="0"/>
-                <a:ea typeface="Calibri" pitchFamily="34" charset="-122"/>
-                <a:cs typeface="Calibri" pitchFamily="34" charset="-120"/>
-              </a:rPr>
-              <a:t>long</a:t>
-            </a:r>
-            <a:endParaRPr lang="en-US" sz="750" dirty="0">
-              <a:latin typeface="Candara" panose="020E0502030303020204" pitchFamily="34" charset="0"/>
-            </a:endParaRPr>
-          </a:p>
-        </p:txBody>
-      </p:sp>
-      <p:sp>
-        <p:nvSpPr>
-          <p:cNvPr id="187" name="Text 185"/>
-          <p:cNvSpPr/>
-          <p:nvPr/>
-        </p:nvSpPr>
-        <p:spPr>
-          <a:xfrm>
-            <a:off x="5082739" y="5773825"/>
-            <a:ext cx="274249" cy="141695"/>
-          </a:xfrm>
-          <a:prstGeom prst="rect">
-            <a:avLst/>
-          </a:prstGeom>
-          <a:noFill/>
-          <a:ln/>
-        </p:spPr>
-        <p:txBody>
-          <a:bodyPr wrap="square" lIns="0" tIns="0" rIns="0" bIns="0" rtlCol="0" anchor="ctr"/>
-          <a:lstStyle/>
-          <a:p>
-            <a:r>
-              <a:rPr lang="en-US" sz="700" b="1" dirty="0">
-                <a:solidFill>
-                  <a:srgbClr val="60B8FF"/>
-                </a:solidFill>
-                <a:latin typeface="Candara" panose="020E0502030303020204" pitchFamily="34" charset="0"/>
-                <a:ea typeface="Calibri" pitchFamily="34" charset="-122"/>
-                <a:cs typeface="Calibri" pitchFamily="34" charset="-120"/>
-              </a:rPr>
-              <a:t>FK</a:t>
-            </a:r>
-            <a:endParaRPr lang="en-US" sz="700" dirty="0">
-              <a:latin typeface="Candara" panose="020E0502030303020204" pitchFamily="34" charset="0"/>
-            </a:endParaRPr>
-          </a:p>
-        </p:txBody>
-      </p:sp>
-      <p:sp>
-        <p:nvSpPr>
-          <p:cNvPr id="188" name="Text 186"/>
-          <p:cNvSpPr/>
-          <p:nvPr/>
-        </p:nvSpPr>
-        <p:spPr>
-          <a:xfrm>
-            <a:off x="5375271" y="5773825"/>
-            <a:ext cx="1005578" cy="141695"/>
-          </a:xfrm>
-          <a:prstGeom prst="rect">
-            <a:avLst/>
-          </a:prstGeom>
-          <a:noFill/>
-          <a:ln/>
-        </p:spPr>
-        <p:txBody>
-          <a:bodyPr wrap="square" lIns="0" tIns="0" rIns="0" bIns="0" rtlCol="0" anchor="ctr"/>
-          <a:lstStyle/>
-          <a:p>
-            <a:r>
-              <a:rPr lang="en-US" sz="850" i="1" dirty="0">
-                <a:solidFill>
-                  <a:srgbClr val="7AB896"/>
-                </a:solidFill>
-                <a:latin typeface="Candara" panose="020E0502030303020204" pitchFamily="34" charset="0"/>
-                <a:ea typeface="Calibri" pitchFamily="34" charset="-122"/>
-                <a:cs typeface="Calibri" pitchFamily="34" charset="-120"/>
-              </a:rPr>
-              <a:t>DeviceId</a:t>
-            </a:r>
-            <a:endParaRPr lang="en-US" sz="850" dirty="0">
-              <a:latin typeface="Candara" panose="020E0502030303020204" pitchFamily="34" charset="0"/>
-            </a:endParaRPr>
-          </a:p>
-        </p:txBody>
-      </p:sp>
-      <p:sp>
-        <p:nvSpPr>
-          <p:cNvPr id="189" name="Text 187"/>
-          <p:cNvSpPr/>
-          <p:nvPr/>
-        </p:nvSpPr>
-        <p:spPr>
-          <a:xfrm>
-            <a:off x="6380849" y="5773825"/>
-            <a:ext cx="475364" cy="141695"/>
-          </a:xfrm>
-          <a:prstGeom prst="rect">
-            <a:avLst/>
-          </a:prstGeom>
-          <a:noFill/>
-          <a:ln/>
-        </p:spPr>
-        <p:txBody>
-          <a:bodyPr wrap="square" lIns="0" tIns="0" rIns="0" bIns="0" rtlCol="0" anchor="ctr"/>
-          <a:lstStyle/>
-          <a:p>
-            <a:pPr algn="r"/>
-            <a:r>
-              <a:rPr lang="en-US" sz="750" dirty="0">
-                <a:solidFill>
-                  <a:srgbClr val="4D8C6A"/>
-                </a:solidFill>
-                <a:latin typeface="Candara" panose="020E0502030303020204" pitchFamily="34" charset="0"/>
-                <a:ea typeface="Calibri" pitchFamily="34" charset="-122"/>
-                <a:cs typeface="Calibri" pitchFamily="34" charset="-120"/>
-              </a:rPr>
-              <a:t>int</a:t>
-            </a:r>
-            <a:endParaRPr lang="en-US" sz="750" dirty="0">
-              <a:latin typeface="Candara" panose="020E0502030303020204" pitchFamily="34" charset="0"/>
-            </a:endParaRPr>
-          </a:p>
-        </p:txBody>
-      </p:sp>
-      <p:sp>
-        <p:nvSpPr>
-          <p:cNvPr id="190" name="Text 188"/>
-          <p:cNvSpPr/>
-          <p:nvPr/>
-        </p:nvSpPr>
-        <p:spPr>
-          <a:xfrm>
-            <a:off x="5082739" y="5915520"/>
-            <a:ext cx="274249" cy="141695"/>
-          </a:xfrm>
-          <a:prstGeom prst="rect">
-            <a:avLst/>
-          </a:prstGeom>
-          <a:noFill/>
-          <a:ln/>
-        </p:spPr>
-        <p:txBody>
-          <a:bodyPr wrap="square" lIns="0" tIns="0" rIns="0" bIns="0" rtlCol="0" anchor="ctr"/>
-          <a:lstStyle/>
-          <a:p>
-            <a:r>
-              <a:rPr lang="en-US" sz="700" b="1" dirty="0">
-                <a:solidFill>
-                  <a:srgbClr val="60B8FF"/>
-                </a:solidFill>
-                <a:latin typeface="Candara" panose="020E0502030303020204" pitchFamily="34" charset="0"/>
-                <a:ea typeface="Calibri" pitchFamily="34" charset="-122"/>
-                <a:cs typeface="Calibri" pitchFamily="34" charset="-120"/>
-              </a:rPr>
-              <a:t>FK?</a:t>
-            </a:r>
-            <a:endParaRPr lang="en-US" sz="700" dirty="0">
-              <a:latin typeface="Candara" panose="020E0502030303020204" pitchFamily="34" charset="0"/>
-            </a:endParaRPr>
-          </a:p>
-        </p:txBody>
-      </p:sp>
-      <p:sp>
-        <p:nvSpPr>
-          <p:cNvPr id="191" name="Text 189"/>
-          <p:cNvSpPr/>
-          <p:nvPr/>
-        </p:nvSpPr>
-        <p:spPr>
-          <a:xfrm>
-            <a:off x="5375271" y="5915520"/>
-            <a:ext cx="1005578" cy="141695"/>
-          </a:xfrm>
-          <a:prstGeom prst="rect">
-            <a:avLst/>
-          </a:prstGeom>
-          <a:noFill/>
-          <a:ln/>
-        </p:spPr>
-        <p:txBody>
-          <a:bodyPr wrap="square" lIns="0" tIns="0" rIns="0" bIns="0" rtlCol="0" anchor="ctr"/>
-          <a:lstStyle/>
-          <a:p>
-            <a:r>
-              <a:rPr lang="en-US" sz="850" i="1" dirty="0">
-                <a:solidFill>
-                  <a:srgbClr val="7AB896"/>
-                </a:solidFill>
-                <a:latin typeface="Candara" panose="020E0502030303020204" pitchFamily="34" charset="0"/>
-                <a:ea typeface="Calibri" pitchFamily="34" charset="-122"/>
-                <a:cs typeface="Calibri" pitchFamily="34" charset="-120"/>
-              </a:rPr>
-              <a:t>ActuatorId</a:t>
-            </a:r>
-            <a:endParaRPr lang="en-US" sz="850" dirty="0">
-              <a:latin typeface="Candara" panose="020E0502030303020204" pitchFamily="34" charset="0"/>
-            </a:endParaRPr>
-          </a:p>
-        </p:txBody>
-      </p:sp>
-      <p:sp>
-        <p:nvSpPr>
-          <p:cNvPr id="192" name="Text 190"/>
-          <p:cNvSpPr/>
-          <p:nvPr/>
-        </p:nvSpPr>
-        <p:spPr>
-          <a:xfrm>
-            <a:off x="6380849" y="5915520"/>
-            <a:ext cx="475364" cy="141695"/>
-          </a:xfrm>
-          <a:prstGeom prst="rect">
-            <a:avLst/>
-          </a:prstGeom>
-          <a:noFill/>
-          <a:ln/>
-        </p:spPr>
-        <p:txBody>
-          <a:bodyPr wrap="square" lIns="0" tIns="0" rIns="0" bIns="0" rtlCol="0" anchor="ctr"/>
-          <a:lstStyle/>
-          <a:p>
-            <a:pPr algn="r"/>
-            <a:r>
-              <a:rPr lang="en-US" sz="750" dirty="0">
-                <a:solidFill>
-                  <a:srgbClr val="4D8C6A"/>
-                </a:solidFill>
-                <a:latin typeface="Candara" panose="020E0502030303020204" pitchFamily="34" charset="0"/>
-                <a:ea typeface="Calibri" pitchFamily="34" charset="-122"/>
-                <a:cs typeface="Calibri" pitchFamily="34" charset="-120"/>
-              </a:rPr>
-              <a:t>int?</a:t>
-            </a:r>
-            <a:endParaRPr lang="en-US" sz="750" dirty="0">
-              <a:latin typeface="Candara" panose="020E0502030303020204" pitchFamily="34" charset="0"/>
-            </a:endParaRPr>
-          </a:p>
-        </p:txBody>
-      </p:sp>
-      <p:sp>
-        <p:nvSpPr>
-          <p:cNvPr id="193" name="Text 191"/>
-          <p:cNvSpPr/>
-          <p:nvPr/>
-        </p:nvSpPr>
-        <p:spPr>
-          <a:xfrm>
-            <a:off x="5375271" y="6057215"/>
-            <a:ext cx="1005578" cy="141695"/>
-          </a:xfrm>
-          <a:prstGeom prst="rect">
-            <a:avLst/>
-          </a:prstGeom>
-          <a:noFill/>
-          <a:ln/>
-        </p:spPr>
-        <p:txBody>
-          <a:bodyPr wrap="square" lIns="0" tIns="0" rIns="0" bIns="0" rtlCol="0" anchor="ctr"/>
-          <a:lstStyle/>
-          <a:p>
-            <a:r>
-              <a:rPr lang="en-US" sz="850" dirty="0">
-                <a:solidFill>
-                  <a:srgbClr val="FFFFFF"/>
-                </a:solidFill>
-                <a:latin typeface="Candara" panose="020E0502030303020204" pitchFamily="34" charset="0"/>
-                <a:ea typeface="Calibri" pitchFamily="34" charset="-122"/>
-                <a:cs typeface="Calibri" pitchFamily="34" charset="-120"/>
-              </a:rPr>
-              <a:t>CommandType</a:t>
-            </a:r>
-            <a:endParaRPr lang="en-US" sz="850" dirty="0">
-              <a:latin typeface="Candara" panose="020E0502030303020204" pitchFamily="34" charset="0"/>
-            </a:endParaRPr>
-          </a:p>
-        </p:txBody>
-      </p:sp>
-      <p:sp>
-        <p:nvSpPr>
-          <p:cNvPr id="194" name="Text 192"/>
-          <p:cNvSpPr/>
-          <p:nvPr/>
-        </p:nvSpPr>
-        <p:spPr>
-          <a:xfrm>
-            <a:off x="6380849" y="6057215"/>
-            <a:ext cx="475364" cy="141695"/>
-          </a:xfrm>
-          <a:prstGeom prst="rect">
-            <a:avLst/>
-          </a:prstGeom>
-          <a:noFill/>
-          <a:ln/>
-        </p:spPr>
-        <p:txBody>
-          <a:bodyPr wrap="square" lIns="0" tIns="0" rIns="0" bIns="0" rtlCol="0" anchor="ctr"/>
-          <a:lstStyle/>
-          <a:p>
-            <a:pPr algn="r"/>
-            <a:r>
-              <a:rPr lang="en-US" sz="750" dirty="0">
-                <a:solidFill>
-                  <a:srgbClr val="4D8C6A"/>
-                </a:solidFill>
-                <a:latin typeface="Candara" panose="020E0502030303020204" pitchFamily="34" charset="0"/>
-                <a:ea typeface="Calibri" pitchFamily="34" charset="-122"/>
-                <a:cs typeface="Calibri" pitchFamily="34" charset="-120"/>
-              </a:rPr>
-              <a:t>string(50)</a:t>
-            </a:r>
-            <a:endParaRPr lang="en-US" sz="750" dirty="0">
-              <a:latin typeface="Candara" panose="020E0502030303020204" pitchFamily="34" charset="0"/>
-            </a:endParaRPr>
-          </a:p>
-        </p:txBody>
-      </p:sp>
-      <p:sp>
-        <p:nvSpPr>
-          <p:cNvPr id="195" name="Shape 193"/>
-          <p:cNvSpPr/>
-          <p:nvPr/>
-        </p:nvSpPr>
-        <p:spPr>
-          <a:xfrm>
-            <a:off x="7157887" y="5147624"/>
-            <a:ext cx="2011156" cy="1133561"/>
-          </a:xfrm>
-          <a:prstGeom prst="roundRect">
-            <a:avLst>
-              <a:gd name="adj" fmla="val 6452"/>
-            </a:avLst>
-          </a:prstGeom>
-          <a:solidFill>
-            <a:srgbClr val="000000">
-              <a:alpha val="20000"/>
-            </a:srgbClr>
-          </a:solidFill>
-          <a:ln w="12700">
-            <a:solidFill>
-              <a:srgbClr val="000000"/>
-            </a:solidFill>
-            <a:prstDash val="solid"/>
-          </a:ln>
-        </p:spPr>
-        <p:txBody>
-          <a:bodyPr/>
-          <a:lstStyle/>
-          <a:p>
-            <a:endParaRPr lang="en-US" sz="1799">
-              <a:latin typeface="Candara" panose="020E0502030303020204" pitchFamily="34" charset="0"/>
-            </a:endParaRPr>
-          </a:p>
-        </p:txBody>
-      </p:sp>
-      <p:sp>
-        <p:nvSpPr>
-          <p:cNvPr id="196" name="Shape 194"/>
-          <p:cNvSpPr/>
-          <p:nvPr/>
-        </p:nvSpPr>
-        <p:spPr>
-          <a:xfrm>
-            <a:off x="7130462" y="5120199"/>
-            <a:ext cx="2011156" cy="1133561"/>
-          </a:xfrm>
-          <a:prstGeom prst="roundRect">
-            <a:avLst>
-              <a:gd name="adj" fmla="val 6452"/>
-            </a:avLst>
-          </a:prstGeom>
-          <a:solidFill>
-            <a:srgbClr val="112B1D"/>
-          </a:solidFill>
-          <a:ln w="9525">
-            <a:solidFill>
-              <a:srgbClr val="1E3D2A"/>
-            </a:solidFill>
-            <a:prstDash val="solid"/>
-          </a:ln>
-        </p:spPr>
-        <p:txBody>
-          <a:bodyPr/>
-          <a:lstStyle/>
-          <a:p>
-            <a:endParaRPr lang="en-US" sz="1799">
-              <a:latin typeface="Candara" panose="020E0502030303020204" pitchFamily="34" charset="0"/>
-            </a:endParaRPr>
-          </a:p>
-        </p:txBody>
-      </p:sp>
-      <p:sp>
-        <p:nvSpPr>
-          <p:cNvPr id="197" name="Shape 195"/>
-          <p:cNvSpPr/>
-          <p:nvPr/>
-        </p:nvSpPr>
-        <p:spPr>
-          <a:xfrm>
-            <a:off x="7130462" y="5193332"/>
-            <a:ext cx="50279" cy="987295"/>
-          </a:xfrm>
-          <a:prstGeom prst="rect">
-            <a:avLst/>
-          </a:prstGeom>
-          <a:solidFill>
-            <a:srgbClr val="1A3D52"/>
-          </a:solidFill>
-          <a:ln w="12700">
-            <a:solidFill>
-              <a:srgbClr val="1A3D52"/>
-            </a:solidFill>
-            <a:prstDash val="solid"/>
-          </a:ln>
-        </p:spPr>
-        <p:txBody>
-          <a:bodyPr/>
-          <a:lstStyle/>
-          <a:p>
-            <a:endParaRPr lang="en-US" sz="1799">
-              <a:latin typeface="Candara" panose="020E0502030303020204" pitchFamily="34" charset="0"/>
-            </a:endParaRPr>
-          </a:p>
-        </p:txBody>
-      </p:sp>
-      <p:sp>
-        <p:nvSpPr>
-          <p:cNvPr id="198" name="Shape 196"/>
-          <p:cNvSpPr/>
-          <p:nvPr/>
-        </p:nvSpPr>
-        <p:spPr>
-          <a:xfrm>
-            <a:off x="7130462" y="5120200"/>
-            <a:ext cx="50279" cy="164549"/>
-          </a:xfrm>
-          <a:prstGeom prst="roundRect">
-            <a:avLst>
-              <a:gd name="adj" fmla="val 72727"/>
-            </a:avLst>
-          </a:prstGeom>
-          <a:solidFill>
-            <a:srgbClr val="1A3D52"/>
-          </a:solidFill>
-          <a:ln w="12700">
-            <a:solidFill>
-              <a:srgbClr val="1A3D52"/>
-            </a:solidFill>
-            <a:prstDash val="solid"/>
-          </a:ln>
-        </p:spPr>
-        <p:txBody>
-          <a:bodyPr/>
-          <a:lstStyle/>
-          <a:p>
-            <a:endParaRPr lang="en-US" sz="1799">
-              <a:latin typeface="Candara" panose="020E0502030303020204" pitchFamily="34" charset="0"/>
-            </a:endParaRPr>
-          </a:p>
-        </p:txBody>
-      </p:sp>
-      <p:sp>
-        <p:nvSpPr>
           <p:cNvPr id="199" name="Text 197"/>
           <p:cNvSpPr/>
           <p:nvPr/>
@@ -38215,13 +36088,13 @@
       </p:sp>
       <p:sp>
         <p:nvSpPr>
-          <p:cNvPr id="219" name="Text 217"/>
-          <p:cNvSpPr/>
-          <p:nvPr/>
-        </p:nvSpPr>
-        <p:spPr>
-          <a:xfrm>
-            <a:off x="7051054" y="3391098"/>
+          <p:cNvPr id="223" name="Text 221"/>
+          <p:cNvSpPr/>
+          <p:nvPr/>
+        </p:nvSpPr>
+        <p:spPr>
+          <a:xfrm>
+            <a:off x="6964236" y="4116594"/>
             <a:ext cx="420514" cy="182832"/>
           </a:xfrm>
           <a:prstGeom prst="rect">
@@ -38260,13 +36133,13 @@
       </p:sp>
       <p:sp>
         <p:nvSpPr>
-          <p:cNvPr id="220" name="Text 218"/>
-          <p:cNvSpPr/>
-          <p:nvPr/>
-        </p:nvSpPr>
-        <p:spPr>
-          <a:xfrm>
-            <a:off x="9257593" y="2909264"/>
+          <p:cNvPr id="224" name="Text 222"/>
+          <p:cNvSpPr/>
+          <p:nvPr/>
+        </p:nvSpPr>
+        <p:spPr>
+          <a:xfrm>
+            <a:off x="9344412" y="5109086"/>
             <a:ext cx="420514" cy="182832"/>
           </a:xfrm>
           <a:prstGeom prst="rect">
@@ -38305,13 +36178,13 @@
       </p:sp>
       <p:sp>
         <p:nvSpPr>
-          <p:cNvPr id="221" name="Text 219"/>
-          <p:cNvSpPr/>
-          <p:nvPr/>
-        </p:nvSpPr>
-        <p:spPr>
-          <a:xfrm>
-            <a:off x="7011109" y="3762868"/>
+          <p:cNvPr id="227" name="Text 225"/>
+          <p:cNvSpPr/>
+          <p:nvPr/>
+        </p:nvSpPr>
+        <p:spPr>
+          <a:xfrm>
+            <a:off x="5704622" y="4125171"/>
             <a:ext cx="420514" cy="182832"/>
           </a:xfrm>
           <a:prstGeom prst="rect">
@@ -38350,13 +36223,13 @@
       </p:sp>
       <p:sp>
         <p:nvSpPr>
-          <p:cNvPr id="222" name="Text 220"/>
-          <p:cNvSpPr/>
-          <p:nvPr/>
-        </p:nvSpPr>
-        <p:spPr>
-          <a:xfrm>
-            <a:off x="9297538" y="4000152"/>
+          <p:cNvPr id="228" name="Text 226"/>
+          <p:cNvSpPr/>
+          <p:nvPr/>
+        </p:nvSpPr>
+        <p:spPr>
+          <a:xfrm>
+            <a:off x="5896092" y="4871968"/>
             <a:ext cx="420514" cy="182832"/>
           </a:xfrm>
           <a:prstGeom prst="rect">
@@ -38395,13 +36268,13 @@
       </p:sp>
       <p:sp>
         <p:nvSpPr>
-          <p:cNvPr id="223" name="Text 221"/>
-          <p:cNvSpPr/>
-          <p:nvPr/>
-        </p:nvSpPr>
-        <p:spPr>
-          <a:xfrm>
-            <a:off x="6964236" y="4116594"/>
+          <p:cNvPr id="229" name="Text 227"/>
+          <p:cNvSpPr/>
+          <p:nvPr/>
+        </p:nvSpPr>
+        <p:spPr>
+          <a:xfrm>
+            <a:off x="6426119" y="4169680"/>
             <a:ext cx="420514" cy="182832"/>
           </a:xfrm>
           <a:prstGeom prst="rect">
@@ -38430,7 +36303,7 @@
                 <a:ea typeface="Calibri" pitchFamily="34" charset="-122"/>
                 <a:cs typeface="Calibri" pitchFamily="34" charset="-120"/>
               </a:rPr>
-              <a:t>1</a:t>
+              <a:t>0..1</a:t>
             </a:r>
             <a:endParaRPr lang="en-US" sz="900" dirty="0">
               <a:latin typeface="Candara" panose="020E0502030303020204" pitchFamily="34" charset="0"/>
@@ -38440,13 +36313,13 @@
       </p:sp>
       <p:sp>
         <p:nvSpPr>
-          <p:cNvPr id="224" name="Text 222"/>
-          <p:cNvSpPr/>
-          <p:nvPr/>
-        </p:nvSpPr>
-        <p:spPr>
-          <a:xfrm>
-            <a:off x="9344412" y="5109086"/>
+          <p:cNvPr id="230" name="Text 228"/>
+          <p:cNvSpPr/>
+          <p:nvPr/>
+        </p:nvSpPr>
+        <p:spPr>
+          <a:xfrm>
+            <a:off x="7368583" y="4827459"/>
             <a:ext cx="420514" cy="182832"/>
           </a:xfrm>
           <a:prstGeom prst="rect">
@@ -38485,13 +36358,13 @@
       </p:sp>
       <p:sp>
         <p:nvSpPr>
-          <p:cNvPr id="225" name="Text 223"/>
-          <p:cNvSpPr/>
-          <p:nvPr/>
-        </p:nvSpPr>
-        <p:spPr>
-          <a:xfrm>
-            <a:off x="5053388" y="3992641"/>
+          <p:cNvPr id="231" name="Text 229"/>
+          <p:cNvSpPr/>
+          <p:nvPr/>
+        </p:nvSpPr>
+        <p:spPr>
+          <a:xfrm>
+            <a:off x="2608323" y="1662357"/>
             <a:ext cx="420514" cy="182832"/>
           </a:xfrm>
           <a:prstGeom prst="rect">
@@ -38530,13 +36403,13 @@
       </p:sp>
       <p:sp>
         <p:nvSpPr>
-          <p:cNvPr id="226" name="Text 224"/>
-          <p:cNvSpPr/>
-          <p:nvPr/>
-        </p:nvSpPr>
-        <p:spPr>
-          <a:xfrm>
-            <a:off x="4307629" y="5004498"/>
+          <p:cNvPr id="232" name="Text 230"/>
+          <p:cNvSpPr/>
+          <p:nvPr/>
+        </p:nvSpPr>
+        <p:spPr>
+          <a:xfrm>
+            <a:off x="9266639" y="1255605"/>
             <a:ext cx="420514" cy="182832"/>
           </a:xfrm>
           <a:prstGeom prst="rect">
@@ -38575,13 +36448,13 @@
       </p:sp>
       <p:sp>
         <p:nvSpPr>
-          <p:cNvPr id="227" name="Text 225"/>
-          <p:cNvSpPr/>
-          <p:nvPr/>
-        </p:nvSpPr>
-        <p:spPr>
-          <a:xfrm>
-            <a:off x="5704622" y="4125171"/>
+          <p:cNvPr id="233" name="Text 231"/>
+          <p:cNvSpPr/>
+          <p:nvPr/>
+        </p:nvSpPr>
+        <p:spPr>
+          <a:xfrm>
+            <a:off x="2427079" y="2327727"/>
             <a:ext cx="420514" cy="182832"/>
           </a:xfrm>
           <a:prstGeom prst="rect">
@@ -38610,7 +36483,7 @@
                 <a:ea typeface="Calibri" pitchFamily="34" charset="-122"/>
                 <a:cs typeface="Calibri" pitchFamily="34" charset="-120"/>
               </a:rPr>
-              <a:t>1</a:t>
+              <a:t>0..1</a:t>
             </a:r>
             <a:endParaRPr lang="en-US" sz="900" dirty="0">
               <a:latin typeface="Candara" panose="020E0502030303020204" pitchFamily="34" charset="0"/>
@@ -38620,13 +36493,13 @@
       </p:sp>
       <p:sp>
         <p:nvSpPr>
-          <p:cNvPr id="228" name="Text 226"/>
-          <p:cNvSpPr/>
-          <p:nvPr/>
-        </p:nvSpPr>
-        <p:spPr>
-          <a:xfrm>
-            <a:off x="5896092" y="4871968"/>
+          <p:cNvPr id="234" name="Text 232"/>
+          <p:cNvSpPr/>
+          <p:nvPr/>
+        </p:nvSpPr>
+        <p:spPr>
+          <a:xfrm>
+            <a:off x="6933939" y="4841088"/>
             <a:ext cx="420514" cy="182832"/>
           </a:xfrm>
           <a:prstGeom prst="rect">
@@ -38665,13 +36538,13 @@
       </p:sp>
       <p:sp>
         <p:nvSpPr>
-          <p:cNvPr id="229" name="Text 227"/>
-          <p:cNvSpPr/>
-          <p:nvPr/>
-        </p:nvSpPr>
-        <p:spPr>
-          <a:xfrm>
-            <a:off x="6426119" y="4169680"/>
+          <p:cNvPr id="235" name="Text 233"/>
+          <p:cNvSpPr/>
+          <p:nvPr/>
+        </p:nvSpPr>
+        <p:spPr>
+          <a:xfrm>
+            <a:off x="2538879" y="2225681"/>
             <a:ext cx="420514" cy="182832"/>
           </a:xfrm>
           <a:prstGeom prst="rect">
@@ -38710,13 +36583,13 @@
       </p:sp>
       <p:sp>
         <p:nvSpPr>
-          <p:cNvPr id="230" name="Text 228"/>
-          <p:cNvSpPr/>
-          <p:nvPr/>
-        </p:nvSpPr>
-        <p:spPr>
-          <a:xfrm>
-            <a:off x="7368583" y="4827459"/>
+          <p:cNvPr id="236" name="Text 234"/>
+          <p:cNvSpPr/>
+          <p:nvPr/>
+        </p:nvSpPr>
+        <p:spPr>
+          <a:xfrm>
+            <a:off x="9336083" y="5171675"/>
             <a:ext cx="420514" cy="182832"/>
           </a:xfrm>
           <a:prstGeom prst="rect">
@@ -38755,13 +36628,13 @@
       </p:sp>
       <p:sp>
         <p:nvSpPr>
-          <p:cNvPr id="231" name="Text 229"/>
-          <p:cNvSpPr/>
-          <p:nvPr/>
-        </p:nvSpPr>
-        <p:spPr>
-          <a:xfrm>
-            <a:off x="2608323" y="1662357"/>
+          <p:cNvPr id="237" name="Text 235"/>
+          <p:cNvSpPr/>
+          <p:nvPr/>
+        </p:nvSpPr>
+        <p:spPr>
+          <a:xfrm>
+            <a:off x="1316393" y="2304581"/>
             <a:ext cx="420514" cy="182832"/>
           </a:xfrm>
           <a:prstGeom prst="rect">
@@ -38790,7 +36663,7 @@
                 <a:ea typeface="Calibri" pitchFamily="34" charset="-122"/>
                 <a:cs typeface="Calibri" pitchFamily="34" charset="-120"/>
               </a:rPr>
-              <a:t>1</a:t>
+              <a:t>0..1</a:t>
             </a:r>
             <a:endParaRPr lang="en-US" sz="900" dirty="0">
               <a:latin typeface="Candara" panose="020E0502030303020204" pitchFamily="34" charset="0"/>
@@ -38800,13 +36673,13 @@
       </p:sp>
       <p:sp>
         <p:nvSpPr>
-          <p:cNvPr id="232" name="Text 230"/>
-          <p:cNvSpPr/>
-          <p:nvPr/>
-        </p:nvSpPr>
-        <p:spPr>
-          <a:xfrm>
-            <a:off x="9266639" y="1255605"/>
+          <p:cNvPr id="238" name="Text 236"/>
+          <p:cNvSpPr/>
+          <p:nvPr/>
+        </p:nvSpPr>
+        <p:spPr>
+          <a:xfrm>
+            <a:off x="1554075" y="2853078"/>
             <a:ext cx="420514" cy="182832"/>
           </a:xfrm>
           <a:prstGeom prst="rect">
@@ -38845,13 +36718,13 @@
       </p:sp>
       <p:sp>
         <p:nvSpPr>
-          <p:cNvPr id="233" name="Text 231"/>
-          <p:cNvSpPr/>
-          <p:nvPr/>
-        </p:nvSpPr>
-        <p:spPr>
-          <a:xfrm>
-            <a:off x="2427079" y="2327727"/>
+          <p:cNvPr id="239" name="Text 237"/>
+          <p:cNvSpPr/>
+          <p:nvPr/>
+        </p:nvSpPr>
+        <p:spPr>
+          <a:xfrm>
+            <a:off x="9084475" y="5820230"/>
             <a:ext cx="420514" cy="182832"/>
           </a:xfrm>
           <a:prstGeom prst="rect">
@@ -38880,7 +36753,7 @@
                 <a:ea typeface="Calibri" pitchFamily="34" charset="-122"/>
                 <a:cs typeface="Calibri" pitchFamily="34" charset="-120"/>
               </a:rPr>
-              <a:t>0..1</a:t>
+              <a:t>1</a:t>
             </a:r>
             <a:endParaRPr lang="en-US" sz="900" dirty="0">
               <a:latin typeface="Candara" panose="020E0502030303020204" pitchFamily="34" charset="0"/>
@@ -38890,13 +36763,13 @@
       </p:sp>
       <p:sp>
         <p:nvSpPr>
-          <p:cNvPr id="234" name="Text 232"/>
-          <p:cNvSpPr/>
-          <p:nvPr/>
-        </p:nvSpPr>
-        <p:spPr>
-          <a:xfrm>
-            <a:off x="6933939" y="4841088"/>
+          <p:cNvPr id="240" name="Text 238"/>
+          <p:cNvSpPr/>
+          <p:nvPr/>
+        </p:nvSpPr>
+        <p:spPr>
+          <a:xfrm>
+            <a:off x="9281036" y="5599438"/>
             <a:ext cx="420514" cy="182832"/>
           </a:xfrm>
           <a:prstGeom prst="rect">
@@ -38935,13 +36808,13 @@
       </p:sp>
       <p:sp>
         <p:nvSpPr>
-          <p:cNvPr id="235" name="Text 233"/>
-          <p:cNvSpPr/>
-          <p:nvPr/>
-        </p:nvSpPr>
-        <p:spPr>
-          <a:xfrm>
-            <a:off x="2538879" y="2225681"/>
+          <p:cNvPr id="241" name="Text 239"/>
+          <p:cNvSpPr/>
+          <p:nvPr/>
+        </p:nvSpPr>
+        <p:spPr>
+          <a:xfrm>
+            <a:off x="2539461" y="4232496"/>
             <a:ext cx="420514" cy="182832"/>
           </a:xfrm>
           <a:prstGeom prst="rect">
@@ -38971,609 +36844,6 @@
                 <a:cs typeface="Calibri" pitchFamily="34" charset="-120"/>
               </a:rPr>
               <a:t>0..1</a:t>
-            </a:r>
-            <a:endParaRPr lang="en-US" sz="900" dirty="0">
-              <a:latin typeface="Candara" panose="020E0502030303020204" pitchFamily="34" charset="0"/>
-            </a:endParaRPr>
-          </a:p>
-        </p:txBody>
-      </p:sp>
-      <p:sp>
-        <p:nvSpPr>
-          <p:cNvPr id="236" name="Text 234"/>
-          <p:cNvSpPr/>
-          <p:nvPr/>
-        </p:nvSpPr>
-        <p:spPr>
-          <a:xfrm>
-            <a:off x="9336083" y="5171675"/>
-            <a:ext cx="420514" cy="182832"/>
-          </a:xfrm>
-          <a:prstGeom prst="rect">
-            <a:avLst/>
-          </a:prstGeom>
-          <a:solidFill>
-            <a:srgbClr val="0D2117"/>
-          </a:solidFill>
-          <a:ln w="6350">
-            <a:solidFill>
-              <a:srgbClr val="2A9962"/>
-            </a:solidFill>
-          </a:ln>
-        </p:spPr>
-        <p:txBody>
-          <a:bodyPr wrap="square" lIns="0" tIns="0" rIns="0" bIns="0" rtlCol="0" anchor="ctr"/>
-          <a:lstStyle/>
-          <a:p>
-            <a:pPr algn="ctr"/>
-            <a:r>
-              <a:rPr lang="en-US" sz="900" b="1" dirty="0">
-                <a:solidFill>
-                  <a:srgbClr val="3ECF80"/>
-                </a:solidFill>
-                <a:latin typeface="Candara" panose="020E0502030303020204" pitchFamily="34" charset="0"/>
-                <a:ea typeface="Calibri" pitchFamily="34" charset="-122"/>
-                <a:cs typeface="Calibri" pitchFamily="34" charset="-120"/>
-              </a:rPr>
-              <a:t>0..*</a:t>
-            </a:r>
-            <a:endParaRPr lang="en-US" sz="900" dirty="0">
-              <a:latin typeface="Candara" panose="020E0502030303020204" pitchFamily="34" charset="0"/>
-            </a:endParaRPr>
-          </a:p>
-        </p:txBody>
-      </p:sp>
-      <p:sp>
-        <p:nvSpPr>
-          <p:cNvPr id="237" name="Text 235"/>
-          <p:cNvSpPr/>
-          <p:nvPr/>
-        </p:nvSpPr>
-        <p:spPr>
-          <a:xfrm>
-            <a:off x="1316393" y="2304581"/>
-            <a:ext cx="420514" cy="182832"/>
-          </a:xfrm>
-          <a:prstGeom prst="rect">
-            <a:avLst/>
-          </a:prstGeom>
-          <a:solidFill>
-            <a:srgbClr val="0D2117"/>
-          </a:solidFill>
-          <a:ln w="6350">
-            <a:solidFill>
-              <a:srgbClr val="2A9962"/>
-            </a:solidFill>
-          </a:ln>
-        </p:spPr>
-        <p:txBody>
-          <a:bodyPr wrap="square" lIns="0" tIns="0" rIns="0" bIns="0" rtlCol="0" anchor="ctr"/>
-          <a:lstStyle/>
-          <a:p>
-            <a:pPr algn="ctr"/>
-            <a:r>
-              <a:rPr lang="en-US" sz="900" b="1" dirty="0">
-                <a:solidFill>
-                  <a:srgbClr val="3ECF80"/>
-                </a:solidFill>
-                <a:latin typeface="Candara" panose="020E0502030303020204" pitchFamily="34" charset="0"/>
-                <a:ea typeface="Calibri" pitchFamily="34" charset="-122"/>
-                <a:cs typeface="Calibri" pitchFamily="34" charset="-120"/>
-              </a:rPr>
-              <a:t>0..1</a:t>
-            </a:r>
-            <a:endParaRPr lang="en-US" sz="900" dirty="0">
-              <a:latin typeface="Candara" panose="020E0502030303020204" pitchFamily="34" charset="0"/>
-            </a:endParaRPr>
-          </a:p>
-        </p:txBody>
-      </p:sp>
-      <p:sp>
-        <p:nvSpPr>
-          <p:cNvPr id="238" name="Text 236"/>
-          <p:cNvSpPr/>
-          <p:nvPr/>
-        </p:nvSpPr>
-        <p:spPr>
-          <a:xfrm>
-            <a:off x="1554075" y="2853078"/>
-            <a:ext cx="420514" cy="182832"/>
-          </a:xfrm>
-          <a:prstGeom prst="rect">
-            <a:avLst/>
-          </a:prstGeom>
-          <a:solidFill>
-            <a:srgbClr val="0D2117"/>
-          </a:solidFill>
-          <a:ln w="6350">
-            <a:solidFill>
-              <a:srgbClr val="2A9962"/>
-            </a:solidFill>
-          </a:ln>
-        </p:spPr>
-        <p:txBody>
-          <a:bodyPr wrap="square" lIns="0" tIns="0" rIns="0" bIns="0" rtlCol="0" anchor="ctr"/>
-          <a:lstStyle/>
-          <a:p>
-            <a:pPr algn="ctr"/>
-            <a:r>
-              <a:rPr lang="en-US" sz="900" b="1" dirty="0">
-                <a:solidFill>
-                  <a:srgbClr val="3ECF80"/>
-                </a:solidFill>
-                <a:latin typeface="Candara" panose="020E0502030303020204" pitchFamily="34" charset="0"/>
-                <a:ea typeface="Calibri" pitchFamily="34" charset="-122"/>
-                <a:cs typeface="Calibri" pitchFamily="34" charset="-120"/>
-              </a:rPr>
-              <a:t>0..*</a:t>
-            </a:r>
-            <a:endParaRPr lang="en-US" sz="900" dirty="0">
-              <a:latin typeface="Candara" panose="020E0502030303020204" pitchFamily="34" charset="0"/>
-            </a:endParaRPr>
-          </a:p>
-        </p:txBody>
-      </p:sp>
-      <p:sp>
-        <p:nvSpPr>
-          <p:cNvPr id="239" name="Text 237"/>
-          <p:cNvSpPr/>
-          <p:nvPr/>
-        </p:nvSpPr>
-        <p:spPr>
-          <a:xfrm>
-            <a:off x="9084475" y="5820230"/>
-            <a:ext cx="420514" cy="182832"/>
-          </a:xfrm>
-          <a:prstGeom prst="rect">
-            <a:avLst/>
-          </a:prstGeom>
-          <a:solidFill>
-            <a:srgbClr val="0D2117"/>
-          </a:solidFill>
-          <a:ln w="6350">
-            <a:solidFill>
-              <a:srgbClr val="2A9962"/>
-            </a:solidFill>
-          </a:ln>
-        </p:spPr>
-        <p:txBody>
-          <a:bodyPr wrap="square" lIns="0" tIns="0" rIns="0" bIns="0" rtlCol="0" anchor="ctr"/>
-          <a:lstStyle/>
-          <a:p>
-            <a:pPr algn="ctr"/>
-            <a:r>
-              <a:rPr lang="en-US" sz="900" b="1" dirty="0">
-                <a:solidFill>
-                  <a:srgbClr val="3ECF80"/>
-                </a:solidFill>
-                <a:latin typeface="Candara" panose="020E0502030303020204" pitchFamily="34" charset="0"/>
-                <a:ea typeface="Calibri" pitchFamily="34" charset="-122"/>
-                <a:cs typeface="Calibri" pitchFamily="34" charset="-120"/>
-              </a:rPr>
-              <a:t>1</a:t>
-            </a:r>
-            <a:endParaRPr lang="en-US" sz="900" dirty="0">
-              <a:latin typeface="Candara" panose="020E0502030303020204" pitchFamily="34" charset="0"/>
-            </a:endParaRPr>
-          </a:p>
-        </p:txBody>
-      </p:sp>
-      <p:sp>
-        <p:nvSpPr>
-          <p:cNvPr id="240" name="Text 238"/>
-          <p:cNvSpPr/>
-          <p:nvPr/>
-        </p:nvSpPr>
-        <p:spPr>
-          <a:xfrm>
-            <a:off x="9281036" y="5599438"/>
-            <a:ext cx="420514" cy="182832"/>
-          </a:xfrm>
-          <a:prstGeom prst="rect">
-            <a:avLst/>
-          </a:prstGeom>
-          <a:solidFill>
-            <a:srgbClr val="0D2117"/>
-          </a:solidFill>
-          <a:ln w="6350">
-            <a:solidFill>
-              <a:srgbClr val="2A9962"/>
-            </a:solidFill>
-          </a:ln>
-        </p:spPr>
-        <p:txBody>
-          <a:bodyPr wrap="square" lIns="0" tIns="0" rIns="0" bIns="0" rtlCol="0" anchor="ctr"/>
-          <a:lstStyle/>
-          <a:p>
-            <a:pPr algn="ctr"/>
-            <a:r>
-              <a:rPr lang="en-US" sz="900" b="1" dirty="0">
-                <a:solidFill>
-                  <a:srgbClr val="3ECF80"/>
-                </a:solidFill>
-                <a:latin typeface="Candara" panose="020E0502030303020204" pitchFamily="34" charset="0"/>
-                <a:ea typeface="Calibri" pitchFamily="34" charset="-122"/>
-                <a:cs typeface="Calibri" pitchFamily="34" charset="-120"/>
-              </a:rPr>
-              <a:t>0..*</a:t>
-            </a:r>
-            <a:endParaRPr lang="en-US" sz="900" dirty="0">
-              <a:latin typeface="Candara" panose="020E0502030303020204" pitchFamily="34" charset="0"/>
-            </a:endParaRPr>
-          </a:p>
-        </p:txBody>
-      </p:sp>
-      <p:sp>
-        <p:nvSpPr>
-          <p:cNvPr id="241" name="Text 239"/>
-          <p:cNvSpPr/>
-          <p:nvPr/>
-        </p:nvSpPr>
-        <p:spPr>
-          <a:xfrm>
-            <a:off x="2539461" y="4232496"/>
-            <a:ext cx="420514" cy="182832"/>
-          </a:xfrm>
-          <a:prstGeom prst="rect">
-            <a:avLst/>
-          </a:prstGeom>
-          <a:solidFill>
-            <a:srgbClr val="0D2117"/>
-          </a:solidFill>
-          <a:ln w="6350">
-            <a:solidFill>
-              <a:srgbClr val="2A9962"/>
-            </a:solidFill>
-          </a:ln>
-        </p:spPr>
-        <p:txBody>
-          <a:bodyPr wrap="square" lIns="0" tIns="0" rIns="0" bIns="0" rtlCol="0" anchor="ctr"/>
-          <a:lstStyle/>
-          <a:p>
-            <a:pPr algn="ctr"/>
-            <a:r>
-              <a:rPr lang="en-US" sz="900" b="1" dirty="0">
-                <a:solidFill>
-                  <a:srgbClr val="3ECF80"/>
-                </a:solidFill>
-                <a:latin typeface="Candara" panose="020E0502030303020204" pitchFamily="34" charset="0"/>
-                <a:ea typeface="Calibri" pitchFamily="34" charset="-122"/>
-                <a:cs typeface="Calibri" pitchFamily="34" charset="-120"/>
-              </a:rPr>
-              <a:t>0..1</a:t>
-            </a:r>
-            <a:endParaRPr lang="en-US" sz="900" dirty="0">
-              <a:latin typeface="Candara" panose="020E0502030303020204" pitchFamily="34" charset="0"/>
-            </a:endParaRPr>
-          </a:p>
-        </p:txBody>
-      </p:sp>
-      <p:sp>
-        <p:nvSpPr>
-          <p:cNvPr id="242" name="Text 240"/>
-          <p:cNvSpPr/>
-          <p:nvPr/>
-        </p:nvSpPr>
-        <p:spPr>
-          <a:xfrm>
-            <a:off x="4627567" y="4947476"/>
-            <a:ext cx="420514" cy="182832"/>
-          </a:xfrm>
-          <a:prstGeom prst="rect">
-            <a:avLst/>
-          </a:prstGeom>
-          <a:solidFill>
-            <a:srgbClr val="0D2117"/>
-          </a:solidFill>
-          <a:ln w="6350">
-            <a:solidFill>
-              <a:srgbClr val="2A9962"/>
-            </a:solidFill>
-          </a:ln>
-        </p:spPr>
-        <p:txBody>
-          <a:bodyPr wrap="square" lIns="0" tIns="0" rIns="0" bIns="0" rtlCol="0" anchor="ctr"/>
-          <a:lstStyle/>
-          <a:p>
-            <a:pPr algn="ctr"/>
-            <a:r>
-              <a:rPr lang="en-US" sz="900" b="1" dirty="0">
-                <a:solidFill>
-                  <a:srgbClr val="3ECF80"/>
-                </a:solidFill>
-                <a:latin typeface="Candara" panose="020E0502030303020204" pitchFamily="34" charset="0"/>
-                <a:ea typeface="Calibri" pitchFamily="34" charset="-122"/>
-                <a:cs typeface="Calibri" pitchFamily="34" charset="-120"/>
-              </a:rPr>
-              <a:t>0..*</a:t>
-            </a:r>
-            <a:endParaRPr lang="en-US" sz="900" dirty="0">
-              <a:latin typeface="Candara" panose="020E0502030303020204" pitchFamily="34" charset="0"/>
-            </a:endParaRPr>
-          </a:p>
-        </p:txBody>
-      </p:sp>
-      <p:sp>
-        <p:nvSpPr>
-          <p:cNvPr id="243" name="Shape 241"/>
-          <p:cNvSpPr/>
-          <p:nvPr/>
-        </p:nvSpPr>
-        <p:spPr>
-          <a:xfrm>
-            <a:off x="457080" y="6619425"/>
-            <a:ext cx="50279" cy="164549"/>
-          </a:xfrm>
-          <a:prstGeom prst="rect">
-            <a:avLst/>
-          </a:prstGeom>
-          <a:solidFill>
-            <a:srgbClr val="3ECF80"/>
-          </a:solidFill>
-          <a:ln w="12700">
-            <a:solidFill>
-              <a:srgbClr val="3ECF80"/>
-            </a:solidFill>
-            <a:prstDash val="solid"/>
-          </a:ln>
-        </p:spPr>
-        <p:txBody>
-          <a:bodyPr/>
-          <a:lstStyle/>
-          <a:p>
-            <a:endParaRPr lang="en-US" sz="1799">
-              <a:latin typeface="Candara" panose="020E0502030303020204" pitchFamily="34" charset="0"/>
-            </a:endParaRPr>
-          </a:p>
-        </p:txBody>
-      </p:sp>
-      <p:sp>
-        <p:nvSpPr>
-          <p:cNvPr id="244" name="Text 242"/>
-          <p:cNvSpPr/>
-          <p:nvPr/>
-        </p:nvSpPr>
-        <p:spPr>
-          <a:xfrm>
-            <a:off x="566780" y="6601142"/>
-            <a:ext cx="1554075" cy="201116"/>
-          </a:xfrm>
-          <a:prstGeom prst="rect">
-            <a:avLst/>
-          </a:prstGeom>
-          <a:noFill/>
-          <a:ln/>
-        </p:spPr>
-        <p:txBody>
-          <a:bodyPr wrap="square" lIns="0" tIns="0" rIns="0" bIns="0" rtlCol="0" anchor="ctr"/>
-          <a:lstStyle/>
-          <a:p>
-            <a:r>
-              <a:rPr lang="en-US" sz="900" dirty="0">
-                <a:solidFill>
-                  <a:srgbClr val="7AB896"/>
-                </a:solidFill>
-                <a:latin typeface="Candara" panose="020E0502030303020204" pitchFamily="34" charset="0"/>
-                <a:ea typeface="Calibri" pitchFamily="34" charset="-122"/>
-                <a:cs typeface="Calibri" pitchFamily="34" charset="-120"/>
-              </a:rPr>
-              <a:t>Hub (Devices)</a:t>
-            </a:r>
-            <a:endParaRPr lang="en-US" sz="900" dirty="0">
-              <a:latin typeface="Candara" panose="020E0502030303020204" pitchFamily="34" charset="0"/>
-            </a:endParaRPr>
-          </a:p>
-        </p:txBody>
-      </p:sp>
-      <p:sp>
-        <p:nvSpPr>
-          <p:cNvPr id="245" name="Shape 243"/>
-          <p:cNvSpPr/>
-          <p:nvPr/>
-        </p:nvSpPr>
-        <p:spPr>
-          <a:xfrm>
-            <a:off x="2056864" y="6619425"/>
-            <a:ext cx="50279" cy="164549"/>
-          </a:xfrm>
-          <a:prstGeom prst="rect">
-            <a:avLst/>
-          </a:prstGeom>
-          <a:solidFill>
-            <a:srgbClr val="2A9962"/>
-          </a:solidFill>
-          <a:ln w="12700">
-            <a:solidFill>
-              <a:srgbClr val="2A9962"/>
-            </a:solidFill>
-            <a:prstDash val="solid"/>
-          </a:ln>
-        </p:spPr>
-        <p:txBody>
-          <a:bodyPr/>
-          <a:lstStyle/>
-          <a:p>
-            <a:endParaRPr lang="en-US" sz="1799">
-              <a:latin typeface="Candara" panose="020E0502030303020204" pitchFamily="34" charset="0"/>
-            </a:endParaRPr>
-          </a:p>
-        </p:txBody>
-      </p:sp>
-      <p:sp>
-        <p:nvSpPr>
-          <p:cNvPr id="246" name="Text 244"/>
-          <p:cNvSpPr/>
-          <p:nvPr/>
-        </p:nvSpPr>
-        <p:spPr>
-          <a:xfrm>
-            <a:off x="2166563" y="6601142"/>
-            <a:ext cx="1554075" cy="201116"/>
-          </a:xfrm>
-          <a:prstGeom prst="rect">
-            <a:avLst/>
-          </a:prstGeom>
-          <a:noFill/>
-          <a:ln/>
-        </p:spPr>
-        <p:txBody>
-          <a:bodyPr wrap="square" lIns="0" tIns="0" rIns="0" bIns="0" rtlCol="0" anchor="ctr"/>
-          <a:lstStyle/>
-          <a:p>
-            <a:r>
-              <a:rPr lang="en-US" sz="900" dirty="0">
-                <a:solidFill>
-                  <a:srgbClr val="7AB896"/>
-                </a:solidFill>
-                <a:latin typeface="Candara" panose="020E0502030303020204" pitchFamily="34" charset="0"/>
-                <a:ea typeface="Calibri" pitchFamily="34" charset="-122"/>
-                <a:cs typeface="Calibri" pitchFamily="34" charset="-120"/>
-              </a:rPr>
-              <a:t>Primary entities</a:t>
-            </a:r>
-            <a:endParaRPr lang="en-US" sz="900" dirty="0">
-              <a:latin typeface="Candara" panose="020E0502030303020204" pitchFamily="34" charset="0"/>
-            </a:endParaRPr>
-          </a:p>
-        </p:txBody>
-      </p:sp>
-      <p:sp>
-        <p:nvSpPr>
-          <p:cNvPr id="247" name="Shape 245"/>
-          <p:cNvSpPr/>
-          <p:nvPr/>
-        </p:nvSpPr>
-        <p:spPr>
-          <a:xfrm>
-            <a:off x="3793771" y="6619425"/>
-            <a:ext cx="50279" cy="164549"/>
-          </a:xfrm>
-          <a:prstGeom prst="rect">
-            <a:avLst/>
-          </a:prstGeom>
-          <a:solidFill>
-            <a:srgbClr val="1B5C3A"/>
-          </a:solidFill>
-          <a:ln w="12700">
-            <a:solidFill>
-              <a:srgbClr val="1B5C3A"/>
-            </a:solidFill>
-            <a:prstDash val="solid"/>
-          </a:ln>
-        </p:spPr>
-        <p:txBody>
-          <a:bodyPr/>
-          <a:lstStyle/>
-          <a:p>
-            <a:endParaRPr lang="en-US" sz="1799">
-              <a:latin typeface="Candara" panose="020E0502030303020204" pitchFamily="34" charset="0"/>
-            </a:endParaRPr>
-          </a:p>
-        </p:txBody>
-      </p:sp>
-      <p:sp>
-        <p:nvSpPr>
-          <p:cNvPr id="248" name="Text 246"/>
-          <p:cNvSpPr/>
-          <p:nvPr/>
-        </p:nvSpPr>
-        <p:spPr>
-          <a:xfrm>
-            <a:off x="3903471" y="6601142"/>
-            <a:ext cx="1554075" cy="201116"/>
-          </a:xfrm>
-          <a:prstGeom prst="rect">
-            <a:avLst/>
-          </a:prstGeom>
-          <a:noFill/>
-          <a:ln/>
-        </p:spPr>
-        <p:txBody>
-          <a:bodyPr wrap="square" lIns="0" tIns="0" rIns="0" bIns="0" rtlCol="0" anchor="ctr"/>
-          <a:lstStyle/>
-          <a:p>
-            <a:r>
-              <a:rPr lang="en-US" sz="900" dirty="0">
-                <a:solidFill>
-                  <a:srgbClr val="7AB896"/>
-                </a:solidFill>
-                <a:latin typeface="Candara" panose="020E0502030303020204" pitchFamily="34" charset="0"/>
-                <a:ea typeface="Calibri" pitchFamily="34" charset="-122"/>
-                <a:cs typeface="Calibri" pitchFamily="34" charset="-120"/>
-              </a:rPr>
-              <a:t>Event / log tables</a:t>
-            </a:r>
-            <a:endParaRPr lang="en-US" sz="900" dirty="0">
-              <a:latin typeface="Candara" panose="020E0502030303020204" pitchFamily="34" charset="0"/>
-            </a:endParaRPr>
-          </a:p>
-        </p:txBody>
-      </p:sp>
-      <p:sp>
-        <p:nvSpPr>
-          <p:cNvPr id="249" name="Shape 247"/>
-          <p:cNvSpPr/>
-          <p:nvPr/>
-        </p:nvSpPr>
-        <p:spPr>
-          <a:xfrm>
-            <a:off x="5667803" y="6619425"/>
-            <a:ext cx="50279" cy="164549"/>
-          </a:xfrm>
-          <a:prstGeom prst="rect">
-            <a:avLst/>
-          </a:prstGeom>
-          <a:solidFill>
-            <a:srgbClr val="1A3D52"/>
-          </a:solidFill>
-          <a:ln w="12700">
-            <a:solidFill>
-              <a:srgbClr val="1A3D52"/>
-            </a:solidFill>
-            <a:prstDash val="solid"/>
-          </a:ln>
-        </p:spPr>
-        <p:txBody>
-          <a:bodyPr/>
-          <a:lstStyle/>
-          <a:p>
-            <a:endParaRPr lang="en-US" sz="1799">
-              <a:latin typeface="Candara" panose="020E0502030303020204" pitchFamily="34" charset="0"/>
-            </a:endParaRPr>
-          </a:p>
-        </p:txBody>
-      </p:sp>
-      <p:sp>
-        <p:nvSpPr>
-          <p:cNvPr id="250" name="Text 248"/>
-          <p:cNvSpPr/>
-          <p:nvPr/>
-        </p:nvSpPr>
-        <p:spPr>
-          <a:xfrm>
-            <a:off x="5777503" y="6601142"/>
-            <a:ext cx="1554075" cy="201116"/>
-          </a:xfrm>
-          <a:prstGeom prst="rect">
-            <a:avLst/>
-          </a:prstGeom>
-          <a:noFill/>
-          <a:ln/>
-        </p:spPr>
-        <p:txBody>
-          <a:bodyPr wrap="square" lIns="0" tIns="0" rIns="0" bIns="0" rtlCol="0" anchor="ctr"/>
-          <a:lstStyle/>
-          <a:p>
-            <a:r>
-              <a:rPr lang="en-US" sz="900" dirty="0">
-                <a:solidFill>
-                  <a:srgbClr val="7AB896"/>
-                </a:solidFill>
-                <a:latin typeface="Candara" panose="020E0502030303020204" pitchFamily="34" charset="0"/>
-                <a:ea typeface="Calibri" pitchFamily="34" charset="-122"/>
-                <a:cs typeface="Calibri" pitchFamily="34" charset="-120"/>
-              </a:rPr>
-              <a:t>Configuration</a:t>
             </a:r>
             <a:endParaRPr lang="en-US" sz="900" dirty="0">
               <a:latin typeface="Candara" panose="020E0502030303020204" pitchFamily="34" charset="0"/>

</xml_diff>